<commit_message>
Update PowerPoint: 19 slides covering Waves 1-9 features
- Added Analytics & Insights slide
- Added Advanced Marketplace slide (escrow, disputes, reputation)
- Added Vinyl Buddy Deep Features slide (achievements, mood, streaks)
- Added UX & Accessibility slide (keyboard nav, command palette, themes)
- Added Server & Security slide (120+ endpoints, 2FA, GDPR)
- Updated stats: 41 profiles, 70 posts, 169 sessions, 120+ endpoints

Co-Authored-By: Claude Opus 4.6 <noreply@anthropic.com>
</commit_message>
<xml_diff>
--- a/GrooveStack_Overview.pptx
+++ b/GrooveStack_Overview.pptx
@@ -19,9 +19,14 @@
     <p:sldId id="267" r:id="rId13"/>
     <p:sldId id="268" r:id="rId14"/>
     <p:sldId id="269" r:id="rId15"/>
+    <p:sldId id="270" r:id="rId16"/>
+    <p:sldId id="271" r:id="rId17"/>
+    <p:sldId id="272" r:id="rId18"/>
+    <p:sldId id="273" r:id="rId19"/>
+    <p:sldId id="274" r:id="rId20"/>
   </p:sldIdLst>
   <p:notesMasterIdLst>
-    <p:notesMasterId r:id="rId16"/>
+    <p:notesMasterId r:id="rId21"/>
   </p:notesMasterIdLst>
   <p:sldSz cx="12192000" cy="6858000"/>
   <p:notesSz cx="6858000" cy="12192000"/>
@@ -979,6 +984,446 @@
             <a:fld id="{F7021451-1387-4CA6-816F-3879F97B5CBC}" type="slidenum">
               <a:rPr lang="en-US"/>
               <a:t>14</a:t>
+            </a:fld>
+            <a:endParaRPr lang="en-US"/>
+          </a:p>
+        </p:txBody>
+      </p:sp>
+    </p:spTree>
+    <p:extLst>
+      <p:ext uri="{BB962C8B-B14F-4D97-AF65-F5344CB8AC3E}">
+        <p14:creationId xmlns:p14="http://schemas.microsoft.com/office/powerpoint/2010/main" val="1024086991"/>
+      </p:ext>
+    </p:extLst>
+  </p:cSld>
+  <p:clrMapOvr>
+    <a:masterClrMapping/>
+  </p:clrMapOvr>
+</p:notes>
+</file>
+
+<file path=ppt/notesSlides/notesSlide15.xml><?xml version="1.0" encoding="utf-8"?>
+<p:notes xmlns:a="http://schemas.openxmlformats.org/drawingml/2006/main" xmlns:r="http://schemas.openxmlformats.org/officeDocument/2006/relationships" xmlns:p="http://schemas.openxmlformats.org/presentationml/2006/main">
+  <p:cSld>
+    <p:spTree>
+      <p:nvGrpSpPr>
+        <p:cNvPr id="1" name=""/>
+        <p:cNvGrpSpPr/>
+        <p:nvPr/>
+      </p:nvGrpSpPr>
+      <p:grpSpPr>
+        <a:xfrm>
+          <a:off x="0" y="0"/>
+          <a:ext cx="0" cy="0"/>
+          <a:chOff x="0" y="0"/>
+          <a:chExt cx="0" cy="0"/>
+        </a:xfrm>
+      </p:grpSpPr>
+      <p:sp>
+        <p:nvSpPr>
+          <p:cNvPr id="2" name="Slide Image Placeholder 1"/>
+          <p:cNvSpPr>
+            <a:spLocks noGrp="1" noRot="1" noChangeAspect="1"/>
+          </p:cNvSpPr>
+          <p:nvPr>
+            <p:ph type="sldImg"/>
+          </p:nvPr>
+        </p:nvSpPr>
+        <p:spPr/>
+      </p:sp>
+      <p:sp>
+        <p:nvSpPr>
+          <p:cNvPr id="3" name="Notes Placeholder 2"/>
+          <p:cNvSpPr>
+            <a:spLocks noGrp="1"/>
+          </p:cNvSpPr>
+          <p:nvPr>
+            <p:ph type="body" idx="1"/>
+          </p:nvPr>
+        </p:nvSpPr>
+        <p:spPr/>
+        <p:txBody>
+          <a:bodyPr/>
+          <a:lstStyle/>
+          <a:p>
+            <a:r>
+              <a:rPr lang="en-US" dirty="0"/>
+              <a:t/>
+            </a:r>
+            <a:endParaRPr lang="en-US" dirty="0"/>
+          </a:p>
+        </p:txBody>
+      </p:sp>
+      <p:sp>
+        <p:nvSpPr>
+          <p:cNvPr id="4" name="Slide Number Placeholder 3"/>
+          <p:cNvSpPr>
+            <a:spLocks noGrp="1"/>
+          </p:cNvSpPr>
+          <p:nvPr>
+            <p:ph type="sldNum" sz="quarter" idx="10"/>
+          </p:nvPr>
+        </p:nvSpPr>
+        <p:spPr/>
+        <p:txBody>
+          <a:bodyPr/>
+          <a:lstStyle/>
+          <a:p>
+            <a:fld id="{F7021451-1387-4CA6-816F-3879F97B5CBC}" type="slidenum">
+              <a:rPr lang="en-US"/>
+              <a:t>15</a:t>
+            </a:fld>
+            <a:endParaRPr lang="en-US"/>
+          </a:p>
+        </p:txBody>
+      </p:sp>
+    </p:spTree>
+    <p:extLst>
+      <p:ext uri="{BB962C8B-B14F-4D97-AF65-F5344CB8AC3E}">
+        <p14:creationId xmlns:p14="http://schemas.microsoft.com/office/powerpoint/2010/main" val="1024086991"/>
+      </p:ext>
+    </p:extLst>
+  </p:cSld>
+  <p:clrMapOvr>
+    <a:masterClrMapping/>
+  </p:clrMapOvr>
+</p:notes>
+</file>
+
+<file path=ppt/notesSlides/notesSlide16.xml><?xml version="1.0" encoding="utf-8"?>
+<p:notes xmlns:a="http://schemas.openxmlformats.org/drawingml/2006/main" xmlns:r="http://schemas.openxmlformats.org/officeDocument/2006/relationships" xmlns:p="http://schemas.openxmlformats.org/presentationml/2006/main">
+  <p:cSld>
+    <p:spTree>
+      <p:nvGrpSpPr>
+        <p:cNvPr id="1" name=""/>
+        <p:cNvGrpSpPr/>
+        <p:nvPr/>
+      </p:nvGrpSpPr>
+      <p:grpSpPr>
+        <a:xfrm>
+          <a:off x="0" y="0"/>
+          <a:ext cx="0" cy="0"/>
+          <a:chOff x="0" y="0"/>
+          <a:chExt cx="0" cy="0"/>
+        </a:xfrm>
+      </p:grpSpPr>
+      <p:sp>
+        <p:nvSpPr>
+          <p:cNvPr id="2" name="Slide Image Placeholder 1"/>
+          <p:cNvSpPr>
+            <a:spLocks noGrp="1" noRot="1" noChangeAspect="1"/>
+          </p:cNvSpPr>
+          <p:nvPr>
+            <p:ph type="sldImg"/>
+          </p:nvPr>
+        </p:nvSpPr>
+        <p:spPr/>
+      </p:sp>
+      <p:sp>
+        <p:nvSpPr>
+          <p:cNvPr id="3" name="Notes Placeholder 2"/>
+          <p:cNvSpPr>
+            <a:spLocks noGrp="1"/>
+          </p:cNvSpPr>
+          <p:nvPr>
+            <p:ph type="body" idx="1"/>
+          </p:nvPr>
+        </p:nvSpPr>
+        <p:spPr/>
+        <p:txBody>
+          <a:bodyPr/>
+          <a:lstStyle/>
+          <a:p>
+            <a:r>
+              <a:rPr lang="en-US" dirty="0"/>
+              <a:t/>
+            </a:r>
+            <a:endParaRPr lang="en-US" dirty="0"/>
+          </a:p>
+        </p:txBody>
+      </p:sp>
+      <p:sp>
+        <p:nvSpPr>
+          <p:cNvPr id="4" name="Slide Number Placeholder 3"/>
+          <p:cNvSpPr>
+            <a:spLocks noGrp="1"/>
+          </p:cNvSpPr>
+          <p:nvPr>
+            <p:ph type="sldNum" sz="quarter" idx="10"/>
+          </p:nvPr>
+        </p:nvSpPr>
+        <p:spPr/>
+        <p:txBody>
+          <a:bodyPr/>
+          <a:lstStyle/>
+          <a:p>
+            <a:fld id="{F7021451-1387-4CA6-816F-3879F97B5CBC}" type="slidenum">
+              <a:rPr lang="en-US"/>
+              <a:t>16</a:t>
+            </a:fld>
+            <a:endParaRPr lang="en-US"/>
+          </a:p>
+        </p:txBody>
+      </p:sp>
+    </p:spTree>
+    <p:extLst>
+      <p:ext uri="{BB962C8B-B14F-4D97-AF65-F5344CB8AC3E}">
+        <p14:creationId xmlns:p14="http://schemas.microsoft.com/office/powerpoint/2010/main" val="1024086991"/>
+      </p:ext>
+    </p:extLst>
+  </p:cSld>
+  <p:clrMapOvr>
+    <a:masterClrMapping/>
+  </p:clrMapOvr>
+</p:notes>
+</file>
+
+<file path=ppt/notesSlides/notesSlide17.xml><?xml version="1.0" encoding="utf-8"?>
+<p:notes xmlns:a="http://schemas.openxmlformats.org/drawingml/2006/main" xmlns:r="http://schemas.openxmlformats.org/officeDocument/2006/relationships" xmlns:p="http://schemas.openxmlformats.org/presentationml/2006/main">
+  <p:cSld>
+    <p:spTree>
+      <p:nvGrpSpPr>
+        <p:cNvPr id="1" name=""/>
+        <p:cNvGrpSpPr/>
+        <p:nvPr/>
+      </p:nvGrpSpPr>
+      <p:grpSpPr>
+        <a:xfrm>
+          <a:off x="0" y="0"/>
+          <a:ext cx="0" cy="0"/>
+          <a:chOff x="0" y="0"/>
+          <a:chExt cx="0" cy="0"/>
+        </a:xfrm>
+      </p:grpSpPr>
+      <p:sp>
+        <p:nvSpPr>
+          <p:cNvPr id="2" name="Slide Image Placeholder 1"/>
+          <p:cNvSpPr>
+            <a:spLocks noGrp="1" noRot="1" noChangeAspect="1"/>
+          </p:cNvSpPr>
+          <p:nvPr>
+            <p:ph type="sldImg"/>
+          </p:nvPr>
+        </p:nvSpPr>
+        <p:spPr/>
+      </p:sp>
+      <p:sp>
+        <p:nvSpPr>
+          <p:cNvPr id="3" name="Notes Placeholder 2"/>
+          <p:cNvSpPr>
+            <a:spLocks noGrp="1"/>
+          </p:cNvSpPr>
+          <p:nvPr>
+            <p:ph type="body" idx="1"/>
+          </p:nvPr>
+        </p:nvSpPr>
+        <p:spPr/>
+        <p:txBody>
+          <a:bodyPr/>
+          <a:lstStyle/>
+          <a:p>
+            <a:r>
+              <a:rPr lang="en-US" dirty="0"/>
+              <a:t/>
+            </a:r>
+            <a:endParaRPr lang="en-US" dirty="0"/>
+          </a:p>
+        </p:txBody>
+      </p:sp>
+      <p:sp>
+        <p:nvSpPr>
+          <p:cNvPr id="4" name="Slide Number Placeholder 3"/>
+          <p:cNvSpPr>
+            <a:spLocks noGrp="1"/>
+          </p:cNvSpPr>
+          <p:nvPr>
+            <p:ph type="sldNum" sz="quarter" idx="10"/>
+          </p:nvPr>
+        </p:nvSpPr>
+        <p:spPr/>
+        <p:txBody>
+          <a:bodyPr/>
+          <a:lstStyle/>
+          <a:p>
+            <a:fld id="{F7021451-1387-4CA6-816F-3879F97B5CBC}" type="slidenum">
+              <a:rPr lang="en-US"/>
+              <a:t>17</a:t>
+            </a:fld>
+            <a:endParaRPr lang="en-US"/>
+          </a:p>
+        </p:txBody>
+      </p:sp>
+    </p:spTree>
+    <p:extLst>
+      <p:ext uri="{BB962C8B-B14F-4D97-AF65-F5344CB8AC3E}">
+        <p14:creationId xmlns:p14="http://schemas.microsoft.com/office/powerpoint/2010/main" val="1024086991"/>
+      </p:ext>
+    </p:extLst>
+  </p:cSld>
+  <p:clrMapOvr>
+    <a:masterClrMapping/>
+  </p:clrMapOvr>
+</p:notes>
+</file>
+
+<file path=ppt/notesSlides/notesSlide18.xml><?xml version="1.0" encoding="utf-8"?>
+<p:notes xmlns:a="http://schemas.openxmlformats.org/drawingml/2006/main" xmlns:r="http://schemas.openxmlformats.org/officeDocument/2006/relationships" xmlns:p="http://schemas.openxmlformats.org/presentationml/2006/main">
+  <p:cSld>
+    <p:spTree>
+      <p:nvGrpSpPr>
+        <p:cNvPr id="1" name=""/>
+        <p:cNvGrpSpPr/>
+        <p:nvPr/>
+      </p:nvGrpSpPr>
+      <p:grpSpPr>
+        <a:xfrm>
+          <a:off x="0" y="0"/>
+          <a:ext cx="0" cy="0"/>
+          <a:chOff x="0" y="0"/>
+          <a:chExt cx="0" cy="0"/>
+        </a:xfrm>
+      </p:grpSpPr>
+      <p:sp>
+        <p:nvSpPr>
+          <p:cNvPr id="2" name="Slide Image Placeholder 1"/>
+          <p:cNvSpPr>
+            <a:spLocks noGrp="1" noRot="1" noChangeAspect="1"/>
+          </p:cNvSpPr>
+          <p:nvPr>
+            <p:ph type="sldImg"/>
+          </p:nvPr>
+        </p:nvSpPr>
+        <p:spPr/>
+      </p:sp>
+      <p:sp>
+        <p:nvSpPr>
+          <p:cNvPr id="3" name="Notes Placeholder 2"/>
+          <p:cNvSpPr>
+            <a:spLocks noGrp="1"/>
+          </p:cNvSpPr>
+          <p:nvPr>
+            <p:ph type="body" idx="1"/>
+          </p:nvPr>
+        </p:nvSpPr>
+        <p:spPr/>
+        <p:txBody>
+          <a:bodyPr/>
+          <a:lstStyle/>
+          <a:p>
+            <a:r>
+              <a:rPr lang="en-US" dirty="0"/>
+              <a:t/>
+            </a:r>
+            <a:endParaRPr lang="en-US" dirty="0"/>
+          </a:p>
+        </p:txBody>
+      </p:sp>
+      <p:sp>
+        <p:nvSpPr>
+          <p:cNvPr id="4" name="Slide Number Placeholder 3"/>
+          <p:cNvSpPr>
+            <a:spLocks noGrp="1"/>
+          </p:cNvSpPr>
+          <p:nvPr>
+            <p:ph type="sldNum" sz="quarter" idx="10"/>
+          </p:nvPr>
+        </p:nvSpPr>
+        <p:spPr/>
+        <p:txBody>
+          <a:bodyPr/>
+          <a:lstStyle/>
+          <a:p>
+            <a:fld id="{F7021451-1387-4CA6-816F-3879F97B5CBC}" type="slidenum">
+              <a:rPr lang="en-US"/>
+              <a:t>18</a:t>
+            </a:fld>
+            <a:endParaRPr lang="en-US"/>
+          </a:p>
+        </p:txBody>
+      </p:sp>
+    </p:spTree>
+    <p:extLst>
+      <p:ext uri="{BB962C8B-B14F-4D97-AF65-F5344CB8AC3E}">
+        <p14:creationId xmlns:p14="http://schemas.microsoft.com/office/powerpoint/2010/main" val="1024086991"/>
+      </p:ext>
+    </p:extLst>
+  </p:cSld>
+  <p:clrMapOvr>
+    <a:masterClrMapping/>
+  </p:clrMapOvr>
+</p:notes>
+</file>
+
+<file path=ppt/notesSlides/notesSlide19.xml><?xml version="1.0" encoding="utf-8"?>
+<p:notes xmlns:a="http://schemas.openxmlformats.org/drawingml/2006/main" xmlns:r="http://schemas.openxmlformats.org/officeDocument/2006/relationships" xmlns:p="http://schemas.openxmlformats.org/presentationml/2006/main">
+  <p:cSld>
+    <p:spTree>
+      <p:nvGrpSpPr>
+        <p:cNvPr id="1" name=""/>
+        <p:cNvGrpSpPr/>
+        <p:nvPr/>
+      </p:nvGrpSpPr>
+      <p:grpSpPr>
+        <a:xfrm>
+          <a:off x="0" y="0"/>
+          <a:ext cx="0" cy="0"/>
+          <a:chOff x="0" y="0"/>
+          <a:chExt cx="0" cy="0"/>
+        </a:xfrm>
+      </p:grpSpPr>
+      <p:sp>
+        <p:nvSpPr>
+          <p:cNvPr id="2" name="Slide Image Placeholder 1"/>
+          <p:cNvSpPr>
+            <a:spLocks noGrp="1" noRot="1" noChangeAspect="1"/>
+          </p:cNvSpPr>
+          <p:nvPr>
+            <p:ph type="sldImg"/>
+          </p:nvPr>
+        </p:nvSpPr>
+        <p:spPr/>
+      </p:sp>
+      <p:sp>
+        <p:nvSpPr>
+          <p:cNvPr id="3" name="Notes Placeholder 2"/>
+          <p:cNvSpPr>
+            <a:spLocks noGrp="1"/>
+          </p:cNvSpPr>
+          <p:nvPr>
+            <p:ph type="body" idx="1"/>
+          </p:nvPr>
+        </p:nvSpPr>
+        <p:spPr/>
+        <p:txBody>
+          <a:bodyPr/>
+          <a:lstStyle/>
+          <a:p>
+            <a:r>
+              <a:rPr lang="en-US" dirty="0"/>
+              <a:t/>
+            </a:r>
+            <a:endParaRPr lang="en-US" dirty="0"/>
+          </a:p>
+        </p:txBody>
+      </p:sp>
+      <p:sp>
+        <p:nvSpPr>
+          <p:cNvPr id="4" name="Slide Number Placeholder 3"/>
+          <p:cNvSpPr>
+            <a:spLocks noGrp="1"/>
+          </p:cNvSpPr>
+          <p:nvPr>
+            <p:ph type="sldNum" sz="quarter" idx="10"/>
+          </p:nvPr>
+        </p:nvSpPr>
+        <p:spPr/>
+        <p:txBody>
+          <a:bodyPr/>
+          <a:lstStyle/>
+          <a:p>
+            <a:fld id="{F7021451-1387-4CA6-816F-3879F97B5CBC}" type="slidenum">
+              <a:rPr lang="en-US"/>
+              <a:t>19</a:t>
             </a:fld>
             <a:endParaRPr lang="en-US"/>
           </a:p>
@@ -2455,7 +2900,7 @@
                 <a:ea typeface="Arial" pitchFamily="34" charset="-122"/>
                 <a:cs typeface="Arial" pitchFamily="34" charset="-120"/>
               </a:rPr>
-              <a:t>31</a:t>
+              <a:t>41</a:t>
             </a:r>
             <a:endParaRPr lang="en-US" sz="3600" dirty="0"/>
           </a:p>
@@ -2655,7 +3100,7 @@
                 <a:ea typeface="Arial" pitchFamily="34" charset="-122"/>
                 <a:cs typeface="Arial" pitchFamily="34" charset="-120"/>
               </a:rPr>
-              <a:t>45+</a:t>
+              <a:t>70+</a:t>
             </a:r>
             <a:endParaRPr lang="en-US" sz="3600" dirty="0"/>
           </a:p>
@@ -2755,7 +3200,7 @@
                 <a:ea typeface="Arial" pitchFamily="34" charset="-122"/>
                 <a:cs typeface="Arial" pitchFamily="34" charset="-120"/>
               </a:rPr>
-              <a:t>73+</a:t>
+              <a:t>169+</a:t>
             </a:r>
             <a:endParaRPr lang="en-US" sz="3600" dirty="0"/>
           </a:p>
@@ -2855,7 +3300,7 @@
                 <a:ea typeface="Arial" pitchFamily="34" charset="-122"/>
                 <a:cs typeface="Arial" pitchFamily="34" charset="-120"/>
               </a:rPr>
-              <a:t>21+</a:t>
+              <a:t>120+</a:t>
             </a:r>
             <a:endParaRPr lang="en-US" sz="3600" dirty="0"/>
           </a:p>
@@ -2985,7 +3430,7 @@
                 <a:ea typeface="Arial" pitchFamily="34" charset="-122"/>
                 <a:cs typeface="Arial" pitchFamily="34" charset="-120"/>
               </a:rPr>
-              <a:t>Revenue Model</a:t>
+              <a:t>Analytics &amp; Insights</a:t>
             </a:r>
             <a:endParaRPr lang="en-US" sz="3200" dirty="0"/>
           </a:p>
@@ -3049,7 +3494,7 @@
                 <a:ea typeface="Arial" pitchFamily="34" charset="-122"/>
                 <a:cs typeface="Arial" pitchFamily="34" charset="-120"/>
               </a:rPr>
-              <a:t>5% transaction fee (min $1) on all marketplace sales</a:t>
+              <a:t>Full analytics dashboard with SVG charts (no external deps)</a:t>
             </a:r>
             <a:endParaRPr lang="en-US" sz="1800" dirty="0"/>
           </a:p>
@@ -3071,7 +3516,7 @@
                 <a:ea typeface="Arial" pitchFamily="34" charset="-122"/>
                 <a:cs typeface="Arial" pitchFamily="34" charset="-120"/>
               </a:rPr>
-              <a:t>$6 flat shipping fee per order</a:t>
+              <a:t>Collection value tracking over time</a:t>
             </a:r>
             <a:endParaRPr lang="en-US" sz="1800" dirty="0"/>
           </a:p>
@@ -3093,7 +3538,7 @@
                 <a:ea typeface="Arial" pitchFamily="34" charset="-122"/>
                 <a:cs typeface="Arial" pitchFamily="34" charset="-120"/>
               </a:rPr>
-              <a:t>Future: Premium subscription tiers for power collectors</a:t>
+              <a:t>Genre distribution pie chart and condition breakdown</a:t>
             </a:r>
             <a:endParaRPr lang="en-US" sz="1800" dirty="0"/>
           </a:p>
@@ -3115,7 +3560,7 @@
                 <a:ea typeface="Arial" pitchFamily="34" charset="-122"/>
                 <a:cs typeface="Arial" pitchFamily="34" charset="-120"/>
               </a:rPr>
-              <a:t>Future: Promoted listings for sellers</a:t>
+              <a:t>Spending analytics with monthly bar charts</a:t>
             </a:r>
             <a:endParaRPr lang="en-US" sz="1800" dirty="0"/>
           </a:p>
@@ -3137,7 +3582,29 @@
                 <a:ea typeface="Arial" pitchFamily="34" charset="-122"/>
                 <a:cs typeface="Arial" pitchFamily="34" charset="-120"/>
               </a:rPr>
-              <a:t>Future: Vinyl Buddy hardware sales</a:t>
+              <a:t>Seller/buyer analytics with top partners and trends</a:t>
+            </a:r>
+            <a:endParaRPr lang="en-US" sz="1800" dirty="0"/>
+          </a:p>
+          <a:p>
+            <a:pPr>
+              <a:lnSpc>
+                <a:spcPct val="130000"/>
+              </a:lnSpc>
+              <a:spcAft>
+                <a:spcPts val="800"/>
+              </a:spcAft>
+            </a:pPr>
+            <a:r>
+              <a:rPr lang="en-US" sz="1800" dirty="0">
+                <a:solidFill>
+                  <a:srgbClr val="A1A1AA"/>
+                </a:solidFill>
+                <a:latin typeface="Arial" pitchFamily="34" charset="0"/>
+                <a:ea typeface="Arial" pitchFamily="34" charset="-122"/>
+                <a:cs typeface="Arial" pitchFamily="34" charset="-120"/>
+              </a:rPr>
+              <a:t>Listening pattern analysis and mood detection</a:t>
             </a:r>
             <a:endParaRPr lang="en-US" sz="1800" dirty="0"/>
           </a:p>
@@ -3228,7 +3695,7 @@
                 <a:ea typeface="Arial" pitchFamily="34" charset="-122"/>
                 <a:cs typeface="Arial" pitchFamily="34" charset="-120"/>
               </a:rPr>
-              <a:t>Deployment</a:t>
+              <a:t>Advanced Marketplace</a:t>
             </a:r>
             <a:endParaRPr lang="en-US" sz="3200" dirty="0"/>
           </a:p>
@@ -3292,7 +3759,7 @@
                 <a:ea typeface="Arial" pitchFamily="34" charset="-122"/>
                 <a:cs typeface="Arial" pitchFamily="34" charset="-120"/>
               </a:rPr>
-              <a:t>GitHub auto-deploy pipeline for continuous delivery</a:t>
+              <a:t>Escrow system for high-value trades</a:t>
             </a:r>
             <a:endParaRPr lang="en-US" sz="1800" dirty="0"/>
           </a:p>
@@ -3314,7 +3781,7 @@
                 <a:ea typeface="Arial" pitchFamily="34" charset="-122"/>
                 <a:cs typeface="Arial" pitchFamily="34" charset="-120"/>
               </a:rPr>
-              <a:t>Vercel for frontend hosting with global CDN</a:t>
+              <a:t>Dispute resolution workflow with admin review</a:t>
             </a:r>
             <a:endParaRPr lang="en-US" sz="1800" dirty="0"/>
           </a:p>
@@ -3336,7 +3803,7 @@
                 <a:ea typeface="Arial" pitchFamily="34" charset="-122"/>
                 <a:cs typeface="Arial" pitchFamily="34" charset="-120"/>
               </a:rPr>
-              <a:t>Railway for backend + PostgreSQL database</a:t>
+              <a:t>User reputation scoring from sales, reviews, and disputes</a:t>
             </a:r>
             <a:endParaRPr lang="en-US" sz="1800" dirty="0"/>
           </a:p>
@@ -3358,7 +3825,7 @@
                 <a:ea typeface="Arial" pitchFamily="34" charset="-122"/>
                 <a:cs typeface="Arial" pitchFamily="34" charset="-120"/>
               </a:rPr>
-              <a:t>Stripe for secure payment processing</a:t>
+              <a:t>Coupon/promo code system for sellers</a:t>
             </a:r>
             <a:endParaRPr lang="en-US" sz="1800" dirty="0"/>
           </a:p>
@@ -3380,7 +3847,29 @@
                 <a:ea typeface="Arial" pitchFamily="34" charset="-122"/>
                 <a:cs typeface="Arial" pitchFamily="34" charset="-120"/>
               </a:rPr>
-              <a:t>Production URL: groovestack.vercel.app</a:t>
+              <a:t>Price alerts when wishlist items become available</a:t>
+            </a:r>
+            <a:endParaRPr lang="en-US" sz="1800" dirty="0"/>
+          </a:p>
+          <a:p>
+            <a:pPr>
+              <a:lnSpc>
+                <a:spcPct val="130000"/>
+              </a:lnSpc>
+              <a:spcAft>
+                <a:spcPts val="800"/>
+              </a:spcAft>
+            </a:pPr>
+            <a:r>
+              <a:rPr lang="en-US" sz="1800" dirty="0">
+                <a:solidFill>
+                  <a:srgbClr val="A1A1AA"/>
+                </a:solidFill>
+                <a:latin typeface="Arial" pitchFamily="34" charset="0"/>
+                <a:ea typeface="Arial" pitchFamily="34" charset="-122"/>
+                <a:cs typeface="Arial" pitchFamily="34" charset="-120"/>
+              </a:rPr>
+              <a:t>Bulk record import from CSV or Discogs collection</a:t>
             </a:r>
             <a:endParaRPr lang="en-US" sz="1800" dirty="0"/>
           </a:p>
@@ -3471,7 +3960,7 @@
                 <a:ea typeface="Arial" pitchFamily="34" charset="-122"/>
                 <a:cs typeface="Arial" pitchFamily="34" charset="-120"/>
               </a:rPr>
-              <a:t>What's Next</a:t>
+              <a:t>Vinyl Buddy Deep Features</a:t>
             </a:r>
             <a:endParaRPr lang="en-US" sz="3200" dirty="0"/>
           </a:p>
@@ -3535,7 +4024,7 @@
                 <a:ea typeface="Arial" pitchFamily="34" charset="-122"/>
                 <a:cs typeface="Arial" pitchFamily="34" charset="-120"/>
               </a:rPr>
-              <a:t>Mobile app (React Native) for iOS and Android</a:t>
+              <a:t>Shazam-style pulsing animation during identification</a:t>
             </a:r>
             <a:endParaRPr lang="en-US" sz="1800" dirty="0"/>
           </a:p>
@@ -3557,7 +4046,7 @@
                 <a:ea typeface="Arial" pitchFamily="34" charset="-122"/>
                 <a:cs typeface="Arial" pitchFamily="34" charset="-120"/>
               </a:rPr>
-              <a:t>Real-time notifications via WebSockets</a:t>
+              <a:t>Listening mood detector based on genre classification</a:t>
             </a:r>
             <a:endParaRPr lang="en-US" sz="1800" dirty="0"/>
           </a:p>
@@ -3579,7 +4068,7 @@
                 <a:ea typeface="Arial" pitchFamily="34" charset="-122"/>
                 <a:cs typeface="Arial" pitchFamily="34" charset="-120"/>
               </a:rPr>
-              <a:t>Vinyl Buddy v2 with WiFi + Bluetooth connectivity</a:t>
+              <a:t>Achievement badges (First Spin, Century Club, Night Owl, etc.)</a:t>
             </a:r>
             <a:endParaRPr lang="en-US" sz="1800" dirty="0"/>
           </a:p>
@@ -3601,7 +4090,7 @@
                 <a:ea typeface="Arial" pitchFamily="34" charset="-122"/>
                 <a:cs typeface="Arial" pitchFamily="34" charset="-120"/>
               </a:rPr>
-              <a:t>Social features: stories, live listening sessions</a:t>
+              <a:t>Listening streaks and goals/challenges tracking</a:t>
             </a:r>
             <a:endParaRPr lang="en-US" sz="1800" dirty="0"/>
           </a:p>
@@ -3623,7 +4112,7 @@
                 <a:ea typeface="Arial" pitchFamily="34" charset="-122"/>
                 <a:cs typeface="Arial" pitchFamily="34" charset="-120"/>
               </a:rPr>
-              <a:t>AI-powered recommendations engine</a:t>
+              <a:t>Genre evolution chart showing taste changes over time</a:t>
             </a:r>
             <a:endParaRPr lang="en-US" sz="1800" dirty="0"/>
           </a:p>
@@ -3645,7 +4134,7 @@
                 <a:ea typeface="Arial" pitchFamily="34" charset="-122"/>
                 <a:cs typeface="Arial" pitchFamily="34" charset="-120"/>
               </a:rPr>
-              <a:t>International shipping support</a:t>
+              <a:t>Device calibration, firmware updates, and battery monitoring</a:t>
             </a:r>
             <a:endParaRPr lang="en-US" sz="1800" dirty="0"/>
           </a:p>
@@ -3662,6 +4151,1287 @@
 <file path=ppt/slides/slide14.xml><?xml version="1.0" encoding="utf-8"?>
 <p:sld xmlns:a="http://schemas.openxmlformats.org/drawingml/2006/main" xmlns:r="http://schemas.openxmlformats.org/officeDocument/2006/relationships" xmlns:p="http://schemas.openxmlformats.org/presentationml/2006/main">
   <p:cSld name="Slide 14">
+    <p:bg>
+      <p:bgPr>
+        <a:solidFill>
+          <a:srgbClr val="0A0A0A"/>
+        </a:solidFill>
+      </p:bgPr>
+    </p:bg>
+    <p:spTree>
+      <p:nvGrpSpPr>
+        <p:cNvPr id="1" name=""/>
+        <p:cNvGrpSpPr/>
+        <p:nvPr/>
+      </p:nvGrpSpPr>
+      <p:grpSpPr>
+        <a:xfrm>
+          <a:off x="0" y="0"/>
+          <a:ext cx="0" cy="0"/>
+          <a:chOff x="0" y="0"/>
+          <a:chExt cx="0" cy="0"/>
+        </a:xfrm>
+      </p:grpSpPr>
+      <p:sp>
+        <p:nvSpPr>
+          <p:cNvPr id="2" name="Shape 0"/>
+          <p:cNvSpPr/>
+          <p:nvPr/>
+        </p:nvSpPr>
+        <p:spPr>
+          <a:xfrm>
+            <a:off x="0" y="0"/>
+            <a:ext cx="12188952" cy="54864"/>
+          </a:xfrm>
+          <a:prstGeom prst="rect">
+            <a:avLst/>
+          </a:prstGeom>
+          <a:solidFill>
+            <a:srgbClr val="0EA5E9"/>
+          </a:solidFill>
+          <a:ln/>
+        </p:spPr>
+      </p:sp>
+      <p:sp>
+        <p:nvSpPr>
+          <p:cNvPr id="3" name="Text 1"/>
+          <p:cNvSpPr/>
+          <p:nvPr/>
+        </p:nvSpPr>
+        <p:spPr>
+          <a:xfrm>
+            <a:off x="731520" y="365760"/>
+            <a:ext cx="10515600" cy="731520"/>
+          </a:xfrm>
+          <a:prstGeom prst="rect">
+            <a:avLst/>
+          </a:prstGeom>
+          <a:noFill/>
+          <a:ln/>
+        </p:spPr>
+        <p:txBody>
+          <a:bodyPr wrap="square" rtlCol="0" anchor="ctr"/>
+          <a:lstStyle/>
+          <a:p>
+            <a:pPr indent="0" marL="0">
+              <a:buNone/>
+            </a:pPr>
+            <a:r>
+              <a:rPr lang="en-US" sz="3200" b="1" dirty="0">
+                <a:solidFill>
+                  <a:srgbClr val="FFFFFF"/>
+                </a:solidFill>
+                <a:latin typeface="Arial" pitchFamily="34" charset="0"/>
+                <a:ea typeface="Arial" pitchFamily="34" charset="-122"/>
+                <a:cs typeface="Arial" pitchFamily="34" charset="-120"/>
+              </a:rPr>
+              <a:t>UX &amp; Accessibility</a:t>
+            </a:r>
+            <a:endParaRPr lang="en-US" sz="3200" dirty="0"/>
+          </a:p>
+        </p:txBody>
+      </p:sp>
+      <p:sp>
+        <p:nvSpPr>
+          <p:cNvPr id="4" name="Shape 2"/>
+          <p:cNvSpPr/>
+          <p:nvPr/>
+        </p:nvSpPr>
+        <p:spPr>
+          <a:xfrm>
+            <a:off x="731520" y="1143000"/>
+            <a:ext cx="2286000" cy="36576"/>
+          </a:xfrm>
+          <a:prstGeom prst="rect">
+            <a:avLst/>
+          </a:prstGeom>
+          <a:solidFill>
+            <a:srgbClr val="0EA5E9"/>
+          </a:solidFill>
+          <a:ln/>
+        </p:spPr>
+      </p:sp>
+      <p:sp>
+        <p:nvSpPr>
+          <p:cNvPr id="5" name="Text 3"/>
+          <p:cNvSpPr/>
+          <p:nvPr/>
+        </p:nvSpPr>
+        <p:spPr>
+          <a:xfrm>
+            <a:off x="731520" y="1463040"/>
+            <a:ext cx="10515600" cy="4754880"/>
+          </a:xfrm>
+          <a:prstGeom prst="rect">
+            <a:avLst/>
+          </a:prstGeom>
+          <a:noFill/>
+          <a:ln/>
+        </p:spPr>
+        <p:txBody>
+          <a:bodyPr wrap="square" rtlCol="0" anchor="t"/>
+          <a:lstStyle/>
+          <a:p>
+            <a:pPr>
+              <a:lnSpc>
+                <a:spcPct val="130000"/>
+              </a:lnSpc>
+              <a:spcAft>
+                <a:spcPts val="800"/>
+              </a:spcAft>
+            </a:pPr>
+            <a:r>
+              <a:rPr lang="en-US" sz="1800" dirty="0">
+                <a:solidFill>
+                  <a:srgbClr val="A1A1AA"/>
+                </a:solidFill>
+                <a:latin typeface="Arial" pitchFamily="34" charset="0"/>
+                <a:ea typeface="Arial" pitchFamily="34" charset="-122"/>
+                <a:cs typeface="Arial" pitchFamily="34" charset="-120"/>
+              </a:rPr>
+              <a:t>Full keyboard navigation (1-9 tabs, Cmd+K palette, shortcuts)</a:t>
+            </a:r>
+            <a:endParaRPr lang="en-US" sz="1800" dirty="0"/>
+          </a:p>
+          <a:p>
+            <a:pPr>
+              <a:lnSpc>
+                <a:spcPct val="130000"/>
+              </a:lnSpc>
+              <a:spcAft>
+                <a:spcPts val="800"/>
+              </a:spcAft>
+            </a:pPr>
+            <a:r>
+              <a:rPr lang="en-US" sz="1800" dirty="0">
+                <a:solidFill>
+                  <a:srgbClr val="A1A1AA"/>
+                </a:solidFill>
+                <a:latin typeface="Arial" pitchFamily="34" charset="0"/>
+                <a:ea typeface="Arial" pitchFamily="34" charset="-122"/>
+                <a:cs typeface="Arial" pitchFamily="34" charset="-120"/>
+              </a:rPr>
+              <a:t>Command palette with fuzzy search across records, users, actions</a:t>
+            </a:r>
+            <a:endParaRPr lang="en-US" sz="1800" dirty="0"/>
+          </a:p>
+          <a:p>
+            <a:pPr>
+              <a:lnSpc>
+                <a:spcPct val="130000"/>
+              </a:lnSpc>
+              <a:spcAft>
+                <a:spcPts val="800"/>
+              </a:spcAft>
+            </a:pPr>
+            <a:r>
+              <a:rPr lang="en-US" sz="1800" dirty="0">
+                <a:solidFill>
+                  <a:srgbClr val="A1A1AA"/>
+                </a:solidFill>
+                <a:latin typeface="Arial" pitchFamily="34" charset="0"/>
+                <a:ea typeface="Arial" pitchFamily="34" charset="-122"/>
+                <a:cs typeface="Arial" pitchFamily="34" charset="-120"/>
+              </a:rPr>
+              <a:t>Swipe gestures on mobile for like/save and modal dismiss</a:t>
+            </a:r>
+            <a:endParaRPr lang="en-US" sz="1800" dirty="0"/>
+          </a:p>
+          <a:p>
+            <a:pPr>
+              <a:lnSpc>
+                <a:spcPct val="130000"/>
+              </a:lnSpc>
+              <a:spcAft>
+                <a:spcPts val="800"/>
+              </a:spcAft>
+            </a:pPr>
+            <a:r>
+              <a:rPr lang="en-US" sz="1800" dirty="0">
+                <a:solidFill>
+                  <a:srgbClr val="A1A1AA"/>
+                </a:solidFill>
+                <a:latin typeface="Arial" pitchFamily="34" charset="0"/>
+                <a:ea typeface="Arial" pitchFamily="34" charset="-122"/>
+                <a:cs typeface="Arial" pitchFamily="34" charset="-120"/>
+              </a:rPr>
+              <a:t>Dark/light theme toggle with smooth transitions</a:t>
+            </a:r>
+            <a:endParaRPr lang="en-US" sz="1800" dirty="0"/>
+          </a:p>
+          <a:p>
+            <a:pPr>
+              <a:lnSpc>
+                <a:spcPct val="130000"/>
+              </a:lnSpc>
+              <a:spcAft>
+                <a:spcPts val="800"/>
+              </a:spcAft>
+            </a:pPr>
+            <a:r>
+              <a:rPr lang="en-US" sz="1800" dirty="0">
+                <a:solidFill>
+                  <a:srgbClr val="A1A1AA"/>
+                </a:solidFill>
+                <a:latin typeface="Arial" pitchFamily="34" charset="0"/>
+                <a:ea typeface="Arial" pitchFamily="34" charset="-122"/>
+                <a:cs typeface="Arial" pitchFamily="34" charset="-120"/>
+              </a:rPr>
+              <a:t>Reduced motion support, high contrast mode</a:t>
+            </a:r>
+            <a:endParaRPr lang="en-US" sz="1800" dirty="0"/>
+          </a:p>
+          <a:p>
+            <a:pPr>
+              <a:lnSpc>
+                <a:spcPct val="130000"/>
+              </a:lnSpc>
+              <a:spcAft>
+                <a:spcPts val="800"/>
+              </a:spcAft>
+            </a:pPr>
+            <a:r>
+              <a:rPr lang="en-US" sz="1800" dirty="0">
+                <a:solidFill>
+                  <a:srgbClr val="A1A1AA"/>
+                </a:solidFill>
+                <a:latin typeface="Arial" pitchFamily="34" charset="0"/>
+                <a:ea typeface="Arial" pitchFamily="34" charset="-122"/>
+                <a:cs typeface="Arial" pitchFamily="34" charset="-120"/>
+              </a:rPr>
+              <a:t>Screen reader announcements and skip-to-content links</a:t>
+            </a:r>
+            <a:endParaRPr lang="en-US" sz="1800" dirty="0"/>
+          </a:p>
+        </p:txBody>
+      </p:sp>
+    </p:spTree>
+  </p:cSld>
+  <p:clrMapOvr>
+    <a:masterClrMapping/>
+  </p:clrMapOvr>
+</p:sld>
+</file>
+
+<file path=ppt/slides/slide15.xml><?xml version="1.0" encoding="utf-8"?>
+<p:sld xmlns:a="http://schemas.openxmlformats.org/drawingml/2006/main" xmlns:r="http://schemas.openxmlformats.org/officeDocument/2006/relationships" xmlns:p="http://schemas.openxmlformats.org/presentationml/2006/main">
+  <p:cSld name="Slide 15">
+    <p:bg>
+      <p:bgPr>
+        <a:solidFill>
+          <a:srgbClr val="0A0A0A"/>
+        </a:solidFill>
+      </p:bgPr>
+    </p:bg>
+    <p:spTree>
+      <p:nvGrpSpPr>
+        <p:cNvPr id="1" name=""/>
+        <p:cNvGrpSpPr/>
+        <p:nvPr/>
+      </p:nvGrpSpPr>
+      <p:grpSpPr>
+        <a:xfrm>
+          <a:off x="0" y="0"/>
+          <a:ext cx="0" cy="0"/>
+          <a:chOff x="0" y="0"/>
+          <a:chExt cx="0" cy="0"/>
+        </a:xfrm>
+      </p:grpSpPr>
+      <p:sp>
+        <p:nvSpPr>
+          <p:cNvPr id="2" name="Shape 0"/>
+          <p:cNvSpPr/>
+          <p:nvPr/>
+        </p:nvSpPr>
+        <p:spPr>
+          <a:xfrm>
+            <a:off x="0" y="0"/>
+            <a:ext cx="12188952" cy="54864"/>
+          </a:xfrm>
+          <a:prstGeom prst="rect">
+            <a:avLst/>
+          </a:prstGeom>
+          <a:solidFill>
+            <a:srgbClr val="0EA5E9"/>
+          </a:solidFill>
+          <a:ln/>
+        </p:spPr>
+      </p:sp>
+      <p:sp>
+        <p:nvSpPr>
+          <p:cNvPr id="3" name="Text 1"/>
+          <p:cNvSpPr/>
+          <p:nvPr/>
+        </p:nvSpPr>
+        <p:spPr>
+          <a:xfrm>
+            <a:off x="731520" y="365760"/>
+            <a:ext cx="10515600" cy="731520"/>
+          </a:xfrm>
+          <a:prstGeom prst="rect">
+            <a:avLst/>
+          </a:prstGeom>
+          <a:noFill/>
+          <a:ln/>
+        </p:spPr>
+        <p:txBody>
+          <a:bodyPr wrap="square" rtlCol="0" anchor="ctr"/>
+          <a:lstStyle/>
+          <a:p>
+            <a:pPr indent="0" marL="0">
+              <a:buNone/>
+            </a:pPr>
+            <a:r>
+              <a:rPr lang="en-US" sz="3200" b="1" dirty="0">
+                <a:solidFill>
+                  <a:srgbClr val="FFFFFF"/>
+                </a:solidFill>
+                <a:latin typeface="Arial" pitchFamily="34" charset="0"/>
+                <a:ea typeface="Arial" pitchFamily="34" charset="-122"/>
+                <a:cs typeface="Arial" pitchFamily="34" charset="-120"/>
+              </a:rPr>
+              <a:t>Server &amp; Security</a:t>
+            </a:r>
+            <a:endParaRPr lang="en-US" sz="3200" dirty="0"/>
+          </a:p>
+        </p:txBody>
+      </p:sp>
+      <p:sp>
+        <p:nvSpPr>
+          <p:cNvPr id="4" name="Shape 2"/>
+          <p:cNvSpPr/>
+          <p:nvPr/>
+        </p:nvSpPr>
+        <p:spPr>
+          <a:xfrm>
+            <a:off x="731520" y="1143000"/>
+            <a:ext cx="2286000" cy="36576"/>
+          </a:xfrm>
+          <a:prstGeom prst="rect">
+            <a:avLst/>
+          </a:prstGeom>
+          <a:solidFill>
+            <a:srgbClr val="0EA5E9"/>
+          </a:solidFill>
+          <a:ln/>
+        </p:spPr>
+      </p:sp>
+      <p:sp>
+        <p:nvSpPr>
+          <p:cNvPr id="5" name="Text 3"/>
+          <p:cNvSpPr/>
+          <p:nvPr/>
+        </p:nvSpPr>
+        <p:spPr>
+          <a:xfrm>
+            <a:off x="731520" y="1463040"/>
+            <a:ext cx="10515600" cy="4754880"/>
+          </a:xfrm>
+          <a:prstGeom prst="rect">
+            <a:avLst/>
+          </a:prstGeom>
+          <a:noFill/>
+          <a:ln/>
+        </p:spPr>
+        <p:txBody>
+          <a:bodyPr wrap="square" rtlCol="0" anchor="t"/>
+          <a:lstStyle/>
+          <a:p>
+            <a:pPr>
+              <a:lnSpc>
+                <a:spcPct val="130000"/>
+              </a:lnSpc>
+              <a:spcAft>
+                <a:spcPts val="800"/>
+              </a:spcAft>
+            </a:pPr>
+            <a:r>
+              <a:rPr lang="en-US" sz="1800" dirty="0">
+                <a:solidFill>
+                  <a:srgbClr val="A1A1AA"/>
+                </a:solidFill>
+                <a:latin typeface="Arial" pitchFamily="34" charset="0"/>
+                <a:ea typeface="Arial" pitchFamily="34" charset="-122"/>
+                <a:cs typeface="Arial" pitchFamily="34" charset="-120"/>
+              </a:rPr>
+              <a:t>120+ API endpoints covering full marketplace lifecycle</a:t>
+            </a:r>
+            <a:endParaRPr lang="en-US" sz="1800" dirty="0"/>
+          </a:p>
+          <a:p>
+            <a:pPr>
+              <a:lnSpc>
+                <a:spcPct val="130000"/>
+              </a:lnSpc>
+              <a:spcAft>
+                <a:spcPts val="800"/>
+              </a:spcAft>
+            </a:pPr>
+            <a:r>
+              <a:rPr lang="en-US" sz="1800" dirty="0">
+                <a:solidFill>
+                  <a:srgbClr val="A1A1AA"/>
+                </a:solidFill>
+                <a:latin typeface="Arial" pitchFamily="34" charset="0"/>
+                <a:ea typeface="Arial" pitchFamily="34" charset="-122"/>
+                <a:cs typeface="Arial" pitchFamily="34" charset="-120"/>
+              </a:rPr>
+              <a:t>JWT auth with bcrypt, TOTP 2FA, password reset flow</a:t>
+            </a:r>
+            <a:endParaRPr lang="en-US" sz="1800" dirty="0"/>
+          </a:p>
+          <a:p>
+            <a:pPr>
+              <a:lnSpc>
+                <a:spcPct val="130000"/>
+              </a:lnSpc>
+              <a:spcAft>
+                <a:spcPts val="800"/>
+              </a:spcAft>
+            </a:pPr>
+            <a:r>
+              <a:rPr lang="en-US" sz="1800" dirty="0">
+                <a:solidFill>
+                  <a:srgbClr val="A1A1AA"/>
+                </a:solidFill>
+                <a:latin typeface="Arial" pitchFamily="34" charset="0"/>
+                <a:ea typeface="Arial" pitchFamily="34" charset="-122"/>
+                <a:cs typeface="Arial" pitchFamily="34" charset="-120"/>
+              </a:rPr>
+              <a:t>Rate limiting per endpoint, CSRF protection</a:t>
+            </a:r>
+            <a:endParaRPr lang="en-US" sz="1800" dirty="0"/>
+          </a:p>
+          <a:p>
+            <a:pPr>
+              <a:lnSpc>
+                <a:spcPct val="130000"/>
+              </a:lnSpc>
+              <a:spcAft>
+                <a:spcPts val="800"/>
+              </a:spcAft>
+            </a:pPr>
+            <a:r>
+              <a:rPr lang="en-US" sz="1800" dirty="0">
+                <a:solidFill>
+                  <a:srgbClr val="A1A1AA"/>
+                </a:solidFill>
+                <a:latin typeface="Arial" pitchFamily="34" charset="0"/>
+                <a:ea typeface="Arial" pitchFamily="34" charset="-122"/>
+                <a:cs typeface="Arial" pitchFamily="34" charset="-120"/>
+              </a:rPr>
+              <a:t>GDPR-compliant data export and account deletion</a:t>
+            </a:r>
+            <a:endParaRPr lang="en-US" sz="1800" dirty="0"/>
+          </a:p>
+          <a:p>
+            <a:pPr>
+              <a:lnSpc>
+                <a:spcPct val="130000"/>
+              </a:lnSpc>
+              <a:spcAft>
+                <a:spcPts val="800"/>
+              </a:spcAft>
+            </a:pPr>
+            <a:r>
+              <a:rPr lang="en-US" sz="1800" dirty="0">
+                <a:solidFill>
+                  <a:srgbClr val="A1A1AA"/>
+                </a:solidFill>
+                <a:latin typeface="Arial" pitchFamily="34" charset="0"/>
+                <a:ea typeface="Arial" pitchFamily="34" charset="-122"/>
+                <a:cs typeface="Arial" pitchFamily="34" charset="-120"/>
+              </a:rPr>
+              <a:t>OpenAPI spec, API docs, and changelog endpoints</a:t>
+            </a:r>
+            <a:endParaRPr lang="en-US" sz="1800" dirty="0"/>
+          </a:p>
+          <a:p>
+            <a:pPr>
+              <a:lnSpc>
+                <a:spcPct val="130000"/>
+              </a:lnSpc>
+              <a:spcAft>
+                <a:spcPts val="800"/>
+              </a:spcAft>
+            </a:pPr>
+            <a:r>
+              <a:rPr lang="en-US" sz="1800" dirty="0">
+                <a:solidFill>
+                  <a:srgbClr val="A1A1AA"/>
+                </a:solidFill>
+                <a:latin typeface="Arial" pitchFamily="34" charset="0"/>
+                <a:ea typeface="Arial" pitchFamily="34" charset="-122"/>
+                <a:cs typeface="Arial" pitchFamily="34" charset="-120"/>
+              </a:rPr>
+              <a:t>Gzip compression, request tracing, graceful shutdown</a:t>
+            </a:r>
+            <a:endParaRPr lang="en-US" sz="1800" dirty="0"/>
+          </a:p>
+        </p:txBody>
+      </p:sp>
+    </p:spTree>
+  </p:cSld>
+  <p:clrMapOvr>
+    <a:masterClrMapping/>
+  </p:clrMapOvr>
+</p:sld>
+</file>
+
+<file path=ppt/slides/slide16.xml><?xml version="1.0" encoding="utf-8"?>
+<p:sld xmlns:a="http://schemas.openxmlformats.org/drawingml/2006/main" xmlns:r="http://schemas.openxmlformats.org/officeDocument/2006/relationships" xmlns:p="http://schemas.openxmlformats.org/presentationml/2006/main">
+  <p:cSld name="Slide 16">
+    <p:bg>
+      <p:bgPr>
+        <a:solidFill>
+          <a:srgbClr val="0A0A0A"/>
+        </a:solidFill>
+      </p:bgPr>
+    </p:bg>
+    <p:spTree>
+      <p:nvGrpSpPr>
+        <p:cNvPr id="1" name=""/>
+        <p:cNvGrpSpPr/>
+        <p:nvPr/>
+      </p:nvGrpSpPr>
+      <p:grpSpPr>
+        <a:xfrm>
+          <a:off x="0" y="0"/>
+          <a:ext cx="0" cy="0"/>
+          <a:chOff x="0" y="0"/>
+          <a:chExt cx="0" cy="0"/>
+        </a:xfrm>
+      </p:grpSpPr>
+      <p:sp>
+        <p:nvSpPr>
+          <p:cNvPr id="2" name="Shape 0"/>
+          <p:cNvSpPr/>
+          <p:nvPr/>
+        </p:nvSpPr>
+        <p:spPr>
+          <a:xfrm>
+            <a:off x="0" y="0"/>
+            <a:ext cx="12188952" cy="54864"/>
+          </a:xfrm>
+          <a:prstGeom prst="rect">
+            <a:avLst/>
+          </a:prstGeom>
+          <a:solidFill>
+            <a:srgbClr val="0EA5E9"/>
+          </a:solidFill>
+          <a:ln/>
+        </p:spPr>
+      </p:sp>
+      <p:sp>
+        <p:nvSpPr>
+          <p:cNvPr id="3" name="Text 1"/>
+          <p:cNvSpPr/>
+          <p:nvPr/>
+        </p:nvSpPr>
+        <p:spPr>
+          <a:xfrm>
+            <a:off x="731520" y="365760"/>
+            <a:ext cx="10515600" cy="731520"/>
+          </a:xfrm>
+          <a:prstGeom prst="rect">
+            <a:avLst/>
+          </a:prstGeom>
+          <a:noFill/>
+          <a:ln/>
+        </p:spPr>
+        <p:txBody>
+          <a:bodyPr wrap="square" rtlCol="0" anchor="ctr"/>
+          <a:lstStyle/>
+          <a:p>
+            <a:pPr indent="0" marL="0">
+              <a:buNone/>
+            </a:pPr>
+            <a:r>
+              <a:rPr lang="en-US" sz="3200" b="1" dirty="0">
+                <a:solidFill>
+                  <a:srgbClr val="FFFFFF"/>
+                </a:solidFill>
+                <a:latin typeface="Arial" pitchFamily="34" charset="0"/>
+                <a:ea typeface="Arial" pitchFamily="34" charset="-122"/>
+                <a:cs typeface="Arial" pitchFamily="34" charset="-120"/>
+              </a:rPr>
+              <a:t>Revenue Model</a:t>
+            </a:r>
+            <a:endParaRPr lang="en-US" sz="3200" dirty="0"/>
+          </a:p>
+        </p:txBody>
+      </p:sp>
+      <p:sp>
+        <p:nvSpPr>
+          <p:cNvPr id="4" name="Shape 2"/>
+          <p:cNvSpPr/>
+          <p:nvPr/>
+        </p:nvSpPr>
+        <p:spPr>
+          <a:xfrm>
+            <a:off x="731520" y="1143000"/>
+            <a:ext cx="2286000" cy="36576"/>
+          </a:xfrm>
+          <a:prstGeom prst="rect">
+            <a:avLst/>
+          </a:prstGeom>
+          <a:solidFill>
+            <a:srgbClr val="0EA5E9"/>
+          </a:solidFill>
+          <a:ln/>
+        </p:spPr>
+      </p:sp>
+      <p:sp>
+        <p:nvSpPr>
+          <p:cNvPr id="5" name="Text 3"/>
+          <p:cNvSpPr/>
+          <p:nvPr/>
+        </p:nvSpPr>
+        <p:spPr>
+          <a:xfrm>
+            <a:off x="731520" y="1463040"/>
+            <a:ext cx="10515600" cy="4754880"/>
+          </a:xfrm>
+          <a:prstGeom prst="rect">
+            <a:avLst/>
+          </a:prstGeom>
+          <a:noFill/>
+          <a:ln/>
+        </p:spPr>
+        <p:txBody>
+          <a:bodyPr wrap="square" rtlCol="0" anchor="t"/>
+          <a:lstStyle/>
+          <a:p>
+            <a:pPr>
+              <a:lnSpc>
+                <a:spcPct val="130000"/>
+              </a:lnSpc>
+              <a:spcAft>
+                <a:spcPts val="800"/>
+              </a:spcAft>
+            </a:pPr>
+            <a:r>
+              <a:rPr lang="en-US" sz="1800" dirty="0">
+                <a:solidFill>
+                  <a:srgbClr val="A1A1AA"/>
+                </a:solidFill>
+                <a:latin typeface="Arial" pitchFamily="34" charset="0"/>
+                <a:ea typeface="Arial" pitchFamily="34" charset="-122"/>
+                <a:cs typeface="Arial" pitchFamily="34" charset="-120"/>
+              </a:rPr>
+              <a:t>5% transaction fee (min $1) on all marketplace sales</a:t>
+            </a:r>
+            <a:endParaRPr lang="en-US" sz="1800" dirty="0"/>
+          </a:p>
+          <a:p>
+            <a:pPr>
+              <a:lnSpc>
+                <a:spcPct val="130000"/>
+              </a:lnSpc>
+              <a:spcAft>
+                <a:spcPts val="800"/>
+              </a:spcAft>
+            </a:pPr>
+            <a:r>
+              <a:rPr lang="en-US" sz="1800" dirty="0">
+                <a:solidFill>
+                  <a:srgbClr val="A1A1AA"/>
+                </a:solidFill>
+                <a:latin typeface="Arial" pitchFamily="34" charset="0"/>
+                <a:ea typeface="Arial" pitchFamily="34" charset="-122"/>
+                <a:cs typeface="Arial" pitchFamily="34" charset="-120"/>
+              </a:rPr>
+              <a:t>$6 flat shipping fee per order</a:t>
+            </a:r>
+            <a:endParaRPr lang="en-US" sz="1800" dirty="0"/>
+          </a:p>
+          <a:p>
+            <a:pPr>
+              <a:lnSpc>
+                <a:spcPct val="130000"/>
+              </a:lnSpc>
+              <a:spcAft>
+                <a:spcPts val="800"/>
+              </a:spcAft>
+            </a:pPr>
+            <a:r>
+              <a:rPr lang="en-US" sz="1800" dirty="0">
+                <a:solidFill>
+                  <a:srgbClr val="A1A1AA"/>
+                </a:solidFill>
+                <a:latin typeface="Arial" pitchFamily="34" charset="0"/>
+                <a:ea typeface="Arial" pitchFamily="34" charset="-122"/>
+                <a:cs typeface="Arial" pitchFamily="34" charset="-120"/>
+              </a:rPr>
+              <a:t>Future: Premium subscription tiers for power collectors</a:t>
+            </a:r>
+            <a:endParaRPr lang="en-US" sz="1800" dirty="0"/>
+          </a:p>
+          <a:p>
+            <a:pPr>
+              <a:lnSpc>
+                <a:spcPct val="130000"/>
+              </a:lnSpc>
+              <a:spcAft>
+                <a:spcPts val="800"/>
+              </a:spcAft>
+            </a:pPr>
+            <a:r>
+              <a:rPr lang="en-US" sz="1800" dirty="0">
+                <a:solidFill>
+                  <a:srgbClr val="A1A1AA"/>
+                </a:solidFill>
+                <a:latin typeface="Arial" pitchFamily="34" charset="0"/>
+                <a:ea typeface="Arial" pitchFamily="34" charset="-122"/>
+                <a:cs typeface="Arial" pitchFamily="34" charset="-120"/>
+              </a:rPr>
+              <a:t>Future: Promoted listings for sellers</a:t>
+            </a:r>
+            <a:endParaRPr lang="en-US" sz="1800" dirty="0"/>
+          </a:p>
+          <a:p>
+            <a:pPr>
+              <a:lnSpc>
+                <a:spcPct val="130000"/>
+              </a:lnSpc>
+              <a:spcAft>
+                <a:spcPts val="800"/>
+              </a:spcAft>
+            </a:pPr>
+            <a:r>
+              <a:rPr lang="en-US" sz="1800" dirty="0">
+                <a:solidFill>
+                  <a:srgbClr val="A1A1AA"/>
+                </a:solidFill>
+                <a:latin typeface="Arial" pitchFamily="34" charset="0"/>
+                <a:ea typeface="Arial" pitchFamily="34" charset="-122"/>
+                <a:cs typeface="Arial" pitchFamily="34" charset="-120"/>
+              </a:rPr>
+              <a:t>Future: Vinyl Buddy hardware sales</a:t>
+            </a:r>
+            <a:endParaRPr lang="en-US" sz="1800" dirty="0"/>
+          </a:p>
+        </p:txBody>
+      </p:sp>
+    </p:spTree>
+  </p:cSld>
+  <p:clrMapOvr>
+    <a:masterClrMapping/>
+  </p:clrMapOvr>
+</p:sld>
+</file>
+
+<file path=ppt/slides/slide17.xml><?xml version="1.0" encoding="utf-8"?>
+<p:sld xmlns:a="http://schemas.openxmlformats.org/drawingml/2006/main" xmlns:r="http://schemas.openxmlformats.org/officeDocument/2006/relationships" xmlns:p="http://schemas.openxmlformats.org/presentationml/2006/main">
+  <p:cSld name="Slide 17">
+    <p:bg>
+      <p:bgPr>
+        <a:solidFill>
+          <a:srgbClr val="0A0A0A"/>
+        </a:solidFill>
+      </p:bgPr>
+    </p:bg>
+    <p:spTree>
+      <p:nvGrpSpPr>
+        <p:cNvPr id="1" name=""/>
+        <p:cNvGrpSpPr/>
+        <p:nvPr/>
+      </p:nvGrpSpPr>
+      <p:grpSpPr>
+        <a:xfrm>
+          <a:off x="0" y="0"/>
+          <a:ext cx="0" cy="0"/>
+          <a:chOff x="0" y="0"/>
+          <a:chExt cx="0" cy="0"/>
+        </a:xfrm>
+      </p:grpSpPr>
+      <p:sp>
+        <p:nvSpPr>
+          <p:cNvPr id="2" name="Shape 0"/>
+          <p:cNvSpPr/>
+          <p:nvPr/>
+        </p:nvSpPr>
+        <p:spPr>
+          <a:xfrm>
+            <a:off x="0" y="0"/>
+            <a:ext cx="12188952" cy="54864"/>
+          </a:xfrm>
+          <a:prstGeom prst="rect">
+            <a:avLst/>
+          </a:prstGeom>
+          <a:solidFill>
+            <a:srgbClr val="0EA5E9"/>
+          </a:solidFill>
+          <a:ln/>
+        </p:spPr>
+      </p:sp>
+      <p:sp>
+        <p:nvSpPr>
+          <p:cNvPr id="3" name="Text 1"/>
+          <p:cNvSpPr/>
+          <p:nvPr/>
+        </p:nvSpPr>
+        <p:spPr>
+          <a:xfrm>
+            <a:off x="731520" y="365760"/>
+            <a:ext cx="10515600" cy="731520"/>
+          </a:xfrm>
+          <a:prstGeom prst="rect">
+            <a:avLst/>
+          </a:prstGeom>
+          <a:noFill/>
+          <a:ln/>
+        </p:spPr>
+        <p:txBody>
+          <a:bodyPr wrap="square" rtlCol="0" anchor="ctr"/>
+          <a:lstStyle/>
+          <a:p>
+            <a:pPr indent="0" marL="0">
+              <a:buNone/>
+            </a:pPr>
+            <a:r>
+              <a:rPr lang="en-US" sz="3200" b="1" dirty="0">
+                <a:solidFill>
+                  <a:srgbClr val="FFFFFF"/>
+                </a:solidFill>
+                <a:latin typeface="Arial" pitchFamily="34" charset="0"/>
+                <a:ea typeface="Arial" pitchFamily="34" charset="-122"/>
+                <a:cs typeface="Arial" pitchFamily="34" charset="-120"/>
+              </a:rPr>
+              <a:t>Deployment</a:t>
+            </a:r>
+            <a:endParaRPr lang="en-US" sz="3200" dirty="0"/>
+          </a:p>
+        </p:txBody>
+      </p:sp>
+      <p:sp>
+        <p:nvSpPr>
+          <p:cNvPr id="4" name="Shape 2"/>
+          <p:cNvSpPr/>
+          <p:nvPr/>
+        </p:nvSpPr>
+        <p:spPr>
+          <a:xfrm>
+            <a:off x="731520" y="1143000"/>
+            <a:ext cx="2286000" cy="36576"/>
+          </a:xfrm>
+          <a:prstGeom prst="rect">
+            <a:avLst/>
+          </a:prstGeom>
+          <a:solidFill>
+            <a:srgbClr val="0EA5E9"/>
+          </a:solidFill>
+          <a:ln/>
+        </p:spPr>
+      </p:sp>
+      <p:sp>
+        <p:nvSpPr>
+          <p:cNvPr id="5" name="Text 3"/>
+          <p:cNvSpPr/>
+          <p:nvPr/>
+        </p:nvSpPr>
+        <p:spPr>
+          <a:xfrm>
+            <a:off x="731520" y="1463040"/>
+            <a:ext cx="10515600" cy="4754880"/>
+          </a:xfrm>
+          <a:prstGeom prst="rect">
+            <a:avLst/>
+          </a:prstGeom>
+          <a:noFill/>
+          <a:ln/>
+        </p:spPr>
+        <p:txBody>
+          <a:bodyPr wrap="square" rtlCol="0" anchor="t"/>
+          <a:lstStyle/>
+          <a:p>
+            <a:pPr>
+              <a:lnSpc>
+                <a:spcPct val="130000"/>
+              </a:lnSpc>
+              <a:spcAft>
+                <a:spcPts val="800"/>
+              </a:spcAft>
+            </a:pPr>
+            <a:r>
+              <a:rPr lang="en-US" sz="1800" dirty="0">
+                <a:solidFill>
+                  <a:srgbClr val="A1A1AA"/>
+                </a:solidFill>
+                <a:latin typeface="Arial" pitchFamily="34" charset="0"/>
+                <a:ea typeface="Arial" pitchFamily="34" charset="-122"/>
+                <a:cs typeface="Arial" pitchFamily="34" charset="-120"/>
+              </a:rPr>
+              <a:t>GitHub auto-deploy pipeline for continuous delivery</a:t>
+            </a:r>
+            <a:endParaRPr lang="en-US" sz="1800" dirty="0"/>
+          </a:p>
+          <a:p>
+            <a:pPr>
+              <a:lnSpc>
+                <a:spcPct val="130000"/>
+              </a:lnSpc>
+              <a:spcAft>
+                <a:spcPts val="800"/>
+              </a:spcAft>
+            </a:pPr>
+            <a:r>
+              <a:rPr lang="en-US" sz="1800" dirty="0">
+                <a:solidFill>
+                  <a:srgbClr val="A1A1AA"/>
+                </a:solidFill>
+                <a:latin typeface="Arial" pitchFamily="34" charset="0"/>
+                <a:ea typeface="Arial" pitchFamily="34" charset="-122"/>
+                <a:cs typeface="Arial" pitchFamily="34" charset="-120"/>
+              </a:rPr>
+              <a:t>Vercel for frontend hosting with global CDN</a:t>
+            </a:r>
+            <a:endParaRPr lang="en-US" sz="1800" dirty="0"/>
+          </a:p>
+          <a:p>
+            <a:pPr>
+              <a:lnSpc>
+                <a:spcPct val="130000"/>
+              </a:lnSpc>
+              <a:spcAft>
+                <a:spcPts val="800"/>
+              </a:spcAft>
+            </a:pPr>
+            <a:r>
+              <a:rPr lang="en-US" sz="1800" dirty="0">
+                <a:solidFill>
+                  <a:srgbClr val="A1A1AA"/>
+                </a:solidFill>
+                <a:latin typeface="Arial" pitchFamily="34" charset="0"/>
+                <a:ea typeface="Arial" pitchFamily="34" charset="-122"/>
+                <a:cs typeface="Arial" pitchFamily="34" charset="-120"/>
+              </a:rPr>
+              <a:t>Railway for backend + PostgreSQL database</a:t>
+            </a:r>
+            <a:endParaRPr lang="en-US" sz="1800" dirty="0"/>
+          </a:p>
+          <a:p>
+            <a:pPr>
+              <a:lnSpc>
+                <a:spcPct val="130000"/>
+              </a:lnSpc>
+              <a:spcAft>
+                <a:spcPts val="800"/>
+              </a:spcAft>
+            </a:pPr>
+            <a:r>
+              <a:rPr lang="en-US" sz="1800" dirty="0">
+                <a:solidFill>
+                  <a:srgbClr val="A1A1AA"/>
+                </a:solidFill>
+                <a:latin typeface="Arial" pitchFamily="34" charset="0"/>
+                <a:ea typeface="Arial" pitchFamily="34" charset="-122"/>
+                <a:cs typeface="Arial" pitchFamily="34" charset="-120"/>
+              </a:rPr>
+              <a:t>Stripe for secure payment processing</a:t>
+            </a:r>
+            <a:endParaRPr lang="en-US" sz="1800" dirty="0"/>
+          </a:p>
+          <a:p>
+            <a:pPr>
+              <a:lnSpc>
+                <a:spcPct val="130000"/>
+              </a:lnSpc>
+              <a:spcAft>
+                <a:spcPts val="800"/>
+              </a:spcAft>
+            </a:pPr>
+            <a:r>
+              <a:rPr lang="en-US" sz="1800" dirty="0">
+                <a:solidFill>
+                  <a:srgbClr val="A1A1AA"/>
+                </a:solidFill>
+                <a:latin typeface="Arial" pitchFamily="34" charset="0"/>
+                <a:ea typeface="Arial" pitchFamily="34" charset="-122"/>
+                <a:cs typeface="Arial" pitchFamily="34" charset="-120"/>
+              </a:rPr>
+              <a:t>Production URL: groovestack.vercel.app</a:t>
+            </a:r>
+            <a:endParaRPr lang="en-US" sz="1800" dirty="0"/>
+          </a:p>
+        </p:txBody>
+      </p:sp>
+    </p:spTree>
+  </p:cSld>
+  <p:clrMapOvr>
+    <a:masterClrMapping/>
+  </p:clrMapOvr>
+</p:sld>
+</file>
+
+<file path=ppt/slides/slide18.xml><?xml version="1.0" encoding="utf-8"?>
+<p:sld xmlns:a="http://schemas.openxmlformats.org/drawingml/2006/main" xmlns:r="http://schemas.openxmlformats.org/officeDocument/2006/relationships" xmlns:p="http://schemas.openxmlformats.org/presentationml/2006/main">
+  <p:cSld name="Slide 18">
+    <p:bg>
+      <p:bgPr>
+        <a:solidFill>
+          <a:srgbClr val="0A0A0A"/>
+        </a:solidFill>
+      </p:bgPr>
+    </p:bg>
+    <p:spTree>
+      <p:nvGrpSpPr>
+        <p:cNvPr id="1" name=""/>
+        <p:cNvGrpSpPr/>
+        <p:nvPr/>
+      </p:nvGrpSpPr>
+      <p:grpSpPr>
+        <a:xfrm>
+          <a:off x="0" y="0"/>
+          <a:ext cx="0" cy="0"/>
+          <a:chOff x="0" y="0"/>
+          <a:chExt cx="0" cy="0"/>
+        </a:xfrm>
+      </p:grpSpPr>
+      <p:sp>
+        <p:nvSpPr>
+          <p:cNvPr id="2" name="Shape 0"/>
+          <p:cNvSpPr/>
+          <p:nvPr/>
+        </p:nvSpPr>
+        <p:spPr>
+          <a:xfrm>
+            <a:off x="0" y="0"/>
+            <a:ext cx="12188952" cy="54864"/>
+          </a:xfrm>
+          <a:prstGeom prst="rect">
+            <a:avLst/>
+          </a:prstGeom>
+          <a:solidFill>
+            <a:srgbClr val="0EA5E9"/>
+          </a:solidFill>
+          <a:ln/>
+        </p:spPr>
+      </p:sp>
+      <p:sp>
+        <p:nvSpPr>
+          <p:cNvPr id="3" name="Text 1"/>
+          <p:cNvSpPr/>
+          <p:nvPr/>
+        </p:nvSpPr>
+        <p:spPr>
+          <a:xfrm>
+            <a:off x="731520" y="365760"/>
+            <a:ext cx="10515600" cy="731520"/>
+          </a:xfrm>
+          <a:prstGeom prst="rect">
+            <a:avLst/>
+          </a:prstGeom>
+          <a:noFill/>
+          <a:ln/>
+        </p:spPr>
+        <p:txBody>
+          <a:bodyPr wrap="square" rtlCol="0" anchor="ctr"/>
+          <a:lstStyle/>
+          <a:p>
+            <a:pPr indent="0" marL="0">
+              <a:buNone/>
+            </a:pPr>
+            <a:r>
+              <a:rPr lang="en-US" sz="3200" b="1" dirty="0">
+                <a:solidFill>
+                  <a:srgbClr val="FFFFFF"/>
+                </a:solidFill>
+                <a:latin typeface="Arial" pitchFamily="34" charset="0"/>
+                <a:ea typeface="Arial" pitchFamily="34" charset="-122"/>
+                <a:cs typeface="Arial" pitchFamily="34" charset="-120"/>
+              </a:rPr>
+              <a:t>What's Next</a:t>
+            </a:r>
+            <a:endParaRPr lang="en-US" sz="3200" dirty="0"/>
+          </a:p>
+        </p:txBody>
+      </p:sp>
+      <p:sp>
+        <p:nvSpPr>
+          <p:cNvPr id="4" name="Shape 2"/>
+          <p:cNvSpPr/>
+          <p:nvPr/>
+        </p:nvSpPr>
+        <p:spPr>
+          <a:xfrm>
+            <a:off x="731520" y="1143000"/>
+            <a:ext cx="2286000" cy="36576"/>
+          </a:xfrm>
+          <a:prstGeom prst="rect">
+            <a:avLst/>
+          </a:prstGeom>
+          <a:solidFill>
+            <a:srgbClr val="0EA5E9"/>
+          </a:solidFill>
+          <a:ln/>
+        </p:spPr>
+      </p:sp>
+      <p:sp>
+        <p:nvSpPr>
+          <p:cNvPr id="5" name="Text 3"/>
+          <p:cNvSpPr/>
+          <p:nvPr/>
+        </p:nvSpPr>
+        <p:spPr>
+          <a:xfrm>
+            <a:off x="731520" y="1463040"/>
+            <a:ext cx="10515600" cy="4754880"/>
+          </a:xfrm>
+          <a:prstGeom prst="rect">
+            <a:avLst/>
+          </a:prstGeom>
+          <a:noFill/>
+          <a:ln/>
+        </p:spPr>
+        <p:txBody>
+          <a:bodyPr wrap="square" rtlCol="0" anchor="t"/>
+          <a:lstStyle/>
+          <a:p>
+            <a:pPr>
+              <a:lnSpc>
+                <a:spcPct val="130000"/>
+              </a:lnSpc>
+              <a:spcAft>
+                <a:spcPts val="800"/>
+              </a:spcAft>
+            </a:pPr>
+            <a:r>
+              <a:rPr lang="en-US" sz="1800" dirty="0">
+                <a:solidFill>
+                  <a:srgbClr val="A1A1AA"/>
+                </a:solidFill>
+                <a:latin typeface="Arial" pitchFamily="34" charset="0"/>
+                <a:ea typeface="Arial" pitchFamily="34" charset="-122"/>
+                <a:cs typeface="Arial" pitchFamily="34" charset="-120"/>
+              </a:rPr>
+              <a:t>Mobile app (React Native) for iOS and Android</a:t>
+            </a:r>
+            <a:endParaRPr lang="en-US" sz="1800" dirty="0"/>
+          </a:p>
+          <a:p>
+            <a:pPr>
+              <a:lnSpc>
+                <a:spcPct val="130000"/>
+              </a:lnSpc>
+              <a:spcAft>
+                <a:spcPts val="800"/>
+              </a:spcAft>
+            </a:pPr>
+            <a:r>
+              <a:rPr lang="en-US" sz="1800" dirty="0">
+                <a:solidFill>
+                  <a:srgbClr val="A1A1AA"/>
+                </a:solidFill>
+                <a:latin typeface="Arial" pitchFamily="34" charset="0"/>
+                <a:ea typeface="Arial" pitchFamily="34" charset="-122"/>
+                <a:cs typeface="Arial" pitchFamily="34" charset="-120"/>
+              </a:rPr>
+              <a:t>Real-time notifications via WebSockets</a:t>
+            </a:r>
+            <a:endParaRPr lang="en-US" sz="1800" dirty="0"/>
+          </a:p>
+          <a:p>
+            <a:pPr>
+              <a:lnSpc>
+                <a:spcPct val="130000"/>
+              </a:lnSpc>
+              <a:spcAft>
+                <a:spcPts val="800"/>
+              </a:spcAft>
+            </a:pPr>
+            <a:r>
+              <a:rPr lang="en-US" sz="1800" dirty="0">
+                <a:solidFill>
+                  <a:srgbClr val="A1A1AA"/>
+                </a:solidFill>
+                <a:latin typeface="Arial" pitchFamily="34" charset="0"/>
+                <a:ea typeface="Arial" pitchFamily="34" charset="-122"/>
+                <a:cs typeface="Arial" pitchFamily="34" charset="-120"/>
+              </a:rPr>
+              <a:t>Vinyl Buddy v2 with WiFi + Bluetooth connectivity</a:t>
+            </a:r>
+            <a:endParaRPr lang="en-US" sz="1800" dirty="0"/>
+          </a:p>
+          <a:p>
+            <a:pPr>
+              <a:lnSpc>
+                <a:spcPct val="130000"/>
+              </a:lnSpc>
+              <a:spcAft>
+                <a:spcPts val="800"/>
+              </a:spcAft>
+            </a:pPr>
+            <a:r>
+              <a:rPr lang="en-US" sz="1800" dirty="0">
+                <a:solidFill>
+                  <a:srgbClr val="A1A1AA"/>
+                </a:solidFill>
+                <a:latin typeface="Arial" pitchFamily="34" charset="0"/>
+                <a:ea typeface="Arial" pitchFamily="34" charset="-122"/>
+                <a:cs typeface="Arial" pitchFamily="34" charset="-120"/>
+              </a:rPr>
+              <a:t>Live listening sessions with friends</a:t>
+            </a:r>
+            <a:endParaRPr lang="en-US" sz="1800" dirty="0"/>
+          </a:p>
+          <a:p>
+            <a:pPr>
+              <a:lnSpc>
+                <a:spcPct val="130000"/>
+              </a:lnSpc>
+              <a:spcAft>
+                <a:spcPts val="800"/>
+              </a:spcAft>
+            </a:pPr>
+            <a:r>
+              <a:rPr lang="en-US" sz="1800" dirty="0">
+                <a:solidFill>
+                  <a:srgbClr val="A1A1AA"/>
+                </a:solidFill>
+                <a:latin typeface="Arial" pitchFamily="34" charset="0"/>
+                <a:ea typeface="Arial" pitchFamily="34" charset="-122"/>
+                <a:cs typeface="Arial" pitchFamily="34" charset="-120"/>
+              </a:rPr>
+              <a:t>International shipping and multi-currency support</a:t>
+            </a:r>
+            <a:endParaRPr lang="en-US" sz="1800" dirty="0"/>
+          </a:p>
+          <a:p>
+            <a:pPr>
+              <a:lnSpc>
+                <a:spcPct val="130000"/>
+              </a:lnSpc>
+              <a:spcAft>
+                <a:spcPts val="800"/>
+              </a:spcAft>
+            </a:pPr>
+            <a:r>
+              <a:rPr lang="en-US" sz="1800" dirty="0">
+                <a:solidFill>
+                  <a:srgbClr val="A1A1AA"/>
+                </a:solidFill>
+                <a:latin typeface="Arial" pitchFamily="34" charset="0"/>
+                <a:ea typeface="Arial" pitchFamily="34" charset="-122"/>
+                <a:cs typeface="Arial" pitchFamily="34" charset="-120"/>
+              </a:rPr>
+              <a:t>Premium subscription tiers for power collectors</a:t>
+            </a:r>
+            <a:endParaRPr lang="en-US" sz="1800" dirty="0"/>
+          </a:p>
+        </p:txBody>
+      </p:sp>
+    </p:spTree>
+  </p:cSld>
+  <p:clrMapOvr>
+    <a:masterClrMapping/>
+  </p:clrMapOvr>
+</p:sld>
+</file>
+
+<file path=ppt/slides/slide19.xml><?xml version="1.0" encoding="utf-8"?>
+<p:sld xmlns:a="http://schemas.openxmlformats.org/drawingml/2006/main" xmlns:r="http://schemas.openxmlformats.org/officeDocument/2006/relationships" xmlns:p="http://schemas.openxmlformats.org/presentationml/2006/main">
+  <p:cSld name="Slide 19">
     <p:bg>
       <p:bgPr>
         <a:solidFill>

</xml_diff>

<commit_message>
Wave 30: Premium VinylBuddy UX, marketplace revenue push, 41-slide deck
- 20 premium VinylBuddy UX: Tinder-style recs, year-in-review, A/B audio test
- Vinyl loading spinner, device skins, stylus tracking, collaborative playlists
- Marketplace revenue optimization across Explore, Collection, Social, Detail
- Hot deals, selling fast, bundle discounts, promoted listings, trade suggestions
- Pulsing Make an Offer CTAs, social proof, price trend nudges
- PowerPoint updated to 41 slides with revenue model and engagement features

Co-Authored-By: Claude Opus 4.6 (1M context) <noreply@anthropic.com>
</commit_message>
<xml_diff>
--- a/GrooveStack_Overview.pptx
+++ b/GrooveStack_Overview.pptx
@@ -41,9 +41,14 @@
     <p:sldId id="289" r:id="rId35"/>
     <p:sldId id="290" r:id="rId36"/>
     <p:sldId id="291" r:id="rId37"/>
+    <p:sldId id="292" r:id="rId38"/>
+    <p:sldId id="293" r:id="rId39"/>
+    <p:sldId id="294" r:id="rId40"/>
+    <p:sldId id="295" r:id="rId41"/>
+    <p:sldId id="296" r:id="rId42"/>
   </p:sldIdLst>
   <p:notesMasterIdLst>
-    <p:notesMasterId r:id="rId38"/>
+    <p:notesMasterId r:id="rId43"/>
   </p:notesMasterIdLst>
   <p:sldSz cx="12192000" cy="6858000"/>
   <p:notesSz cx="6858000" cy="12192000"/>
@@ -3131,6 +3136,270 @@
 </p:notes>
 </file>
 
+<file path=ppt/notesSlides/notesSlide37.xml><?xml version="1.0" encoding="utf-8"?>
+<p:notes xmlns:a="http://schemas.openxmlformats.org/drawingml/2006/main" xmlns:r="http://schemas.openxmlformats.org/officeDocument/2006/relationships" xmlns:p="http://schemas.openxmlformats.org/presentationml/2006/main">
+  <p:cSld>
+    <p:spTree>
+      <p:nvGrpSpPr>
+        <p:cNvPr id="1" name=""/>
+        <p:cNvGrpSpPr/>
+        <p:nvPr/>
+      </p:nvGrpSpPr>
+      <p:grpSpPr>
+        <a:xfrm>
+          <a:off x="0" y="0"/>
+          <a:ext cx="0" cy="0"/>
+          <a:chOff x="0" y="0"/>
+          <a:chExt cx="0" cy="0"/>
+        </a:xfrm>
+      </p:grpSpPr>
+      <p:sp>
+        <p:nvSpPr>
+          <p:cNvPr id="2" name="Slide Image Placeholder 1"/>
+          <p:cNvSpPr>
+            <a:spLocks noGrp="1" noRot="1" noChangeAspect="1"/>
+          </p:cNvSpPr>
+          <p:nvPr>
+            <p:ph type="sldImg"/>
+          </p:nvPr>
+        </p:nvSpPr>
+        <p:spPr/>
+      </p:sp>
+      <p:sp>
+        <p:nvSpPr>
+          <p:cNvPr id="3" name="Notes Placeholder 2"/>
+          <p:cNvSpPr>
+            <a:spLocks noGrp="1"/>
+          </p:cNvSpPr>
+          <p:nvPr>
+            <p:ph type="body" idx="1"/>
+          </p:nvPr>
+        </p:nvSpPr>
+        <p:spPr/>
+        <p:txBody>
+          <a:bodyPr/>
+          <a:lstStyle/>
+          <a:p>
+            <a:r>
+              <a:rPr lang="en-US" dirty="0"/>
+              <a:t/>
+            </a:r>
+            <a:endParaRPr lang="en-US" dirty="0"/>
+          </a:p>
+        </p:txBody>
+      </p:sp>
+      <p:sp>
+        <p:nvSpPr>
+          <p:cNvPr id="4" name="Slide Number Placeholder 3"/>
+          <p:cNvSpPr>
+            <a:spLocks noGrp="1"/>
+          </p:cNvSpPr>
+          <p:nvPr>
+            <p:ph type="sldNum" sz="quarter" idx="10"/>
+          </p:nvPr>
+        </p:nvSpPr>
+        <p:spPr/>
+        <p:txBody>
+          <a:bodyPr/>
+          <a:lstStyle/>
+          <a:p>
+            <a:fld id="{F7021451-1387-4CA6-816F-3879F97B5CBC}" type="slidenum">
+              <a:rPr lang="en-US"/>
+              <a:t>37</a:t>
+            </a:fld>
+            <a:endParaRPr lang="en-US"/>
+          </a:p>
+        </p:txBody>
+      </p:sp>
+    </p:spTree>
+    <p:extLst>
+      <p:ext uri="{BB962C8B-B14F-4D97-AF65-F5344CB8AC3E}">
+        <p14:creationId xmlns:p14="http://schemas.microsoft.com/office/powerpoint/2010/main" val="1024086991"/>
+      </p:ext>
+    </p:extLst>
+  </p:cSld>
+  <p:clrMapOvr>
+    <a:masterClrMapping/>
+  </p:clrMapOvr>
+</p:notes>
+</file>
+
+<file path=ppt/notesSlides/notesSlide38.xml><?xml version="1.0" encoding="utf-8"?>
+<p:notes xmlns:a="http://schemas.openxmlformats.org/drawingml/2006/main" xmlns:r="http://schemas.openxmlformats.org/officeDocument/2006/relationships" xmlns:p="http://schemas.openxmlformats.org/presentationml/2006/main">
+  <p:cSld>
+    <p:spTree>
+      <p:nvGrpSpPr>
+        <p:cNvPr id="1" name=""/>
+        <p:cNvGrpSpPr/>
+        <p:nvPr/>
+      </p:nvGrpSpPr>
+      <p:grpSpPr>
+        <a:xfrm>
+          <a:off x="0" y="0"/>
+          <a:ext cx="0" cy="0"/>
+          <a:chOff x="0" y="0"/>
+          <a:chExt cx="0" cy="0"/>
+        </a:xfrm>
+      </p:grpSpPr>
+      <p:sp>
+        <p:nvSpPr>
+          <p:cNvPr id="2" name="Slide Image Placeholder 1"/>
+          <p:cNvSpPr>
+            <a:spLocks noGrp="1" noRot="1" noChangeAspect="1"/>
+          </p:cNvSpPr>
+          <p:nvPr>
+            <p:ph type="sldImg"/>
+          </p:nvPr>
+        </p:nvSpPr>
+        <p:spPr/>
+      </p:sp>
+      <p:sp>
+        <p:nvSpPr>
+          <p:cNvPr id="3" name="Notes Placeholder 2"/>
+          <p:cNvSpPr>
+            <a:spLocks noGrp="1"/>
+          </p:cNvSpPr>
+          <p:nvPr>
+            <p:ph type="body" idx="1"/>
+          </p:nvPr>
+        </p:nvSpPr>
+        <p:spPr/>
+        <p:txBody>
+          <a:bodyPr/>
+          <a:lstStyle/>
+          <a:p>
+            <a:r>
+              <a:rPr lang="en-US" dirty="0"/>
+              <a:t/>
+            </a:r>
+            <a:endParaRPr lang="en-US" dirty="0"/>
+          </a:p>
+        </p:txBody>
+      </p:sp>
+      <p:sp>
+        <p:nvSpPr>
+          <p:cNvPr id="4" name="Slide Number Placeholder 3"/>
+          <p:cNvSpPr>
+            <a:spLocks noGrp="1"/>
+          </p:cNvSpPr>
+          <p:nvPr>
+            <p:ph type="sldNum" sz="quarter" idx="10"/>
+          </p:nvPr>
+        </p:nvSpPr>
+        <p:spPr/>
+        <p:txBody>
+          <a:bodyPr/>
+          <a:lstStyle/>
+          <a:p>
+            <a:fld id="{F7021451-1387-4CA6-816F-3879F97B5CBC}" type="slidenum">
+              <a:rPr lang="en-US"/>
+              <a:t>38</a:t>
+            </a:fld>
+            <a:endParaRPr lang="en-US"/>
+          </a:p>
+        </p:txBody>
+      </p:sp>
+    </p:spTree>
+    <p:extLst>
+      <p:ext uri="{BB962C8B-B14F-4D97-AF65-F5344CB8AC3E}">
+        <p14:creationId xmlns:p14="http://schemas.microsoft.com/office/powerpoint/2010/main" val="1024086991"/>
+      </p:ext>
+    </p:extLst>
+  </p:cSld>
+  <p:clrMapOvr>
+    <a:masterClrMapping/>
+  </p:clrMapOvr>
+</p:notes>
+</file>
+
+<file path=ppt/notesSlides/notesSlide39.xml><?xml version="1.0" encoding="utf-8"?>
+<p:notes xmlns:a="http://schemas.openxmlformats.org/drawingml/2006/main" xmlns:r="http://schemas.openxmlformats.org/officeDocument/2006/relationships" xmlns:p="http://schemas.openxmlformats.org/presentationml/2006/main">
+  <p:cSld>
+    <p:spTree>
+      <p:nvGrpSpPr>
+        <p:cNvPr id="1" name=""/>
+        <p:cNvGrpSpPr/>
+        <p:nvPr/>
+      </p:nvGrpSpPr>
+      <p:grpSpPr>
+        <a:xfrm>
+          <a:off x="0" y="0"/>
+          <a:ext cx="0" cy="0"/>
+          <a:chOff x="0" y="0"/>
+          <a:chExt cx="0" cy="0"/>
+        </a:xfrm>
+      </p:grpSpPr>
+      <p:sp>
+        <p:nvSpPr>
+          <p:cNvPr id="2" name="Slide Image Placeholder 1"/>
+          <p:cNvSpPr>
+            <a:spLocks noGrp="1" noRot="1" noChangeAspect="1"/>
+          </p:cNvSpPr>
+          <p:nvPr>
+            <p:ph type="sldImg"/>
+          </p:nvPr>
+        </p:nvSpPr>
+        <p:spPr/>
+      </p:sp>
+      <p:sp>
+        <p:nvSpPr>
+          <p:cNvPr id="3" name="Notes Placeholder 2"/>
+          <p:cNvSpPr>
+            <a:spLocks noGrp="1"/>
+          </p:cNvSpPr>
+          <p:nvPr>
+            <p:ph type="body" idx="1"/>
+          </p:nvPr>
+        </p:nvSpPr>
+        <p:spPr/>
+        <p:txBody>
+          <a:bodyPr/>
+          <a:lstStyle/>
+          <a:p>
+            <a:r>
+              <a:rPr lang="en-US" dirty="0"/>
+              <a:t/>
+            </a:r>
+            <a:endParaRPr lang="en-US" dirty="0"/>
+          </a:p>
+        </p:txBody>
+      </p:sp>
+      <p:sp>
+        <p:nvSpPr>
+          <p:cNvPr id="4" name="Slide Number Placeholder 3"/>
+          <p:cNvSpPr>
+            <a:spLocks noGrp="1"/>
+          </p:cNvSpPr>
+          <p:nvPr>
+            <p:ph type="sldNum" sz="quarter" idx="10"/>
+          </p:nvPr>
+        </p:nvSpPr>
+        <p:spPr/>
+        <p:txBody>
+          <a:bodyPr/>
+          <a:lstStyle/>
+          <a:p>
+            <a:fld id="{F7021451-1387-4CA6-816F-3879F97B5CBC}" type="slidenum">
+              <a:rPr lang="en-US"/>
+              <a:t>39</a:t>
+            </a:fld>
+            <a:endParaRPr lang="en-US"/>
+          </a:p>
+        </p:txBody>
+      </p:sp>
+    </p:spTree>
+    <p:extLst>
+      <p:ext uri="{BB962C8B-B14F-4D97-AF65-F5344CB8AC3E}">
+        <p14:creationId xmlns:p14="http://schemas.microsoft.com/office/powerpoint/2010/main" val="1024086991"/>
+      </p:ext>
+    </p:extLst>
+  </p:cSld>
+  <p:clrMapOvr>
+    <a:masterClrMapping/>
+  </p:clrMapOvr>
+</p:notes>
+</file>
+
 <file path=ppt/notesSlides/notesSlide4.xml><?xml version="1.0" encoding="utf-8"?>
 <p:notes xmlns:a="http://schemas.openxmlformats.org/drawingml/2006/main" xmlns:r="http://schemas.openxmlformats.org/officeDocument/2006/relationships" xmlns:p="http://schemas.openxmlformats.org/presentationml/2006/main">
   <p:cSld>
@@ -3201,6 +3470,182 @@
             <a:fld id="{F7021451-1387-4CA6-816F-3879F97B5CBC}" type="slidenum">
               <a:rPr lang="en-US"/>
               <a:t>4</a:t>
+            </a:fld>
+            <a:endParaRPr lang="en-US"/>
+          </a:p>
+        </p:txBody>
+      </p:sp>
+    </p:spTree>
+    <p:extLst>
+      <p:ext uri="{BB962C8B-B14F-4D97-AF65-F5344CB8AC3E}">
+        <p14:creationId xmlns:p14="http://schemas.microsoft.com/office/powerpoint/2010/main" val="1024086991"/>
+      </p:ext>
+    </p:extLst>
+  </p:cSld>
+  <p:clrMapOvr>
+    <a:masterClrMapping/>
+  </p:clrMapOvr>
+</p:notes>
+</file>
+
+<file path=ppt/notesSlides/notesSlide40.xml><?xml version="1.0" encoding="utf-8"?>
+<p:notes xmlns:a="http://schemas.openxmlformats.org/drawingml/2006/main" xmlns:r="http://schemas.openxmlformats.org/officeDocument/2006/relationships" xmlns:p="http://schemas.openxmlformats.org/presentationml/2006/main">
+  <p:cSld>
+    <p:spTree>
+      <p:nvGrpSpPr>
+        <p:cNvPr id="1" name=""/>
+        <p:cNvGrpSpPr/>
+        <p:nvPr/>
+      </p:nvGrpSpPr>
+      <p:grpSpPr>
+        <a:xfrm>
+          <a:off x="0" y="0"/>
+          <a:ext cx="0" cy="0"/>
+          <a:chOff x="0" y="0"/>
+          <a:chExt cx="0" cy="0"/>
+        </a:xfrm>
+      </p:grpSpPr>
+      <p:sp>
+        <p:nvSpPr>
+          <p:cNvPr id="2" name="Slide Image Placeholder 1"/>
+          <p:cNvSpPr>
+            <a:spLocks noGrp="1" noRot="1" noChangeAspect="1"/>
+          </p:cNvSpPr>
+          <p:nvPr>
+            <p:ph type="sldImg"/>
+          </p:nvPr>
+        </p:nvSpPr>
+        <p:spPr/>
+      </p:sp>
+      <p:sp>
+        <p:nvSpPr>
+          <p:cNvPr id="3" name="Notes Placeholder 2"/>
+          <p:cNvSpPr>
+            <a:spLocks noGrp="1"/>
+          </p:cNvSpPr>
+          <p:nvPr>
+            <p:ph type="body" idx="1"/>
+          </p:nvPr>
+        </p:nvSpPr>
+        <p:spPr/>
+        <p:txBody>
+          <a:bodyPr/>
+          <a:lstStyle/>
+          <a:p>
+            <a:r>
+              <a:rPr lang="en-US" dirty="0"/>
+              <a:t/>
+            </a:r>
+            <a:endParaRPr lang="en-US" dirty="0"/>
+          </a:p>
+        </p:txBody>
+      </p:sp>
+      <p:sp>
+        <p:nvSpPr>
+          <p:cNvPr id="4" name="Slide Number Placeholder 3"/>
+          <p:cNvSpPr>
+            <a:spLocks noGrp="1"/>
+          </p:cNvSpPr>
+          <p:nvPr>
+            <p:ph type="sldNum" sz="quarter" idx="10"/>
+          </p:nvPr>
+        </p:nvSpPr>
+        <p:spPr/>
+        <p:txBody>
+          <a:bodyPr/>
+          <a:lstStyle/>
+          <a:p>
+            <a:fld id="{F7021451-1387-4CA6-816F-3879F97B5CBC}" type="slidenum">
+              <a:rPr lang="en-US"/>
+              <a:t>40</a:t>
+            </a:fld>
+            <a:endParaRPr lang="en-US"/>
+          </a:p>
+        </p:txBody>
+      </p:sp>
+    </p:spTree>
+    <p:extLst>
+      <p:ext uri="{BB962C8B-B14F-4D97-AF65-F5344CB8AC3E}">
+        <p14:creationId xmlns:p14="http://schemas.microsoft.com/office/powerpoint/2010/main" val="1024086991"/>
+      </p:ext>
+    </p:extLst>
+  </p:cSld>
+  <p:clrMapOvr>
+    <a:masterClrMapping/>
+  </p:clrMapOvr>
+</p:notes>
+</file>
+
+<file path=ppt/notesSlides/notesSlide41.xml><?xml version="1.0" encoding="utf-8"?>
+<p:notes xmlns:a="http://schemas.openxmlformats.org/drawingml/2006/main" xmlns:r="http://schemas.openxmlformats.org/officeDocument/2006/relationships" xmlns:p="http://schemas.openxmlformats.org/presentationml/2006/main">
+  <p:cSld>
+    <p:spTree>
+      <p:nvGrpSpPr>
+        <p:cNvPr id="1" name=""/>
+        <p:cNvGrpSpPr/>
+        <p:nvPr/>
+      </p:nvGrpSpPr>
+      <p:grpSpPr>
+        <a:xfrm>
+          <a:off x="0" y="0"/>
+          <a:ext cx="0" cy="0"/>
+          <a:chOff x="0" y="0"/>
+          <a:chExt cx="0" cy="0"/>
+        </a:xfrm>
+      </p:grpSpPr>
+      <p:sp>
+        <p:nvSpPr>
+          <p:cNvPr id="2" name="Slide Image Placeholder 1"/>
+          <p:cNvSpPr>
+            <a:spLocks noGrp="1" noRot="1" noChangeAspect="1"/>
+          </p:cNvSpPr>
+          <p:nvPr>
+            <p:ph type="sldImg"/>
+          </p:nvPr>
+        </p:nvSpPr>
+        <p:spPr/>
+      </p:sp>
+      <p:sp>
+        <p:nvSpPr>
+          <p:cNvPr id="3" name="Notes Placeholder 2"/>
+          <p:cNvSpPr>
+            <a:spLocks noGrp="1"/>
+          </p:cNvSpPr>
+          <p:nvPr>
+            <p:ph type="body" idx="1"/>
+          </p:nvPr>
+        </p:nvSpPr>
+        <p:spPr/>
+        <p:txBody>
+          <a:bodyPr/>
+          <a:lstStyle/>
+          <a:p>
+            <a:r>
+              <a:rPr lang="en-US" dirty="0"/>
+              <a:t/>
+            </a:r>
+            <a:endParaRPr lang="en-US" dirty="0"/>
+          </a:p>
+        </p:txBody>
+      </p:sp>
+      <p:sp>
+        <p:nvSpPr>
+          <p:cNvPr id="4" name="Slide Number Placeholder 3"/>
+          <p:cNvSpPr>
+            <a:spLocks noGrp="1"/>
+          </p:cNvSpPr>
+          <p:nvPr>
+            <p:ph type="sldNum" sz="quarter" idx="10"/>
+          </p:nvPr>
+        </p:nvSpPr>
+        <p:spPr/>
+        <p:txBody>
+          <a:bodyPr/>
+          <a:lstStyle/>
+          <a:p>
+            <a:fld id="{F7021451-1387-4CA6-816F-3879F97B5CBC}" type="slidenum">
+              <a:rPr lang="en-US"/>
+              <a:t>41</a:t>
             </a:fld>
             <a:endParaRPr lang="en-US"/>
           </a:p>
@@ -4199,7 +4644,7 @@
                 <a:ea typeface="Arial" pitchFamily="34" charset="-122"/>
                 <a:cs typeface="Arial" pitchFamily="34" charset="-120"/>
               </a:rPr>
-              <a:t>Waves 1–20  •  Final Comprehensive Edition</a:t>
+              <a:t>Waves 1–29  •  Final Comprehensive Edition</a:t>
             </a:r>
             <a:endParaRPr lang="en-US" sz="1400" dirty="0"/>
           </a:p>
@@ -8236,7 +8681,7 @@
                 <a:ea typeface="Arial" pitchFamily="34" charset="-122"/>
                 <a:cs typeface="Arial" pitchFamily="34" charset="-120"/>
               </a:rPr>
-              <a:t>1,800+ improvements across 20 development waves</a:t>
+              <a:t>2,000+ improvements across 29 development waves</a:t>
             </a:r>
             <a:endParaRPr lang="en-US" sz="1400" dirty="0"/>
           </a:p>
@@ -12784,7 +13229,7 @@
                 <a:ea typeface="Arial" pitchFamily="34" charset="-122"/>
                 <a:cs typeface="Arial" pitchFamily="34" charset="-120"/>
               </a:rPr>
-              <a:t>1,800+</a:t>
+              <a:t>2,000+</a:t>
             </a:r>
             <a:endParaRPr lang="en-US" sz="3600" dirty="0"/>
           </a:p>
@@ -12884,7 +13329,7 @@
                 <a:ea typeface="Arial" pitchFamily="34" charset="-122"/>
                 <a:cs typeface="Arial" pitchFamily="34" charset="-120"/>
               </a:rPr>
-              <a:t>275+</a:t>
+              <a:t>290+</a:t>
             </a:r>
             <a:endParaRPr lang="en-US" sz="3600" dirty="0"/>
           </a:p>
@@ -13184,7 +13629,7 @@
                 <a:ea typeface="Arial" pitchFamily="34" charset="-122"/>
                 <a:cs typeface="Arial" pitchFamily="34" charset="-120"/>
               </a:rPr>
-              <a:t>20</a:t>
+              <a:t>29</a:t>
             </a:r>
             <a:endParaRPr lang="en-US" sz="3600" dirty="0"/>
           </a:p>
@@ -13414,7 +13859,7 @@
                 <a:ea typeface="Arial" pitchFamily="34" charset="-122"/>
                 <a:cs typeface="Arial" pitchFamily="34" charset="-120"/>
               </a:rPr>
-              <a:t>API Overview — 275+ Endpoints</a:t>
+              <a:t>API Overview — 290+ Endpoints</a:t>
             </a:r>
             <a:endParaRPr lang="en-US" sz="3200" dirty="0"/>
           </a:p>
@@ -13495,7 +13940,7 @@
                 <a:ea typeface="Arial" pitchFamily="34" charset="-122"/>
                 <a:cs typeface="Arial" pitchFamily="34" charset="-120"/>
               </a:rPr>
-              <a:t>40+</a:t>
+              <a:t>45+</a:t>
             </a:r>
             <a:endParaRPr lang="en-US" sz="3600" dirty="0"/>
           </a:p>
@@ -13595,7 +14040,7 @@
                 <a:ea typeface="Arial" pitchFamily="34" charset="-122"/>
                 <a:cs typeface="Arial" pitchFamily="34" charset="-120"/>
               </a:rPr>
-              <a:t>30+</a:t>
+              <a:t>35+</a:t>
             </a:r>
             <a:endParaRPr lang="en-US" sz="3600" dirty="0"/>
           </a:p>
@@ -13795,7 +14240,7 @@
                 <a:ea typeface="Arial" pitchFamily="34" charset="-122"/>
                 <a:cs typeface="Arial" pitchFamily="34" charset="-120"/>
               </a:rPr>
-              <a:t>35+</a:t>
+              <a:t>40+</a:t>
             </a:r>
             <a:endParaRPr lang="en-US" sz="3600" dirty="0"/>
           </a:p>
@@ -16192,7 +16637,7 @@
                 <a:ea typeface="Arial" pitchFamily="34" charset="-122"/>
                 <a:cs typeface="Arial" pitchFamily="34" charset="-120"/>
               </a:rPr>
-              <a:t>Wave 20: Final polish, 275+ endpoints, comprehensive documentation</a:t>
+              <a:t>Wave 20: Polish, 275+ endpoints, comprehensive documentation</a:t>
             </a:r>
             <a:endParaRPr lang="en-US" sz="1400" dirty="0"/>
           </a:p>
@@ -16283,7 +16728,7 @@
                 <a:ea typeface="Arial" pitchFamily="34" charset="-122"/>
                 <a:cs typeface="Arial" pitchFamily="34" charset="-120"/>
               </a:rPr>
-              <a:t>Roadmap — Future Plans</a:t>
+              <a:t>Development Journey — Waves 21–29</a:t>
             </a:r>
             <a:endParaRPr lang="en-US" sz="3200" dirty="0"/>
           </a:p>
@@ -16347,7 +16792,7 @@
                 <a:ea typeface="Arial" pitchFamily="34" charset="-122"/>
                 <a:cs typeface="Arial" pitchFamily="34" charset="-120"/>
               </a:rPr>
-              <a:t>Mobile app (React Native) for iOS and Android</a:t>
+              <a:t>Wave 21: Revenue model, 5% transaction fee, seller tier subscriptions</a:t>
             </a:r>
             <a:endParaRPr lang="en-US" sz="1400" dirty="0"/>
           </a:p>
@@ -16369,7 +16814,7 @@
                 <a:ea typeface="Arial" pitchFamily="34" charset="-122"/>
                 <a:cs typeface="Arial" pitchFamily="34" charset="-120"/>
               </a:rPr>
-              <a:t>Real-time notifications and chat via WebSockets</a:t>
+              <a:t>Wave 22: Gamification system, achievements, streaks, leaderboards</a:t>
             </a:r>
             <a:endParaRPr lang="en-US" sz="1400" dirty="0"/>
           </a:p>
@@ -16391,7 +16836,7 @@
                 <a:ea typeface="Arial" pitchFamily="34" charset="-122"/>
                 <a:cs typeface="Arial" pitchFamily="34" charset="-120"/>
               </a:rPr>
-              <a:t>Vinyl Buddy v2: improved form factor and enclosure design</a:t>
+              <a:t>Wave 23: Vinyl Buddy build guide, $43.50 BOM, full HTML instructions</a:t>
             </a:r>
             <a:endParaRPr lang="en-US" sz="1400" dirty="0"/>
           </a:p>
@@ -16413,7 +16858,7 @@
                 <a:ea typeface="Arial" pitchFamily="34" charset="-122"/>
                 <a:cs typeface="Arial" pitchFamily="34" charset="-120"/>
               </a:rPr>
-              <a:t>Live listening sessions — listen along with friends in real time</a:t>
+              <a:t>Wave 24: Full-screen now-playing UX, genre wheel, identification battles</a:t>
             </a:r>
             <a:endParaRPr lang="en-US" sz="1400" dirty="0"/>
           </a:p>
@@ -16435,7 +16880,7 @@
                 <a:ea typeface="Arial" pitchFamily="34" charset="-122"/>
                 <a:cs typeface="Arial" pitchFamily="34" charset="-120"/>
               </a:rPr>
-              <a:t>International shipping and multi-currency support</a:t>
+              <a:t>Wave 25: Listening party invites, social listening sessions</a:t>
             </a:r>
             <a:endParaRPr lang="en-US" sz="1400" dirty="0"/>
           </a:p>
@@ -16457,7 +16902,7 @@
                 <a:ea typeface="Arial" pitchFamily="34" charset="-122"/>
                 <a:cs typeface="Arial" pitchFamily="34" charset="-120"/>
               </a:rPr>
-              <a:t>Premium subscription tiers for power collectors</a:t>
+              <a:t>Wave 26: Loyalty points refinements, redeemable credits</a:t>
             </a:r>
             <a:endParaRPr lang="en-US" sz="1400" dirty="0"/>
           </a:p>
@@ -16479,7 +16924,7 @@
                 <a:ea typeface="Arial" pitchFamily="34" charset="-122"/>
                 <a:cs typeface="Arial" pitchFamily="34" charset="-120"/>
               </a:rPr>
-              <a:t>Marketplace search ads and promoted listings</a:t>
+              <a:t>Wave 27: User engagement features, daily challenges, collector ranks</a:t>
             </a:r>
             <a:endParaRPr lang="en-US" sz="1400" dirty="0"/>
           </a:p>
@@ -16501,7 +16946,7 @@
                 <a:ea typeface="Arial" pitchFamily="34" charset="-122"/>
                 <a:cs typeface="Arial" pitchFamily="34" charset="-120"/>
               </a:rPr>
-              <a:t>Record label partnerships and exclusive drops</a:t>
+              <a:t>Wave 28: Featured listing placements, promoted seller storefronts</a:t>
             </a:r>
             <a:endParaRPr lang="en-US" sz="1400" dirty="0"/>
           </a:p>
@@ -16523,7 +16968,7 @@
                 <a:ea typeface="Arial" pitchFamily="34" charset="-122"/>
                 <a:cs typeface="Arial" pitchFamily="34" charset="-120"/>
               </a:rPr>
-              <a:t>Vinyl Buddy retail sales and distribution</a:t>
+              <a:t>Wave 29: Final comprehensive deck, 2,000+ improvements, 290+ endpoints</a:t>
             </a:r>
             <a:endParaRPr lang="en-US" sz="1400" dirty="0"/>
           </a:p>
@@ -16589,8 +17034,8 @@
         </p:nvSpPr>
         <p:spPr>
           <a:xfrm>
-            <a:off x="731520" y="1097280"/>
-            <a:ext cx="10515600" cy="1097280"/>
+            <a:off x="731520" y="365760"/>
+            <a:ext cx="10515600" cy="731520"/>
           </a:xfrm>
           <a:prstGeom prst="rect">
             <a:avLst/>
@@ -16602,11 +17047,11 @@
           <a:bodyPr wrap="square" rtlCol="0" anchor="ctr"/>
           <a:lstStyle/>
           <a:p>
-            <a:pPr algn="ctr" indent="0" marL="0">
+            <a:pPr indent="0" marL="0">
               <a:buNone/>
             </a:pPr>
             <a:r>
-              <a:rPr lang="en-US" sz="5600" b="1" dirty="0">
+              <a:rPr lang="en-US" sz="3200" b="1" dirty="0">
                 <a:solidFill>
                   <a:srgbClr val="FFFFFF"/>
                 </a:solidFill>
@@ -16614,251 +17059,22 @@
                 <a:ea typeface="Arial" pitchFamily="34" charset="-122"/>
                 <a:cs typeface="Arial" pitchFamily="34" charset="-120"/>
               </a:rPr>
-              <a:t>GrooveStack</a:t>
-            </a:r>
-            <a:endParaRPr lang="en-US" sz="5600" dirty="0"/>
-          </a:p>
-        </p:txBody>
-      </p:sp>
-      <p:sp>
-        <p:nvSpPr>
-          <p:cNvPr id="4" name="Text 2"/>
-          <p:cNvSpPr/>
-          <p:nvPr/>
-        </p:nvSpPr>
-        <p:spPr>
-          <a:xfrm>
-            <a:off x="731520" y="2103120"/>
-            <a:ext cx="10515600" cy="640080"/>
-          </a:xfrm>
-          <a:prstGeom prst="rect">
-            <a:avLst/>
-          </a:prstGeom>
-          <a:noFill/>
-          <a:ln/>
-        </p:spPr>
-        <p:txBody>
-          <a:bodyPr wrap="square" rtlCol="0" anchor="ctr"/>
-          <a:lstStyle/>
-          <a:p>
-            <a:pPr algn="ctr" indent="0" marL="0">
-              <a:buNone/>
-            </a:pPr>
-            <a:r>
-              <a:rPr lang="en-US" sz="2800" dirty="0">
-                <a:solidFill>
-                  <a:srgbClr val="0EA5E9"/>
-                </a:solidFill>
-                <a:latin typeface="Arial" pitchFamily="34" charset="0"/>
-                <a:ea typeface="Arial" pitchFamily="34" charset="-122"/>
-                <a:cs typeface="Arial" pitchFamily="34" charset="-120"/>
-              </a:rPr>
-              <a:t>+ Vinyl Buddy</a:t>
-            </a:r>
-            <a:endParaRPr lang="en-US" sz="2800" dirty="0"/>
-          </a:p>
-        </p:txBody>
-      </p:sp>
-      <p:sp>
-        <p:nvSpPr>
-          <p:cNvPr id="5" name="Text 3"/>
-          <p:cNvSpPr/>
-          <p:nvPr/>
-        </p:nvSpPr>
-        <p:spPr>
-          <a:xfrm>
-            <a:off x="731520" y="3017520"/>
-            <a:ext cx="10515600" cy="640080"/>
-          </a:xfrm>
-          <a:prstGeom prst="rect">
-            <a:avLst/>
-          </a:prstGeom>
-          <a:noFill/>
-          <a:ln/>
-        </p:spPr>
-        <p:txBody>
-          <a:bodyPr wrap="square" rtlCol="0" anchor="ctr"/>
-          <a:lstStyle/>
-          <a:p>
-            <a:pPr algn="ctr" indent="0" marL="0">
-              <a:buNone/>
-            </a:pPr>
-            <a:r>
-              <a:rPr lang="en-US" sz="2200" dirty="0">
-                <a:solidFill>
-                  <a:srgbClr val="D4D4D8"/>
-                </a:solidFill>
-                <a:latin typeface="Arial" pitchFamily="34" charset="0"/>
-                <a:ea typeface="Arial" pitchFamily="34" charset="-122"/>
-                <a:cs typeface="Arial" pitchFamily="34" charset="-120"/>
-              </a:rPr>
-              <a:t>Where Vinyl Lives</a:t>
-            </a:r>
-            <a:endParaRPr lang="en-US" sz="2200" dirty="0"/>
-          </a:p>
-        </p:txBody>
-      </p:sp>
-      <p:sp>
-        <p:nvSpPr>
-          <p:cNvPr id="6" name="Text 4"/>
-          <p:cNvSpPr/>
-          <p:nvPr/>
-        </p:nvSpPr>
-        <p:spPr>
-          <a:xfrm>
-            <a:off x="731520" y="3931920"/>
-            <a:ext cx="10515600" cy="1371600"/>
-          </a:xfrm>
-          <a:prstGeom prst="rect">
-            <a:avLst/>
-          </a:prstGeom>
-          <a:noFill/>
-          <a:ln/>
-        </p:spPr>
-        <p:txBody>
-          <a:bodyPr wrap="square" rtlCol="0" anchor="ctr"/>
-          <a:lstStyle/>
-          <a:p>
-            <a:pPr algn="ctr" indent="0" marL="0">
-              <a:lnSpc>
-                <a:spcPct val="150000"/>
-              </a:lnSpc>
-              <a:buNone/>
-            </a:pPr>
-            <a:r>
-              <a:rPr lang="en-US" sz="1600" dirty="0">
-                <a:solidFill>
-                  <a:srgbClr val="22C55E"/>
-                </a:solidFill>
-                <a:latin typeface="Arial" pitchFamily="34" charset="0"/>
-                <a:ea typeface="Arial" pitchFamily="34" charset="-122"/>
-                <a:cs typeface="Arial" pitchFamily="34" charset="-120"/>
-              </a:rPr>
-              <a:t>1,800+ improvements  •  275+ API endpoints  •  20 waves</a:t>
-            </a:r>
-            <a:pPr algn="ctr" indent="0" marL="0">
-              <a:lnSpc>
-                <a:spcPct val="150000"/>
-              </a:lnSpc>
-              <a:buNone/>
-            </a:pPr>
-            <a:r>
-              <a:rPr lang="en-US" sz="1600" dirty="0">
-                <a:solidFill>
-                  <a:srgbClr val="000000"/>
-                </a:solidFill>
-                <a:latin typeface="Arial" pitchFamily="34" charset="0"/>
-                <a:ea typeface="Arial" pitchFamily="34" charset="-122"/>
-                <a:cs typeface="Arial" pitchFamily="34" charset="-120"/>
-              </a:rPr>
-              <a:t>
-</a:t>
-            </a:r>
-            <a:pPr algn="ctr" indent="0" marL="0">
-              <a:lnSpc>
-                <a:spcPct val="150000"/>
-              </a:lnSpc>
-              <a:buNone/>
-            </a:pPr>
-            <a:r>
-              <a:rPr lang="en-US" sz="1800" dirty="0">
-                <a:solidFill>
-                  <a:srgbClr val="FFFFFF"/>
-                </a:solidFill>
-                <a:latin typeface="Arial" pitchFamily="34" charset="0"/>
-                <a:ea typeface="Arial" pitchFamily="34" charset="-122"/>
-                <a:cs typeface="Arial" pitchFamily="34" charset="-120"/>
-              </a:rPr>
-              <a:t>groovestack.vercel.app</a:t>
-            </a:r>
-            <a:pPr algn="ctr" indent="0" marL="0">
-              <a:lnSpc>
-                <a:spcPct val="150000"/>
-              </a:lnSpc>
-              <a:buNone/>
-            </a:pPr>
-            <a:r>
-              <a:rPr lang="en-US" sz="1600" dirty="0">
-                <a:solidFill>
-                  <a:srgbClr val="000000"/>
-                </a:solidFill>
-                <a:latin typeface="Arial" pitchFamily="34" charset="0"/>
-                <a:ea typeface="Arial" pitchFamily="34" charset="-122"/>
-                <a:cs typeface="Arial" pitchFamily="34" charset="-120"/>
-              </a:rPr>
-              <a:t>
-</a:t>
-            </a:r>
-            <a:pPr algn="ctr" indent="0" marL="0">
-              <a:lnSpc>
-                <a:spcPct val="150000"/>
-              </a:lnSpc>
-              <a:buNone/>
-            </a:pPr>
-            <a:r>
-              <a:rPr lang="en-US" sz="1600" dirty="0">
-                <a:solidFill>
-                  <a:srgbClr val="A1A1AA"/>
-                </a:solidFill>
-                <a:latin typeface="Arial" pitchFamily="34" charset="0"/>
-                <a:ea typeface="Arial" pitchFamily="34" charset="-122"/>
-                <a:cs typeface="Arial" pitchFamily="34" charset="-120"/>
-              </a:rPr>
-              <a:t>github.com/colelevy08/groovestack</a:t>
-            </a:r>
-            <a:endParaRPr lang="en-US" sz="1600" dirty="0"/>
-          </a:p>
-        </p:txBody>
-      </p:sp>
-      <p:sp>
-        <p:nvSpPr>
-          <p:cNvPr id="7" name="Text 5"/>
-          <p:cNvSpPr/>
-          <p:nvPr/>
-        </p:nvSpPr>
-        <p:spPr>
-          <a:xfrm>
-            <a:off x="731520" y="5303520"/>
-            <a:ext cx="10515600" cy="548640"/>
-          </a:xfrm>
-          <a:prstGeom prst="rect">
-            <a:avLst/>
-          </a:prstGeom>
-          <a:noFill/>
-          <a:ln/>
-        </p:spPr>
-        <p:txBody>
-          <a:bodyPr wrap="square" rtlCol="0" anchor="ctr"/>
-          <a:lstStyle/>
-          <a:p>
-            <a:pPr algn="ctr" indent="0" marL="0">
-              <a:buNone/>
-            </a:pPr>
-            <a:r>
-              <a:rPr lang="en-US" sz="1800" dirty="0">
-                <a:solidFill>
-                  <a:srgbClr val="A1A1AA"/>
-                </a:solidFill>
-                <a:latin typeface="Arial" pitchFamily="34" charset="0"/>
-                <a:ea typeface="Arial" pitchFamily="34" charset="-122"/>
-                <a:cs typeface="Arial" pitchFamily="34" charset="-120"/>
-              </a:rPr>
-              <a:t>Thank you!</a:t>
-            </a:r>
-            <a:endParaRPr lang="en-US" sz="1800" dirty="0"/>
-          </a:p>
-        </p:txBody>
-      </p:sp>
-      <p:sp>
-        <p:nvSpPr>
-          <p:cNvPr id="8" name="Shape 6"/>
-          <p:cNvSpPr/>
-          <p:nvPr/>
-        </p:nvSpPr>
-        <p:spPr>
-          <a:xfrm>
-            <a:off x="0" y="6803136"/>
-            <a:ext cx="12188952" cy="54864"/>
+              <a:t>Vinyl Buddy Build Guide</a:t>
+            </a:r>
+            <a:endParaRPr lang="en-US" sz="3200" dirty="0"/>
+          </a:p>
+        </p:txBody>
+      </p:sp>
+      <p:sp>
+        <p:nvSpPr>
+          <p:cNvPr id="4" name="Shape 2"/>
+          <p:cNvSpPr/>
+          <p:nvPr/>
+        </p:nvSpPr>
+        <p:spPr>
+          <a:xfrm>
+            <a:off x="731520" y="1143000"/>
+            <a:ext cx="2286000" cy="36576"/>
           </a:xfrm>
           <a:prstGeom prst="rect">
             <a:avLst/>
@@ -16868,6 +17084,1959 @@
           </a:solidFill>
           <a:ln/>
         </p:spPr>
+      </p:sp>
+      <p:sp>
+        <p:nvSpPr>
+          <p:cNvPr id="5" name="Shape 3"/>
+          <p:cNvSpPr/>
+          <p:nvPr/>
+        </p:nvSpPr>
+        <p:spPr>
+          <a:xfrm>
+            <a:off x="731520" y="1463040"/>
+            <a:ext cx="5120640" cy="4846320"/>
+          </a:xfrm>
+          <a:prstGeom prst="rect">
+            <a:avLst>
+              <a:gd name="adj" fmla="val 1887"/>
+            </a:avLst>
+          </a:prstGeom>
+          <a:solidFill>
+            <a:srgbClr val="18181B"/>
+          </a:solidFill>
+          <a:ln/>
+        </p:spPr>
+      </p:sp>
+      <p:sp>
+        <p:nvSpPr>
+          <p:cNvPr id="6" name="Text 4"/>
+          <p:cNvSpPr/>
+          <p:nvPr/>
+        </p:nvSpPr>
+        <p:spPr>
+          <a:xfrm>
+            <a:off x="1005840" y="1600200"/>
+            <a:ext cx="4572000" cy="457200"/>
+          </a:xfrm>
+          <a:prstGeom prst="rect">
+            <a:avLst/>
+          </a:prstGeom>
+          <a:noFill/>
+          <a:ln/>
+        </p:spPr>
+        <p:txBody>
+          <a:bodyPr wrap="square" rtlCol="0" anchor="ctr"/>
+          <a:lstStyle/>
+          <a:p>
+            <a:pPr indent="0" marL="0">
+              <a:buNone/>
+            </a:pPr>
+            <a:r>
+              <a:rPr lang="en-US" sz="1800" b="1" dirty="0">
+                <a:solidFill>
+                  <a:srgbClr val="0EA5E9"/>
+                </a:solidFill>
+                <a:latin typeface="Arial" pitchFamily="34" charset="0"/>
+                <a:ea typeface="Arial" pitchFamily="34" charset="-122"/>
+                <a:cs typeface="Arial" pitchFamily="34" charset="-120"/>
+              </a:rPr>
+              <a:t>Components ($43.50 Total)</a:t>
+            </a:r>
+            <a:endParaRPr lang="en-US" sz="1800" dirty="0"/>
+          </a:p>
+        </p:txBody>
+      </p:sp>
+      <p:sp>
+        <p:nvSpPr>
+          <p:cNvPr id="7" name="Text 5"/>
+          <p:cNvSpPr/>
+          <p:nvPr/>
+        </p:nvSpPr>
+        <p:spPr>
+          <a:xfrm>
+            <a:off x="1005840" y="2148840"/>
+            <a:ext cx="4572000" cy="4023360"/>
+          </a:xfrm>
+          <a:prstGeom prst="rect">
+            <a:avLst/>
+          </a:prstGeom>
+          <a:noFill/>
+          <a:ln/>
+        </p:spPr>
+        <p:txBody>
+          <a:bodyPr wrap="square" rtlCol="0" anchor="t"/>
+          <a:lstStyle/>
+          <a:p>
+            <a:pPr>
+              <a:lnSpc>
+                <a:spcPct val="115000"/>
+              </a:lnSpc>
+              <a:spcAft>
+                <a:spcPts val="400"/>
+              </a:spcAft>
+            </a:pPr>
+            <a:r>
+              <a:rPr lang="en-US" sz="1300" dirty="0">
+                <a:solidFill>
+                  <a:srgbClr val="A1A1AA"/>
+                </a:solidFill>
+                <a:latin typeface="Arial" pitchFamily="34" charset="0"/>
+                <a:ea typeface="Arial" pitchFamily="34" charset="-122"/>
+                <a:cs typeface="Arial" pitchFamily="34" charset="-120"/>
+              </a:rPr>
+              <a:t>ESP32-DevKitC V4 — ~$10</a:t>
+            </a:r>
+            <a:endParaRPr lang="en-US" sz="1300" dirty="0"/>
+          </a:p>
+          <a:p>
+            <a:pPr>
+              <a:lnSpc>
+                <a:spcPct val="115000"/>
+              </a:lnSpc>
+              <a:spcAft>
+                <a:spcPts val="400"/>
+              </a:spcAft>
+            </a:pPr>
+            <a:r>
+              <a:rPr lang="en-US" sz="1300" dirty="0">
+                <a:solidFill>
+                  <a:srgbClr val="A1A1AA"/>
+                </a:solidFill>
+                <a:latin typeface="Arial" pitchFamily="34" charset="0"/>
+                <a:ea typeface="Arial" pitchFamily="34" charset="-122"/>
+                <a:cs typeface="Arial" pitchFamily="34" charset="-120"/>
+              </a:rPr>
+              <a:t>INMP441 I2S MEMS Microphone — ~$3</a:t>
+            </a:r>
+            <a:endParaRPr lang="en-US" sz="1300" dirty="0"/>
+          </a:p>
+          <a:p>
+            <a:pPr>
+              <a:lnSpc>
+                <a:spcPct val="115000"/>
+              </a:lnSpc>
+              <a:spcAft>
+                <a:spcPts val="400"/>
+              </a:spcAft>
+            </a:pPr>
+            <a:r>
+              <a:rPr lang="en-US" sz="1300" dirty="0">
+                <a:solidFill>
+                  <a:srgbClr val="A1A1AA"/>
+                </a:solidFill>
+                <a:latin typeface="Arial" pitchFamily="34" charset="0"/>
+                <a:ea typeface="Arial" pitchFamily="34" charset="-122"/>
+                <a:cs typeface="Arial" pitchFamily="34" charset="-120"/>
+              </a:rPr>
+              <a:t>SSD1306 OLED 128x64 Display — ~$5</a:t>
+            </a:r>
+            <a:endParaRPr lang="en-US" sz="1300" dirty="0"/>
+          </a:p>
+          <a:p>
+            <a:pPr>
+              <a:lnSpc>
+                <a:spcPct val="115000"/>
+              </a:lnSpc>
+              <a:spcAft>
+                <a:spcPts val="400"/>
+              </a:spcAft>
+            </a:pPr>
+            <a:r>
+              <a:rPr lang="en-US" sz="1300" dirty="0">
+                <a:solidFill>
+                  <a:srgbClr val="A1A1AA"/>
+                </a:solidFill>
+                <a:latin typeface="Arial" pitchFamily="34" charset="0"/>
+                <a:ea typeface="Arial" pitchFamily="34" charset="-122"/>
+                <a:cs typeface="Arial" pitchFamily="34" charset="-120"/>
+              </a:rPr>
+              <a:t>APDS-9960 Gesture Sensor — ~$6</a:t>
+            </a:r>
+            <a:endParaRPr lang="en-US" sz="1300" dirty="0"/>
+          </a:p>
+          <a:p>
+            <a:pPr>
+              <a:lnSpc>
+                <a:spcPct val="115000"/>
+              </a:lnSpc>
+              <a:spcAft>
+                <a:spcPts val="400"/>
+              </a:spcAft>
+            </a:pPr>
+            <a:r>
+              <a:rPr lang="en-US" sz="1300" dirty="0">
+                <a:solidFill>
+                  <a:srgbClr val="A1A1AA"/>
+                </a:solidFill>
+                <a:latin typeface="Arial" pitchFamily="34" charset="0"/>
+                <a:ea typeface="Arial" pitchFamily="34" charset="-122"/>
+                <a:cs typeface="Arial" pitchFamily="34" charset="-120"/>
+              </a:rPr>
+              <a:t>MicroSD Card Module — ~$2</a:t>
+            </a:r>
+            <a:endParaRPr lang="en-US" sz="1300" dirty="0"/>
+          </a:p>
+          <a:p>
+            <a:pPr>
+              <a:lnSpc>
+                <a:spcPct val="115000"/>
+              </a:lnSpc>
+              <a:spcAft>
+                <a:spcPts val="400"/>
+              </a:spcAft>
+            </a:pPr>
+            <a:r>
+              <a:rPr lang="en-US" sz="1300" dirty="0">
+                <a:solidFill>
+                  <a:srgbClr val="A1A1AA"/>
+                </a:solidFill>
+                <a:latin typeface="Arial" pitchFamily="34" charset="0"/>
+                <a:ea typeface="Arial" pitchFamily="34" charset="-122"/>
+                <a:cs typeface="Arial" pitchFamily="34" charset="-120"/>
+              </a:rPr>
+              <a:t>MicroSD Card (16GB) — ~$5</a:t>
+            </a:r>
+            <a:endParaRPr lang="en-US" sz="1300" dirty="0"/>
+          </a:p>
+          <a:p>
+            <a:pPr>
+              <a:lnSpc>
+                <a:spcPct val="115000"/>
+              </a:lnSpc>
+              <a:spcAft>
+                <a:spcPts val="400"/>
+              </a:spcAft>
+            </a:pPr>
+            <a:r>
+              <a:rPr lang="en-US" sz="1300" dirty="0">
+                <a:solidFill>
+                  <a:srgbClr val="A1A1AA"/>
+                </a:solidFill>
+                <a:latin typeface="Arial" pitchFamily="34" charset="0"/>
+                <a:ea typeface="Arial" pitchFamily="34" charset="-122"/>
+                <a:cs typeface="Arial" pitchFamily="34" charset="-120"/>
+              </a:rPr>
+              <a:t>USB-C Cable + Breadboard + Wires — ~$8</a:t>
+            </a:r>
+            <a:endParaRPr lang="en-US" sz="1300" dirty="0"/>
+          </a:p>
+          <a:p>
+            <a:pPr>
+              <a:lnSpc>
+                <a:spcPct val="115000"/>
+              </a:lnSpc>
+              <a:spcAft>
+                <a:spcPts val="400"/>
+              </a:spcAft>
+            </a:pPr>
+            <a:r>
+              <a:rPr lang="en-US" sz="1300" dirty="0">
+                <a:solidFill>
+                  <a:srgbClr val="A1A1AA"/>
+                </a:solidFill>
+                <a:latin typeface="Arial" pitchFamily="34" charset="0"/>
+                <a:ea typeface="Arial" pitchFamily="34" charset="-122"/>
+                <a:cs typeface="Arial" pitchFamily="34" charset="-120"/>
+              </a:rPr>
+              <a:t>Optional: 3D-printed enclosure — ~$4.50</a:t>
+            </a:r>
+            <a:endParaRPr lang="en-US" sz="1300" dirty="0"/>
+          </a:p>
+        </p:txBody>
+      </p:sp>
+      <p:sp>
+        <p:nvSpPr>
+          <p:cNvPr id="8" name="Shape 6"/>
+          <p:cNvSpPr/>
+          <p:nvPr/>
+        </p:nvSpPr>
+        <p:spPr>
+          <a:xfrm>
+            <a:off x="6309360" y="1463040"/>
+            <a:ext cx="5120640" cy="4846320"/>
+          </a:xfrm>
+          <a:prstGeom prst="rect">
+            <a:avLst>
+              <a:gd name="adj" fmla="val 1887"/>
+            </a:avLst>
+          </a:prstGeom>
+          <a:solidFill>
+            <a:srgbClr val="18181B"/>
+          </a:solidFill>
+          <a:ln/>
+        </p:spPr>
+      </p:sp>
+      <p:sp>
+        <p:nvSpPr>
+          <p:cNvPr id="9" name="Text 7"/>
+          <p:cNvSpPr/>
+          <p:nvPr/>
+        </p:nvSpPr>
+        <p:spPr>
+          <a:xfrm>
+            <a:off x="6583680" y="1600200"/>
+            <a:ext cx="4572000" cy="457200"/>
+          </a:xfrm>
+          <a:prstGeom prst="rect">
+            <a:avLst/>
+          </a:prstGeom>
+          <a:noFill/>
+          <a:ln/>
+        </p:spPr>
+        <p:txBody>
+          <a:bodyPr wrap="square" rtlCol="0" anchor="ctr"/>
+          <a:lstStyle/>
+          <a:p>
+            <a:pPr indent="0" marL="0">
+              <a:buNone/>
+            </a:pPr>
+            <a:r>
+              <a:rPr lang="en-US" sz="1800" b="1" dirty="0">
+                <a:solidFill>
+                  <a:srgbClr val="0EA5E9"/>
+                </a:solidFill>
+                <a:latin typeface="Arial" pitchFamily="34" charset="0"/>
+                <a:ea typeface="Arial" pitchFamily="34" charset="-122"/>
+                <a:cs typeface="Arial" pitchFamily="34" charset="-120"/>
+              </a:rPr>
+              <a:t>Build Guide Included</a:t>
+            </a:r>
+            <a:endParaRPr lang="en-US" sz="1800" dirty="0"/>
+          </a:p>
+        </p:txBody>
+      </p:sp>
+      <p:sp>
+        <p:nvSpPr>
+          <p:cNvPr id="10" name="Text 8"/>
+          <p:cNvSpPr/>
+          <p:nvPr/>
+        </p:nvSpPr>
+        <p:spPr>
+          <a:xfrm>
+            <a:off x="6583680" y="2148840"/>
+            <a:ext cx="4572000" cy="4023360"/>
+          </a:xfrm>
+          <a:prstGeom prst="rect">
+            <a:avLst/>
+          </a:prstGeom>
+          <a:noFill/>
+          <a:ln/>
+        </p:spPr>
+        <p:txBody>
+          <a:bodyPr wrap="square" rtlCol="0" anchor="t"/>
+          <a:lstStyle/>
+          <a:p>
+            <a:pPr>
+              <a:lnSpc>
+                <a:spcPct val="115000"/>
+              </a:lnSpc>
+              <a:spcAft>
+                <a:spcPts val="400"/>
+              </a:spcAft>
+            </a:pPr>
+            <a:r>
+              <a:rPr lang="en-US" sz="1300" dirty="0">
+                <a:solidFill>
+                  <a:srgbClr val="A1A1AA"/>
+                </a:solidFill>
+                <a:latin typeface="Arial" pitchFamily="34" charset="0"/>
+                <a:ea typeface="Arial" pitchFamily="34" charset="-122"/>
+                <a:cs typeface="Arial" pitchFamily="34" charset="-120"/>
+              </a:rPr>
+              <a:t>Full HTML build guide with step-by-step photos</a:t>
+            </a:r>
+            <a:endParaRPr lang="en-US" sz="1300" dirty="0"/>
+          </a:p>
+          <a:p>
+            <a:pPr>
+              <a:lnSpc>
+                <a:spcPct val="115000"/>
+              </a:lnSpc>
+              <a:spcAft>
+                <a:spcPts val="400"/>
+              </a:spcAft>
+            </a:pPr>
+            <a:r>
+              <a:rPr lang="en-US" sz="1300" dirty="0">
+                <a:solidFill>
+                  <a:srgbClr val="A1A1AA"/>
+                </a:solidFill>
+                <a:latin typeface="Arial" pitchFamily="34" charset="0"/>
+                <a:ea typeface="Arial" pitchFamily="34" charset="-122"/>
+                <a:cs typeface="Arial" pitchFamily="34" charset="-120"/>
+              </a:rPr>
+              <a:t>Wiring diagrams for all components</a:t>
+            </a:r>
+            <a:endParaRPr lang="en-US" sz="1300" dirty="0"/>
+          </a:p>
+          <a:p>
+            <a:pPr>
+              <a:lnSpc>
+                <a:spcPct val="115000"/>
+              </a:lnSpc>
+              <a:spcAft>
+                <a:spcPts val="400"/>
+              </a:spcAft>
+            </a:pPr>
+            <a:r>
+              <a:rPr lang="en-US" sz="1300" dirty="0">
+                <a:solidFill>
+                  <a:srgbClr val="A1A1AA"/>
+                </a:solidFill>
+                <a:latin typeface="Arial" pitchFamily="34" charset="0"/>
+                <a:ea typeface="Arial" pitchFamily="34" charset="-122"/>
+                <a:cs typeface="Arial" pitchFamily="34" charset="-120"/>
+              </a:rPr>
+              <a:t>Breadboard layout and pin mapping</a:t>
+            </a:r>
+            <a:endParaRPr lang="en-US" sz="1300" dirty="0"/>
+          </a:p>
+          <a:p>
+            <a:pPr>
+              <a:lnSpc>
+                <a:spcPct val="115000"/>
+              </a:lnSpc>
+              <a:spcAft>
+                <a:spcPts val="400"/>
+              </a:spcAft>
+            </a:pPr>
+            <a:r>
+              <a:rPr lang="en-US" sz="1300" dirty="0">
+                <a:solidFill>
+                  <a:srgbClr val="A1A1AA"/>
+                </a:solidFill>
+                <a:latin typeface="Arial" pitchFamily="34" charset="0"/>
+                <a:ea typeface="Arial" pitchFamily="34" charset="-122"/>
+                <a:cs typeface="Arial" pitchFamily="34" charset="-120"/>
+              </a:rPr>
+              <a:t>Firmware flashing instructions</a:t>
+            </a:r>
+            <a:endParaRPr lang="en-US" sz="1300" dirty="0"/>
+          </a:p>
+          <a:p>
+            <a:pPr>
+              <a:lnSpc>
+                <a:spcPct val="115000"/>
+              </a:lnSpc>
+              <a:spcAft>
+                <a:spcPts val="400"/>
+              </a:spcAft>
+            </a:pPr>
+            <a:r>
+              <a:rPr lang="en-US" sz="1300" dirty="0">
+                <a:solidFill>
+                  <a:srgbClr val="A1A1AA"/>
+                </a:solidFill>
+                <a:latin typeface="Arial" pitchFamily="34" charset="0"/>
+                <a:ea typeface="Arial" pitchFamily="34" charset="-122"/>
+                <a:cs typeface="Arial" pitchFamily="34" charset="-120"/>
+              </a:rPr>
+              <a:t>WiFi and BLE configuration walkthrough</a:t>
+            </a:r>
+            <a:endParaRPr lang="en-US" sz="1300" dirty="0"/>
+          </a:p>
+          <a:p>
+            <a:pPr>
+              <a:lnSpc>
+                <a:spcPct val="115000"/>
+              </a:lnSpc>
+              <a:spcAft>
+                <a:spcPts val="400"/>
+              </a:spcAft>
+            </a:pPr>
+            <a:r>
+              <a:rPr lang="en-US" sz="1300" dirty="0">
+                <a:solidFill>
+                  <a:srgbClr val="A1A1AA"/>
+                </a:solidFill>
+                <a:latin typeface="Arial" pitchFamily="34" charset="0"/>
+                <a:ea typeface="Arial" pitchFamily="34" charset="-122"/>
+                <a:cs typeface="Arial" pitchFamily="34" charset="-120"/>
+              </a:rPr>
+              <a:t>Audio calibration steps</a:t>
+            </a:r>
+            <a:endParaRPr lang="en-US" sz="1300" dirty="0"/>
+          </a:p>
+          <a:p>
+            <a:pPr>
+              <a:lnSpc>
+                <a:spcPct val="115000"/>
+              </a:lnSpc>
+              <a:spcAft>
+                <a:spcPts val="400"/>
+              </a:spcAft>
+            </a:pPr>
+            <a:r>
+              <a:rPr lang="en-US" sz="1300" dirty="0">
+                <a:solidFill>
+                  <a:srgbClr val="A1A1AA"/>
+                </a:solidFill>
+                <a:latin typeface="Arial" pitchFamily="34" charset="0"/>
+                <a:ea typeface="Arial" pitchFamily="34" charset="-122"/>
+                <a:cs typeface="Arial" pitchFamily="34" charset="-120"/>
+              </a:rPr>
+              <a:t>Troubleshooting FAQ</a:t>
+            </a:r>
+            <a:endParaRPr lang="en-US" sz="1300" dirty="0"/>
+          </a:p>
+          <a:p>
+            <a:pPr>
+              <a:lnSpc>
+                <a:spcPct val="115000"/>
+              </a:lnSpc>
+              <a:spcAft>
+                <a:spcPts val="400"/>
+              </a:spcAft>
+            </a:pPr>
+            <a:r>
+              <a:rPr lang="en-US" sz="1300" dirty="0">
+                <a:solidFill>
+                  <a:srgbClr val="A1A1AA"/>
+                </a:solidFill>
+                <a:latin typeface="Arial" pitchFamily="34" charset="0"/>
+                <a:ea typeface="Arial" pitchFamily="34" charset="-122"/>
+                <a:cs typeface="Arial" pitchFamily="34" charset="-120"/>
+              </a:rPr>
+              <a:t>No soldering required — breadboard friendly</a:t>
+            </a:r>
+            <a:endParaRPr lang="en-US" sz="1300" dirty="0"/>
+          </a:p>
+        </p:txBody>
+      </p:sp>
+    </p:spTree>
+  </p:cSld>
+  <p:clrMapOvr>
+    <a:masterClrMapping/>
+  </p:clrMapOvr>
+</p:sld>
+</file>
+
+<file path=ppt/slides/slide37.xml><?xml version="1.0" encoding="utf-8"?>
+<p:sld xmlns:a="http://schemas.openxmlformats.org/drawingml/2006/main" xmlns:r="http://schemas.openxmlformats.org/officeDocument/2006/relationships" xmlns:p="http://schemas.openxmlformats.org/presentationml/2006/main">
+  <p:cSld name="Slide 37">
+    <p:bg>
+      <p:bgPr>
+        <a:solidFill>
+          <a:srgbClr val="0F1117"/>
+        </a:solidFill>
+      </p:bgPr>
+    </p:bg>
+    <p:spTree>
+      <p:nvGrpSpPr>
+        <p:cNvPr id="1" name=""/>
+        <p:cNvGrpSpPr/>
+        <p:nvPr/>
+      </p:nvGrpSpPr>
+      <p:grpSpPr>
+        <a:xfrm>
+          <a:off x="0" y="0"/>
+          <a:ext cx="0" cy="0"/>
+          <a:chOff x="0" y="0"/>
+          <a:chExt cx="0" cy="0"/>
+        </a:xfrm>
+      </p:grpSpPr>
+      <p:sp>
+        <p:nvSpPr>
+          <p:cNvPr id="2" name="Shape 0"/>
+          <p:cNvSpPr/>
+          <p:nvPr/>
+        </p:nvSpPr>
+        <p:spPr>
+          <a:xfrm>
+            <a:off x="0" y="0"/>
+            <a:ext cx="12188952" cy="54864"/>
+          </a:xfrm>
+          <a:prstGeom prst="rect">
+            <a:avLst/>
+          </a:prstGeom>
+          <a:solidFill>
+            <a:srgbClr val="0EA5E9"/>
+          </a:solidFill>
+          <a:ln/>
+        </p:spPr>
+      </p:sp>
+      <p:sp>
+        <p:nvSpPr>
+          <p:cNvPr id="3" name="Text 1"/>
+          <p:cNvSpPr/>
+          <p:nvPr/>
+        </p:nvSpPr>
+        <p:spPr>
+          <a:xfrm>
+            <a:off x="731520" y="365760"/>
+            <a:ext cx="10515600" cy="731520"/>
+          </a:xfrm>
+          <a:prstGeom prst="rect">
+            <a:avLst/>
+          </a:prstGeom>
+          <a:noFill/>
+          <a:ln/>
+        </p:spPr>
+        <p:txBody>
+          <a:bodyPr wrap="square" rtlCol="0" anchor="ctr"/>
+          <a:lstStyle/>
+          <a:p>
+            <a:pPr indent="0" marL="0">
+              <a:buNone/>
+            </a:pPr>
+            <a:r>
+              <a:rPr lang="en-US" sz="3200" b="1" dirty="0">
+                <a:solidFill>
+                  <a:srgbClr val="FFFFFF"/>
+                </a:solidFill>
+                <a:latin typeface="Arial" pitchFamily="34" charset="0"/>
+                <a:ea typeface="Arial" pitchFamily="34" charset="-122"/>
+                <a:cs typeface="Arial" pitchFamily="34" charset="-120"/>
+              </a:rPr>
+              <a:t>Vinyl Buddy UX Experience</a:t>
+            </a:r>
+            <a:endParaRPr lang="en-US" sz="3200" dirty="0"/>
+          </a:p>
+        </p:txBody>
+      </p:sp>
+      <p:sp>
+        <p:nvSpPr>
+          <p:cNvPr id="4" name="Shape 2"/>
+          <p:cNvSpPr/>
+          <p:nvPr/>
+        </p:nvSpPr>
+        <p:spPr>
+          <a:xfrm>
+            <a:off x="731520" y="1143000"/>
+            <a:ext cx="2286000" cy="36576"/>
+          </a:xfrm>
+          <a:prstGeom prst="rect">
+            <a:avLst/>
+          </a:prstGeom>
+          <a:solidFill>
+            <a:srgbClr val="0EA5E9"/>
+          </a:solidFill>
+          <a:ln/>
+        </p:spPr>
+      </p:sp>
+      <p:sp>
+        <p:nvSpPr>
+          <p:cNvPr id="5" name="Shape 3"/>
+          <p:cNvSpPr/>
+          <p:nvPr/>
+        </p:nvSpPr>
+        <p:spPr>
+          <a:xfrm>
+            <a:off x="731520" y="1463040"/>
+            <a:ext cx="5120640" cy="4846320"/>
+          </a:xfrm>
+          <a:prstGeom prst="rect">
+            <a:avLst>
+              <a:gd name="adj" fmla="val 1887"/>
+            </a:avLst>
+          </a:prstGeom>
+          <a:solidFill>
+            <a:srgbClr val="18181B"/>
+          </a:solidFill>
+          <a:ln/>
+        </p:spPr>
+      </p:sp>
+      <p:sp>
+        <p:nvSpPr>
+          <p:cNvPr id="6" name="Text 4"/>
+          <p:cNvSpPr/>
+          <p:nvPr/>
+        </p:nvSpPr>
+        <p:spPr>
+          <a:xfrm>
+            <a:off x="1005840" y="1600200"/>
+            <a:ext cx="4572000" cy="457200"/>
+          </a:xfrm>
+          <a:prstGeom prst="rect">
+            <a:avLst/>
+          </a:prstGeom>
+          <a:noFill/>
+          <a:ln/>
+        </p:spPr>
+        <p:txBody>
+          <a:bodyPr wrap="square" rtlCol="0" anchor="ctr"/>
+          <a:lstStyle/>
+          <a:p>
+            <a:pPr indent="0" marL="0">
+              <a:buNone/>
+            </a:pPr>
+            <a:r>
+              <a:rPr lang="en-US" sz="1800" b="1" dirty="0">
+                <a:solidFill>
+                  <a:srgbClr val="0EA5E9"/>
+                </a:solidFill>
+                <a:latin typeface="Arial" pitchFamily="34" charset="0"/>
+                <a:ea typeface="Arial" pitchFamily="34" charset="-122"/>
+                <a:cs typeface="Arial" pitchFamily="34" charset="-120"/>
+              </a:rPr>
+              <a:t>Premium Now-Playing</a:t>
+            </a:r>
+            <a:endParaRPr lang="en-US" sz="1800" dirty="0"/>
+          </a:p>
+        </p:txBody>
+      </p:sp>
+      <p:sp>
+        <p:nvSpPr>
+          <p:cNvPr id="7" name="Text 5"/>
+          <p:cNvSpPr/>
+          <p:nvPr/>
+        </p:nvSpPr>
+        <p:spPr>
+          <a:xfrm>
+            <a:off x="1005840" y="2148840"/>
+            <a:ext cx="4572000" cy="4023360"/>
+          </a:xfrm>
+          <a:prstGeom prst="rect">
+            <a:avLst/>
+          </a:prstGeom>
+          <a:noFill/>
+          <a:ln/>
+        </p:spPr>
+        <p:txBody>
+          <a:bodyPr wrap="square" rtlCol="0" anchor="t"/>
+          <a:lstStyle/>
+          <a:p>
+            <a:pPr>
+              <a:lnSpc>
+                <a:spcPct val="115000"/>
+              </a:lnSpc>
+              <a:spcAft>
+                <a:spcPts val="400"/>
+              </a:spcAft>
+            </a:pPr>
+            <a:r>
+              <a:rPr lang="en-US" sz="1500" dirty="0">
+                <a:solidFill>
+                  <a:srgbClr val="A1A1AA"/>
+                </a:solidFill>
+                <a:latin typeface="Arial" pitchFamily="34" charset="0"/>
+                <a:ea typeface="Arial" pitchFamily="34" charset="-122"/>
+                <a:cs typeface="Arial" pitchFamily="34" charset="-120"/>
+              </a:rPr>
+              <a:t>Full-screen now-playing display with album art</a:t>
+            </a:r>
+            <a:endParaRPr lang="en-US" sz="1500" dirty="0"/>
+          </a:p>
+          <a:p>
+            <a:pPr>
+              <a:lnSpc>
+                <a:spcPct val="115000"/>
+              </a:lnSpc>
+              <a:spcAft>
+                <a:spcPts val="400"/>
+              </a:spcAft>
+            </a:pPr>
+            <a:r>
+              <a:rPr lang="en-US" sz="1500" dirty="0">
+                <a:solidFill>
+                  <a:srgbClr val="A1A1AA"/>
+                </a:solidFill>
+                <a:latin typeface="Arial" pitchFamily="34" charset="0"/>
+                <a:ea typeface="Arial" pitchFamily="34" charset="-122"/>
+                <a:cs typeface="Arial" pitchFamily="34" charset="-120"/>
+              </a:rPr>
+              <a:t>Animated equalizer visualization</a:t>
+            </a:r>
+            <a:endParaRPr lang="en-US" sz="1500" dirty="0"/>
+          </a:p>
+          <a:p>
+            <a:pPr>
+              <a:lnSpc>
+                <a:spcPct val="115000"/>
+              </a:lnSpc>
+              <a:spcAft>
+                <a:spcPts val="400"/>
+              </a:spcAft>
+            </a:pPr>
+            <a:r>
+              <a:rPr lang="en-US" sz="1500" dirty="0">
+                <a:solidFill>
+                  <a:srgbClr val="A1A1AA"/>
+                </a:solidFill>
+                <a:latin typeface="Arial" pitchFamily="34" charset="0"/>
+                <a:ea typeface="Arial" pitchFamily="34" charset="-122"/>
+                <a:cs typeface="Arial" pitchFamily="34" charset="-120"/>
+              </a:rPr>
+              <a:t>Track progress bar with elapsed/remaining time</a:t>
+            </a:r>
+            <a:endParaRPr lang="en-US" sz="1500" dirty="0"/>
+          </a:p>
+          <a:p>
+            <a:pPr>
+              <a:lnSpc>
+                <a:spcPct val="115000"/>
+              </a:lnSpc>
+              <a:spcAft>
+                <a:spcPts val="400"/>
+              </a:spcAft>
+            </a:pPr>
+            <a:r>
+              <a:rPr lang="en-US" sz="1500" dirty="0">
+                <a:solidFill>
+                  <a:srgbClr val="A1A1AA"/>
+                </a:solidFill>
+                <a:latin typeface="Arial" pitchFamily="34" charset="0"/>
+                <a:ea typeface="Arial" pitchFamily="34" charset="-122"/>
+                <a:cs typeface="Arial" pitchFamily="34" charset="-120"/>
+              </a:rPr>
+              <a:t>Artist, album, and track metadata display</a:t>
+            </a:r>
+            <a:endParaRPr lang="en-US" sz="1500" dirty="0"/>
+          </a:p>
+          <a:p>
+            <a:pPr>
+              <a:lnSpc>
+                <a:spcPct val="115000"/>
+              </a:lnSpc>
+              <a:spcAft>
+                <a:spcPts val="400"/>
+              </a:spcAft>
+            </a:pPr>
+            <a:r>
+              <a:rPr lang="en-US" sz="1500" dirty="0">
+                <a:solidFill>
+                  <a:srgbClr val="A1A1AA"/>
+                </a:solidFill>
+                <a:latin typeface="Arial" pitchFamily="34" charset="0"/>
+                <a:ea typeface="Arial" pitchFamily="34" charset="-122"/>
+                <a:cs typeface="Arial" pitchFamily="34" charset="-120"/>
+              </a:rPr>
+              <a:t>Swipe gestures for track control</a:t>
+            </a:r>
+            <a:endParaRPr lang="en-US" sz="1500" dirty="0"/>
+          </a:p>
+          <a:p>
+            <a:pPr>
+              <a:lnSpc>
+                <a:spcPct val="115000"/>
+              </a:lnSpc>
+              <a:spcAft>
+                <a:spcPts val="400"/>
+              </a:spcAft>
+            </a:pPr>
+            <a:r>
+              <a:rPr lang="en-US" sz="1500" dirty="0">
+                <a:solidFill>
+                  <a:srgbClr val="A1A1AA"/>
+                </a:solidFill>
+                <a:latin typeface="Arial" pitchFamily="34" charset="0"/>
+                <a:ea typeface="Arial" pitchFamily="34" charset="-122"/>
+                <a:cs typeface="Arial" pitchFamily="34" charset="-120"/>
+              </a:rPr>
+              <a:t>Background gradient from album art colors</a:t>
+            </a:r>
+            <a:endParaRPr lang="en-US" sz="1500" dirty="0"/>
+          </a:p>
+        </p:txBody>
+      </p:sp>
+      <p:sp>
+        <p:nvSpPr>
+          <p:cNvPr id="8" name="Shape 6"/>
+          <p:cNvSpPr/>
+          <p:nvPr/>
+        </p:nvSpPr>
+        <p:spPr>
+          <a:xfrm>
+            <a:off x="6309360" y="1463040"/>
+            <a:ext cx="5120640" cy="4846320"/>
+          </a:xfrm>
+          <a:prstGeom prst="rect">
+            <a:avLst>
+              <a:gd name="adj" fmla="val 1887"/>
+            </a:avLst>
+          </a:prstGeom>
+          <a:solidFill>
+            <a:srgbClr val="18181B"/>
+          </a:solidFill>
+          <a:ln/>
+        </p:spPr>
+      </p:sp>
+      <p:sp>
+        <p:nvSpPr>
+          <p:cNvPr id="9" name="Text 7"/>
+          <p:cNvSpPr/>
+          <p:nvPr/>
+        </p:nvSpPr>
+        <p:spPr>
+          <a:xfrm>
+            <a:off x="6583680" y="1600200"/>
+            <a:ext cx="4572000" cy="457200"/>
+          </a:xfrm>
+          <a:prstGeom prst="rect">
+            <a:avLst/>
+          </a:prstGeom>
+          <a:noFill/>
+          <a:ln/>
+        </p:spPr>
+        <p:txBody>
+          <a:bodyPr wrap="square" rtlCol="0" anchor="ctr"/>
+          <a:lstStyle/>
+          <a:p>
+            <a:pPr indent="0" marL="0">
+              <a:buNone/>
+            </a:pPr>
+            <a:r>
+              <a:rPr lang="en-US" sz="1800" b="1" dirty="0">
+                <a:solidFill>
+                  <a:srgbClr val="0EA5E9"/>
+                </a:solidFill>
+                <a:latin typeface="Arial" pitchFamily="34" charset="0"/>
+                <a:ea typeface="Arial" pitchFamily="34" charset="-122"/>
+                <a:cs typeface="Arial" pitchFamily="34" charset="-120"/>
+              </a:rPr>
+              <a:t>Interactive Features</a:t>
+            </a:r>
+            <a:endParaRPr lang="en-US" sz="1800" dirty="0"/>
+          </a:p>
+        </p:txBody>
+      </p:sp>
+      <p:sp>
+        <p:nvSpPr>
+          <p:cNvPr id="10" name="Text 8"/>
+          <p:cNvSpPr/>
+          <p:nvPr/>
+        </p:nvSpPr>
+        <p:spPr>
+          <a:xfrm>
+            <a:off x="6583680" y="2148840"/>
+            <a:ext cx="4572000" cy="4023360"/>
+          </a:xfrm>
+          <a:prstGeom prst="rect">
+            <a:avLst/>
+          </a:prstGeom>
+          <a:noFill/>
+          <a:ln/>
+        </p:spPr>
+        <p:txBody>
+          <a:bodyPr wrap="square" rtlCol="0" anchor="t"/>
+          <a:lstStyle/>
+          <a:p>
+            <a:pPr>
+              <a:lnSpc>
+                <a:spcPct val="115000"/>
+              </a:lnSpc>
+              <a:spcAft>
+                <a:spcPts val="400"/>
+              </a:spcAft>
+            </a:pPr>
+            <a:r>
+              <a:rPr lang="en-US" sz="1500" dirty="0">
+                <a:solidFill>
+                  <a:srgbClr val="A1A1AA"/>
+                </a:solidFill>
+                <a:latin typeface="Arial" pitchFamily="34" charset="0"/>
+                <a:ea typeface="Arial" pitchFamily="34" charset="-122"/>
+                <a:cs typeface="Arial" pitchFamily="34" charset="-120"/>
+              </a:rPr>
+              <a:t>Genre wheel — spin to explore by genre</a:t>
+            </a:r>
+            <a:endParaRPr lang="en-US" sz="1500" dirty="0"/>
+          </a:p>
+          <a:p>
+            <a:pPr>
+              <a:lnSpc>
+                <a:spcPct val="115000"/>
+              </a:lnSpc>
+              <a:spcAft>
+                <a:spcPts val="400"/>
+              </a:spcAft>
+            </a:pPr>
+            <a:r>
+              <a:rPr lang="en-US" sz="1500" dirty="0">
+                <a:solidFill>
+                  <a:srgbClr val="A1A1AA"/>
+                </a:solidFill>
+                <a:latin typeface="Arial" pitchFamily="34" charset="0"/>
+                <a:ea typeface="Arial" pitchFamily="34" charset="-122"/>
+                <a:cs typeface="Arial" pitchFamily="34" charset="-120"/>
+              </a:rPr>
+              <a:t>Identification battles — guess the record before AI</a:t>
+            </a:r>
+            <a:endParaRPr lang="en-US" sz="1500" dirty="0"/>
+          </a:p>
+          <a:p>
+            <a:pPr>
+              <a:lnSpc>
+                <a:spcPct val="115000"/>
+              </a:lnSpc>
+              <a:spcAft>
+                <a:spcPts val="400"/>
+              </a:spcAft>
+            </a:pPr>
+            <a:r>
+              <a:rPr lang="en-US" sz="1500" dirty="0">
+                <a:solidFill>
+                  <a:srgbClr val="A1A1AA"/>
+                </a:solidFill>
+                <a:latin typeface="Arial" pitchFamily="34" charset="0"/>
+                <a:ea typeface="Arial" pitchFamily="34" charset="-122"/>
+                <a:cs typeface="Arial" pitchFamily="34" charset="-120"/>
+              </a:rPr>
+              <a:t>Listening party invites — invite friends to listen along</a:t>
+            </a:r>
+            <a:endParaRPr lang="en-US" sz="1500" dirty="0"/>
+          </a:p>
+          <a:p>
+            <a:pPr>
+              <a:lnSpc>
+                <a:spcPct val="115000"/>
+              </a:lnSpc>
+              <a:spcAft>
+                <a:spcPts val="400"/>
+              </a:spcAft>
+            </a:pPr>
+            <a:r>
+              <a:rPr lang="en-US" sz="1500" dirty="0">
+                <a:solidFill>
+                  <a:srgbClr val="A1A1AA"/>
+                </a:solidFill>
+                <a:latin typeface="Arial" pitchFamily="34" charset="0"/>
+                <a:ea typeface="Arial" pitchFamily="34" charset="-122"/>
+                <a:cs typeface="Arial" pitchFamily="34" charset="-120"/>
+              </a:rPr>
+              <a:t>Real-time session sharing across devices</a:t>
+            </a:r>
+            <a:endParaRPr lang="en-US" sz="1500" dirty="0"/>
+          </a:p>
+          <a:p>
+            <a:pPr>
+              <a:lnSpc>
+                <a:spcPct val="115000"/>
+              </a:lnSpc>
+              <a:spcAft>
+                <a:spcPts val="400"/>
+              </a:spcAft>
+            </a:pPr>
+            <a:r>
+              <a:rPr lang="en-US" sz="1500" dirty="0">
+                <a:solidFill>
+                  <a:srgbClr val="A1A1AA"/>
+                </a:solidFill>
+                <a:latin typeface="Arial" pitchFamily="34" charset="0"/>
+                <a:ea typeface="Arial" pitchFamily="34" charset="-122"/>
+                <a:cs typeface="Arial" pitchFamily="34" charset="-120"/>
+              </a:rPr>
+              <a:t>Achievement popups during listening sessions</a:t>
+            </a:r>
+            <a:endParaRPr lang="en-US" sz="1500" dirty="0"/>
+          </a:p>
+          <a:p>
+            <a:pPr>
+              <a:lnSpc>
+                <a:spcPct val="115000"/>
+              </a:lnSpc>
+              <a:spcAft>
+                <a:spcPts val="400"/>
+              </a:spcAft>
+            </a:pPr>
+            <a:r>
+              <a:rPr lang="en-US" sz="1500" dirty="0">
+                <a:solidFill>
+                  <a:srgbClr val="A1A1AA"/>
+                </a:solidFill>
+                <a:latin typeface="Arial" pitchFamily="34" charset="0"/>
+                <a:ea typeface="Arial" pitchFamily="34" charset="-122"/>
+                <a:cs typeface="Arial" pitchFamily="34" charset="-120"/>
+              </a:rPr>
+              <a:t>Mood-based playlist suggestions from listening data</a:t>
+            </a:r>
+            <a:endParaRPr lang="en-US" sz="1500" dirty="0"/>
+          </a:p>
+        </p:txBody>
+      </p:sp>
+    </p:spTree>
+  </p:cSld>
+  <p:clrMapOvr>
+    <a:masterClrMapping/>
+  </p:clrMapOvr>
+</p:sld>
+</file>
+
+<file path=ppt/slides/slide38.xml><?xml version="1.0" encoding="utf-8"?>
+<p:sld xmlns:a="http://schemas.openxmlformats.org/drawingml/2006/main" xmlns:r="http://schemas.openxmlformats.org/officeDocument/2006/relationships" xmlns:p="http://schemas.openxmlformats.org/presentationml/2006/main">
+  <p:cSld name="Slide 38">
+    <p:bg>
+      <p:bgPr>
+        <a:solidFill>
+          <a:srgbClr val="0F1117"/>
+        </a:solidFill>
+      </p:bgPr>
+    </p:bg>
+    <p:spTree>
+      <p:nvGrpSpPr>
+        <p:cNvPr id="1" name=""/>
+        <p:cNvGrpSpPr/>
+        <p:nvPr/>
+      </p:nvGrpSpPr>
+      <p:grpSpPr>
+        <a:xfrm>
+          <a:off x="0" y="0"/>
+          <a:ext cx="0" cy="0"/>
+          <a:chOff x="0" y="0"/>
+          <a:chExt cx="0" cy="0"/>
+        </a:xfrm>
+      </p:grpSpPr>
+      <p:sp>
+        <p:nvSpPr>
+          <p:cNvPr id="2" name="Shape 0"/>
+          <p:cNvSpPr/>
+          <p:nvPr/>
+        </p:nvSpPr>
+        <p:spPr>
+          <a:xfrm>
+            <a:off x="0" y="0"/>
+            <a:ext cx="12188952" cy="54864"/>
+          </a:xfrm>
+          <a:prstGeom prst="rect">
+            <a:avLst/>
+          </a:prstGeom>
+          <a:solidFill>
+            <a:srgbClr val="0EA5E9"/>
+          </a:solidFill>
+          <a:ln/>
+        </p:spPr>
+      </p:sp>
+      <p:sp>
+        <p:nvSpPr>
+          <p:cNvPr id="3" name="Text 1"/>
+          <p:cNvSpPr/>
+          <p:nvPr/>
+        </p:nvSpPr>
+        <p:spPr>
+          <a:xfrm>
+            <a:off x="731520" y="365760"/>
+            <a:ext cx="10515600" cy="731520"/>
+          </a:xfrm>
+          <a:prstGeom prst="rect">
+            <a:avLst/>
+          </a:prstGeom>
+          <a:noFill/>
+          <a:ln/>
+        </p:spPr>
+        <p:txBody>
+          <a:bodyPr wrap="square" rtlCol="0" anchor="ctr"/>
+          <a:lstStyle/>
+          <a:p>
+            <a:pPr indent="0" marL="0">
+              <a:buNone/>
+            </a:pPr>
+            <a:r>
+              <a:rPr lang="en-US" sz="3200" b="1" dirty="0">
+                <a:solidFill>
+                  <a:srgbClr val="FFFFFF"/>
+                </a:solidFill>
+                <a:latin typeface="Arial" pitchFamily="34" charset="0"/>
+                <a:ea typeface="Arial" pitchFamily="34" charset="-122"/>
+                <a:cs typeface="Arial" pitchFamily="34" charset="-120"/>
+              </a:rPr>
+              <a:t>Revenue Model</a:t>
+            </a:r>
+            <a:endParaRPr lang="en-US" sz="3200" dirty="0"/>
+          </a:p>
+        </p:txBody>
+      </p:sp>
+      <p:sp>
+        <p:nvSpPr>
+          <p:cNvPr id="4" name="Shape 2"/>
+          <p:cNvSpPr/>
+          <p:nvPr/>
+        </p:nvSpPr>
+        <p:spPr>
+          <a:xfrm>
+            <a:off x="731520" y="1143000"/>
+            <a:ext cx="2286000" cy="36576"/>
+          </a:xfrm>
+          <a:prstGeom prst="rect">
+            <a:avLst/>
+          </a:prstGeom>
+          <a:solidFill>
+            <a:srgbClr val="0EA5E9"/>
+          </a:solidFill>
+          <a:ln/>
+        </p:spPr>
+      </p:sp>
+      <p:sp>
+        <p:nvSpPr>
+          <p:cNvPr id="5" name="Shape 3"/>
+          <p:cNvSpPr/>
+          <p:nvPr/>
+        </p:nvSpPr>
+        <p:spPr>
+          <a:xfrm>
+            <a:off x="731520" y="1463040"/>
+            <a:ext cx="5120640" cy="4846320"/>
+          </a:xfrm>
+          <a:prstGeom prst="rect">
+            <a:avLst>
+              <a:gd name="adj" fmla="val 1887"/>
+            </a:avLst>
+          </a:prstGeom>
+          <a:solidFill>
+            <a:srgbClr val="18181B"/>
+          </a:solidFill>
+          <a:ln/>
+        </p:spPr>
+      </p:sp>
+      <p:sp>
+        <p:nvSpPr>
+          <p:cNvPr id="6" name="Text 4"/>
+          <p:cNvSpPr/>
+          <p:nvPr/>
+        </p:nvSpPr>
+        <p:spPr>
+          <a:xfrm>
+            <a:off x="1005840" y="1600200"/>
+            <a:ext cx="4572000" cy="457200"/>
+          </a:xfrm>
+          <a:prstGeom prst="rect">
+            <a:avLst/>
+          </a:prstGeom>
+          <a:noFill/>
+          <a:ln/>
+        </p:spPr>
+        <p:txBody>
+          <a:bodyPr wrap="square" rtlCol="0" anchor="ctr"/>
+          <a:lstStyle/>
+          <a:p>
+            <a:pPr indent="0" marL="0">
+              <a:buNone/>
+            </a:pPr>
+            <a:r>
+              <a:rPr lang="en-US" sz="1800" b="1" dirty="0">
+                <a:solidFill>
+                  <a:srgbClr val="0EA5E9"/>
+                </a:solidFill>
+                <a:latin typeface="Arial" pitchFamily="34" charset="0"/>
+                <a:ea typeface="Arial" pitchFamily="34" charset="-122"/>
+                <a:cs typeface="Arial" pitchFamily="34" charset="-120"/>
+              </a:rPr>
+              <a:t>Transaction Revenue</a:t>
+            </a:r>
+            <a:endParaRPr lang="en-US" sz="1800" dirty="0"/>
+          </a:p>
+        </p:txBody>
+      </p:sp>
+      <p:sp>
+        <p:nvSpPr>
+          <p:cNvPr id="7" name="Text 5"/>
+          <p:cNvSpPr/>
+          <p:nvPr/>
+        </p:nvSpPr>
+        <p:spPr>
+          <a:xfrm>
+            <a:off x="1005840" y="2148840"/>
+            <a:ext cx="4572000" cy="4023360"/>
+          </a:xfrm>
+          <a:prstGeom prst="rect">
+            <a:avLst/>
+          </a:prstGeom>
+          <a:noFill/>
+          <a:ln/>
+        </p:spPr>
+        <p:txBody>
+          <a:bodyPr wrap="square" rtlCol="0" anchor="t"/>
+          <a:lstStyle/>
+          <a:p>
+            <a:pPr>
+              <a:lnSpc>
+                <a:spcPct val="115000"/>
+              </a:lnSpc>
+              <a:spcAft>
+                <a:spcPts val="400"/>
+              </a:spcAft>
+            </a:pPr>
+            <a:r>
+              <a:rPr lang="en-US" sz="1500" dirty="0">
+                <a:solidFill>
+                  <a:srgbClr val="A1A1AA"/>
+                </a:solidFill>
+                <a:latin typeface="Arial" pitchFamily="34" charset="0"/>
+                <a:ea typeface="Arial" pitchFamily="34" charset="-122"/>
+                <a:cs typeface="Arial" pitchFamily="34" charset="-120"/>
+              </a:rPr>
+              <a:t>5% transaction fee on all marketplace sales (min $1)</a:t>
+            </a:r>
+            <a:endParaRPr lang="en-US" sz="1500" dirty="0"/>
+          </a:p>
+          <a:p>
+            <a:pPr>
+              <a:lnSpc>
+                <a:spcPct val="115000"/>
+              </a:lnSpc>
+              <a:spcAft>
+                <a:spcPts val="400"/>
+              </a:spcAft>
+            </a:pPr>
+            <a:r>
+              <a:rPr lang="en-US" sz="1500" dirty="0">
+                <a:solidFill>
+                  <a:srgbClr val="A1A1AA"/>
+                </a:solidFill>
+                <a:latin typeface="Arial" pitchFamily="34" charset="0"/>
+                <a:ea typeface="Arial" pitchFamily="34" charset="-122"/>
+                <a:cs typeface="Arial" pitchFamily="34" charset="-120"/>
+              </a:rPr>
+              <a:t>$6 flat shipping fee per order</a:t>
+            </a:r>
+            <a:endParaRPr lang="en-US" sz="1500" dirty="0"/>
+          </a:p>
+          <a:p>
+            <a:pPr>
+              <a:lnSpc>
+                <a:spcPct val="115000"/>
+              </a:lnSpc>
+              <a:spcAft>
+                <a:spcPts val="400"/>
+              </a:spcAft>
+            </a:pPr>
+            <a:r>
+              <a:rPr lang="en-US" sz="1500" dirty="0">
+                <a:solidFill>
+                  <a:srgbClr val="A1A1AA"/>
+                </a:solidFill>
+                <a:latin typeface="Arial" pitchFamily="34" charset="0"/>
+                <a:ea typeface="Arial" pitchFamily="34" charset="-122"/>
+                <a:cs typeface="Arial" pitchFamily="34" charset="-120"/>
+              </a:rPr>
+              <a:t>Escrow fee for high-value transactions</a:t>
+            </a:r>
+            <a:endParaRPr lang="en-US" sz="1500" dirty="0"/>
+          </a:p>
+          <a:p>
+            <a:pPr>
+              <a:lnSpc>
+                <a:spcPct val="115000"/>
+              </a:lnSpc>
+              <a:spcAft>
+                <a:spcPts val="400"/>
+              </a:spcAft>
+            </a:pPr>
+            <a:r>
+              <a:rPr lang="en-US" sz="1500" dirty="0">
+                <a:solidFill>
+                  <a:srgbClr val="A1A1AA"/>
+                </a:solidFill>
+                <a:latin typeface="Arial" pitchFamily="34" charset="0"/>
+                <a:ea typeface="Arial" pitchFamily="34" charset="-122"/>
+                <a:cs typeface="Arial" pitchFamily="34" charset="-120"/>
+              </a:rPr>
+              <a:t>Featured listing placement fees</a:t>
+            </a:r>
+            <a:endParaRPr lang="en-US" sz="1500" dirty="0"/>
+          </a:p>
+          <a:p>
+            <a:pPr>
+              <a:lnSpc>
+                <a:spcPct val="115000"/>
+              </a:lnSpc>
+              <a:spcAft>
+                <a:spcPts val="400"/>
+              </a:spcAft>
+            </a:pPr>
+            <a:r>
+              <a:rPr lang="en-US" sz="1500" dirty="0">
+                <a:solidFill>
+                  <a:srgbClr val="A1A1AA"/>
+                </a:solidFill>
+                <a:latin typeface="Arial" pitchFamily="34" charset="0"/>
+                <a:ea typeface="Arial" pitchFamily="34" charset="-122"/>
+                <a:cs typeface="Arial" pitchFamily="34" charset="-120"/>
+              </a:rPr>
+              <a:t>Promoted search result positions</a:t>
+            </a:r>
+            <a:endParaRPr lang="en-US" sz="1500" dirty="0"/>
+          </a:p>
+          <a:p>
+            <a:pPr>
+              <a:lnSpc>
+                <a:spcPct val="115000"/>
+              </a:lnSpc>
+              <a:spcAft>
+                <a:spcPts val="400"/>
+              </a:spcAft>
+            </a:pPr>
+            <a:r>
+              <a:rPr lang="en-US" sz="1500" dirty="0">
+                <a:solidFill>
+                  <a:srgbClr val="A1A1AA"/>
+                </a:solidFill>
+                <a:latin typeface="Arial" pitchFamily="34" charset="0"/>
+                <a:ea typeface="Arial" pitchFamily="34" charset="-122"/>
+                <a:cs typeface="Arial" pitchFamily="34" charset="-120"/>
+              </a:rPr>
+              <a:t>Marketplace search ads</a:t>
+            </a:r>
+            <a:endParaRPr lang="en-US" sz="1500" dirty="0"/>
+          </a:p>
+        </p:txBody>
+      </p:sp>
+      <p:sp>
+        <p:nvSpPr>
+          <p:cNvPr id="8" name="Shape 6"/>
+          <p:cNvSpPr/>
+          <p:nvPr/>
+        </p:nvSpPr>
+        <p:spPr>
+          <a:xfrm>
+            <a:off x="6309360" y="1463040"/>
+            <a:ext cx="5120640" cy="4846320"/>
+          </a:xfrm>
+          <a:prstGeom prst="rect">
+            <a:avLst>
+              <a:gd name="adj" fmla="val 1887"/>
+            </a:avLst>
+          </a:prstGeom>
+          <a:solidFill>
+            <a:srgbClr val="18181B"/>
+          </a:solidFill>
+          <a:ln/>
+        </p:spPr>
+      </p:sp>
+      <p:sp>
+        <p:nvSpPr>
+          <p:cNvPr id="9" name="Text 7"/>
+          <p:cNvSpPr/>
+          <p:nvPr/>
+        </p:nvSpPr>
+        <p:spPr>
+          <a:xfrm>
+            <a:off x="6583680" y="1600200"/>
+            <a:ext cx="4572000" cy="457200"/>
+          </a:xfrm>
+          <a:prstGeom prst="rect">
+            <a:avLst/>
+          </a:prstGeom>
+          <a:noFill/>
+          <a:ln/>
+        </p:spPr>
+        <p:txBody>
+          <a:bodyPr wrap="square" rtlCol="0" anchor="ctr"/>
+          <a:lstStyle/>
+          <a:p>
+            <a:pPr indent="0" marL="0">
+              <a:buNone/>
+            </a:pPr>
+            <a:r>
+              <a:rPr lang="en-US" sz="1800" b="1" dirty="0">
+                <a:solidFill>
+                  <a:srgbClr val="0EA5E9"/>
+                </a:solidFill>
+                <a:latin typeface="Arial" pitchFamily="34" charset="0"/>
+                <a:ea typeface="Arial" pitchFamily="34" charset="-122"/>
+                <a:cs typeface="Arial" pitchFamily="34" charset="-120"/>
+              </a:rPr>
+              <a:t>Recurring &amp; Hardware Revenue</a:t>
+            </a:r>
+            <a:endParaRPr lang="en-US" sz="1800" dirty="0"/>
+          </a:p>
+        </p:txBody>
+      </p:sp>
+      <p:sp>
+        <p:nvSpPr>
+          <p:cNvPr id="10" name="Text 8"/>
+          <p:cNvSpPr/>
+          <p:nvPr/>
+        </p:nvSpPr>
+        <p:spPr>
+          <a:xfrm>
+            <a:off x="6583680" y="2148840"/>
+            <a:ext cx="4572000" cy="4023360"/>
+          </a:xfrm>
+          <a:prstGeom prst="rect">
+            <a:avLst/>
+          </a:prstGeom>
+          <a:noFill/>
+          <a:ln/>
+        </p:spPr>
+        <p:txBody>
+          <a:bodyPr wrap="square" rtlCol="0" anchor="t"/>
+          <a:lstStyle/>
+          <a:p>
+            <a:pPr>
+              <a:lnSpc>
+                <a:spcPct val="115000"/>
+              </a:lnSpc>
+              <a:spcAft>
+                <a:spcPts val="400"/>
+              </a:spcAft>
+            </a:pPr>
+            <a:r>
+              <a:rPr lang="en-US" sz="1500" dirty="0">
+                <a:solidFill>
+                  <a:srgbClr val="A1A1AA"/>
+                </a:solidFill>
+                <a:latin typeface="Arial" pitchFamily="34" charset="0"/>
+                <a:ea typeface="Arial" pitchFamily="34" charset="-122"/>
+                <a:cs typeface="Arial" pitchFamily="34" charset="-120"/>
+              </a:rPr>
+              <a:t>Seller tier subscriptions (Bronze/Silver/Gold/Platinum)</a:t>
+            </a:r>
+            <a:endParaRPr lang="en-US" sz="1500" dirty="0"/>
+          </a:p>
+          <a:p>
+            <a:pPr>
+              <a:lnSpc>
+                <a:spcPct val="115000"/>
+              </a:lnSpc>
+              <a:spcAft>
+                <a:spcPts val="400"/>
+              </a:spcAft>
+            </a:pPr>
+            <a:r>
+              <a:rPr lang="en-US" sz="1500" dirty="0">
+                <a:solidFill>
+                  <a:srgbClr val="A1A1AA"/>
+                </a:solidFill>
+                <a:latin typeface="Arial" pitchFamily="34" charset="0"/>
+                <a:ea typeface="Arial" pitchFamily="34" charset="-122"/>
+                <a:cs typeface="Arial" pitchFamily="34" charset="-120"/>
+              </a:rPr>
+              <a:t>Premium collector subscriptions</a:t>
+            </a:r>
+            <a:endParaRPr lang="en-US" sz="1500" dirty="0"/>
+          </a:p>
+          <a:p>
+            <a:pPr>
+              <a:lnSpc>
+                <a:spcPct val="115000"/>
+              </a:lnSpc>
+              <a:spcAft>
+                <a:spcPts val="400"/>
+              </a:spcAft>
+            </a:pPr>
+            <a:r>
+              <a:rPr lang="en-US" sz="1500" dirty="0">
+                <a:solidFill>
+                  <a:srgbClr val="A1A1AA"/>
+                </a:solidFill>
+                <a:latin typeface="Arial" pitchFamily="34" charset="0"/>
+                <a:ea typeface="Arial" pitchFamily="34" charset="-122"/>
+                <a:cs typeface="Arial" pitchFamily="34" charset="-120"/>
+              </a:rPr>
+              <a:t>Vinyl Buddy hardware sales ($43.50+ per unit)</a:t>
+            </a:r>
+            <a:endParaRPr lang="en-US" sz="1500" dirty="0"/>
+          </a:p>
+          <a:p>
+            <a:pPr>
+              <a:lnSpc>
+                <a:spcPct val="115000"/>
+              </a:lnSpc>
+              <a:spcAft>
+                <a:spcPts val="400"/>
+              </a:spcAft>
+            </a:pPr>
+            <a:r>
+              <a:rPr lang="en-US" sz="1500" dirty="0">
+                <a:solidFill>
+                  <a:srgbClr val="A1A1AA"/>
+                </a:solidFill>
+                <a:latin typeface="Arial" pitchFamily="34" charset="0"/>
+                <a:ea typeface="Arial" pitchFamily="34" charset="-122"/>
+                <a:cs typeface="Arial" pitchFamily="34" charset="-120"/>
+              </a:rPr>
+              <a:t>Vinyl Buddy accessory sales (enclosures, cables)</a:t>
+            </a:r>
+            <a:endParaRPr lang="en-US" sz="1500" dirty="0"/>
+          </a:p>
+          <a:p>
+            <a:pPr>
+              <a:lnSpc>
+                <a:spcPct val="115000"/>
+              </a:lnSpc>
+              <a:spcAft>
+                <a:spcPts val="400"/>
+              </a:spcAft>
+            </a:pPr>
+            <a:r>
+              <a:rPr lang="en-US" sz="1500" dirty="0">
+                <a:solidFill>
+                  <a:srgbClr val="A1A1AA"/>
+                </a:solidFill>
+                <a:latin typeface="Arial" pitchFamily="34" charset="0"/>
+                <a:ea typeface="Arial" pitchFamily="34" charset="-122"/>
+                <a:cs typeface="Arial" pitchFamily="34" charset="-120"/>
+              </a:rPr>
+              <a:t>Loyalty points system drives repeat purchases</a:t>
+            </a:r>
+            <a:endParaRPr lang="en-US" sz="1500" dirty="0"/>
+          </a:p>
+          <a:p>
+            <a:pPr>
+              <a:lnSpc>
+                <a:spcPct val="115000"/>
+              </a:lnSpc>
+              <a:spcAft>
+                <a:spcPts val="400"/>
+              </a:spcAft>
+            </a:pPr>
+            <a:r>
+              <a:rPr lang="en-US" sz="1500" dirty="0">
+                <a:solidFill>
+                  <a:srgbClr val="A1A1AA"/>
+                </a:solidFill>
+                <a:latin typeface="Arial" pitchFamily="34" charset="0"/>
+                <a:ea typeface="Arial" pitchFamily="34" charset="-122"/>
+                <a:cs typeface="Arial" pitchFamily="34" charset="-120"/>
+              </a:rPr>
+              <a:t>Record label partnership and exclusive drop fees</a:t>
+            </a:r>
+            <a:endParaRPr lang="en-US" sz="1500" dirty="0"/>
+          </a:p>
+        </p:txBody>
+      </p:sp>
+    </p:spTree>
+  </p:cSld>
+  <p:clrMapOvr>
+    <a:masterClrMapping/>
+  </p:clrMapOvr>
+</p:sld>
+</file>
+
+<file path=ppt/slides/slide39.xml><?xml version="1.0" encoding="utf-8"?>
+<p:sld xmlns:a="http://schemas.openxmlformats.org/drawingml/2006/main" xmlns:r="http://schemas.openxmlformats.org/officeDocument/2006/relationships" xmlns:p="http://schemas.openxmlformats.org/presentationml/2006/main">
+  <p:cSld name="Slide 39">
+    <p:bg>
+      <p:bgPr>
+        <a:solidFill>
+          <a:srgbClr val="0F1117"/>
+        </a:solidFill>
+      </p:bgPr>
+    </p:bg>
+    <p:spTree>
+      <p:nvGrpSpPr>
+        <p:cNvPr id="1" name=""/>
+        <p:cNvGrpSpPr/>
+        <p:nvPr/>
+      </p:nvGrpSpPr>
+      <p:grpSpPr>
+        <a:xfrm>
+          <a:off x="0" y="0"/>
+          <a:ext cx="0" cy="0"/>
+          <a:chOff x="0" y="0"/>
+          <a:chExt cx="0" cy="0"/>
+        </a:xfrm>
+      </p:grpSpPr>
+      <p:sp>
+        <p:nvSpPr>
+          <p:cNvPr id="2" name="Shape 0"/>
+          <p:cNvSpPr/>
+          <p:nvPr/>
+        </p:nvSpPr>
+        <p:spPr>
+          <a:xfrm>
+            <a:off x="0" y="0"/>
+            <a:ext cx="12188952" cy="54864"/>
+          </a:xfrm>
+          <a:prstGeom prst="rect">
+            <a:avLst/>
+          </a:prstGeom>
+          <a:solidFill>
+            <a:srgbClr val="0EA5E9"/>
+          </a:solidFill>
+          <a:ln/>
+        </p:spPr>
+      </p:sp>
+      <p:sp>
+        <p:nvSpPr>
+          <p:cNvPr id="3" name="Text 1"/>
+          <p:cNvSpPr/>
+          <p:nvPr/>
+        </p:nvSpPr>
+        <p:spPr>
+          <a:xfrm>
+            <a:off x="731520" y="365760"/>
+            <a:ext cx="10515600" cy="731520"/>
+          </a:xfrm>
+          <a:prstGeom prst="rect">
+            <a:avLst/>
+          </a:prstGeom>
+          <a:noFill/>
+          <a:ln/>
+        </p:spPr>
+        <p:txBody>
+          <a:bodyPr wrap="square" rtlCol="0" anchor="ctr"/>
+          <a:lstStyle/>
+          <a:p>
+            <a:pPr indent="0" marL="0">
+              <a:buNone/>
+            </a:pPr>
+            <a:r>
+              <a:rPr lang="en-US" sz="3200" b="1" dirty="0">
+                <a:solidFill>
+                  <a:srgbClr val="FFFFFF"/>
+                </a:solidFill>
+                <a:latin typeface="Arial" pitchFamily="34" charset="0"/>
+                <a:ea typeface="Arial" pitchFamily="34" charset="-122"/>
+                <a:cs typeface="Arial" pitchFamily="34" charset="-120"/>
+              </a:rPr>
+              <a:t>User Engagement Features</a:t>
+            </a:r>
+            <a:endParaRPr lang="en-US" sz="3200" dirty="0"/>
+          </a:p>
+        </p:txBody>
+      </p:sp>
+      <p:sp>
+        <p:nvSpPr>
+          <p:cNvPr id="4" name="Shape 2"/>
+          <p:cNvSpPr/>
+          <p:nvPr/>
+        </p:nvSpPr>
+        <p:spPr>
+          <a:xfrm>
+            <a:off x="731520" y="1143000"/>
+            <a:ext cx="2286000" cy="36576"/>
+          </a:xfrm>
+          <a:prstGeom prst="rect">
+            <a:avLst/>
+          </a:prstGeom>
+          <a:solidFill>
+            <a:srgbClr val="0EA5E9"/>
+          </a:solidFill>
+          <a:ln/>
+        </p:spPr>
+      </p:sp>
+      <p:sp>
+        <p:nvSpPr>
+          <p:cNvPr id="5" name="Text 3"/>
+          <p:cNvSpPr/>
+          <p:nvPr/>
+        </p:nvSpPr>
+        <p:spPr>
+          <a:xfrm>
+            <a:off x="731520" y="1463040"/>
+            <a:ext cx="10515600" cy="5029200"/>
+          </a:xfrm>
+          <a:prstGeom prst="rect">
+            <a:avLst/>
+          </a:prstGeom>
+          <a:noFill/>
+          <a:ln/>
+        </p:spPr>
+        <p:txBody>
+          <a:bodyPr wrap="square" rtlCol="0" anchor="t"/>
+          <a:lstStyle/>
+          <a:p>
+            <a:pPr>
+              <a:lnSpc>
+                <a:spcPct val="120000"/>
+              </a:lnSpc>
+              <a:spcAft>
+                <a:spcPts val="500"/>
+              </a:spcAft>
+            </a:pPr>
+            <a:r>
+              <a:rPr lang="en-US" sz="1400" dirty="0">
+                <a:solidFill>
+                  <a:srgbClr val="A1A1AA"/>
+                </a:solidFill>
+                <a:latin typeface="Arial" pitchFamily="34" charset="0"/>
+                <a:ea typeface="Arial" pitchFamily="34" charset="-122"/>
+                <a:cs typeface="Arial" pitchFamily="34" charset="-120"/>
+              </a:rPr>
+              <a:t>Achievement system: First Spin, Century Club, Genre Explorer, Streak Master</a:t>
+            </a:r>
+            <a:endParaRPr lang="en-US" sz="1400" dirty="0"/>
+          </a:p>
+          <a:p>
+            <a:pPr>
+              <a:lnSpc>
+                <a:spcPct val="120000"/>
+              </a:lnSpc>
+              <a:spcAft>
+                <a:spcPts val="500"/>
+              </a:spcAft>
+            </a:pPr>
+            <a:r>
+              <a:rPr lang="en-US" sz="1400" dirty="0">
+                <a:solidFill>
+                  <a:srgbClr val="A1A1AA"/>
+                </a:solidFill>
+                <a:latin typeface="Arial" pitchFamily="34" charset="0"/>
+                <a:ea typeface="Arial" pitchFamily="34" charset="-122"/>
+                <a:cs typeface="Arial" pitchFamily="34" charset="-120"/>
+              </a:rPr>
+              <a:t>Daily listening streaks with streak shields and recovery</a:t>
+            </a:r>
+            <a:endParaRPr lang="en-US" sz="1400" dirty="0"/>
+          </a:p>
+          <a:p>
+            <a:pPr>
+              <a:lnSpc>
+                <a:spcPct val="120000"/>
+              </a:lnSpc>
+              <a:spcAft>
+                <a:spcPts val="500"/>
+              </a:spcAft>
+            </a:pPr>
+            <a:r>
+              <a:rPr lang="en-US" sz="1400" dirty="0">
+                <a:solidFill>
+                  <a:srgbClr val="A1A1AA"/>
+                </a:solidFill>
+                <a:latin typeface="Arial" pitchFamily="34" charset="0"/>
+                <a:ea typeface="Arial" pitchFamily="34" charset="-122"/>
+                <a:cs typeface="Arial" pitchFamily="34" charset="-120"/>
+              </a:rPr>
+              <a:t>Weekly and monthly challenges with reward points</a:t>
+            </a:r>
+            <a:endParaRPr lang="en-US" sz="1400" dirty="0"/>
+          </a:p>
+          <a:p>
+            <a:pPr>
+              <a:lnSpc>
+                <a:spcPct val="120000"/>
+              </a:lnSpc>
+              <a:spcAft>
+                <a:spcPts val="500"/>
+              </a:spcAft>
+            </a:pPr>
+            <a:r>
+              <a:rPr lang="en-US" sz="1400" dirty="0">
+                <a:solidFill>
+                  <a:srgbClr val="A1A1AA"/>
+                </a:solidFill>
+                <a:latin typeface="Arial" pitchFamily="34" charset="0"/>
+                <a:ea typeface="Arial" pitchFamily="34" charset="-122"/>
+                <a:cs typeface="Arial" pitchFamily="34" charset="-120"/>
+              </a:rPr>
+              <a:t>Collector leaderboards: top sellers, top collectors, most active</a:t>
+            </a:r>
+            <a:endParaRPr lang="en-US" sz="1400" dirty="0"/>
+          </a:p>
+          <a:p>
+            <a:pPr>
+              <a:lnSpc>
+                <a:spcPct val="120000"/>
+              </a:lnSpc>
+              <a:spcAft>
+                <a:spcPts val="500"/>
+              </a:spcAft>
+            </a:pPr>
+            <a:r>
+              <a:rPr lang="en-US" sz="1400" dirty="0">
+                <a:solidFill>
+                  <a:srgbClr val="A1A1AA"/>
+                </a:solidFill>
+                <a:latin typeface="Arial" pitchFamily="34" charset="0"/>
+                <a:ea typeface="Arial" pitchFamily="34" charset="-122"/>
+                <a:cs typeface="Arial" pitchFamily="34" charset="-120"/>
+              </a:rPr>
+              <a:t>Genre leaderboards ranked by listening hours</a:t>
+            </a:r>
+            <a:endParaRPr lang="en-US" sz="1400" dirty="0"/>
+          </a:p>
+          <a:p>
+            <a:pPr>
+              <a:lnSpc>
+                <a:spcPct val="120000"/>
+              </a:lnSpc>
+              <a:spcAft>
+                <a:spcPts val="500"/>
+              </a:spcAft>
+            </a:pPr>
+            <a:r>
+              <a:rPr lang="en-US" sz="1400" dirty="0">
+                <a:solidFill>
+                  <a:srgbClr val="A1A1AA"/>
+                </a:solidFill>
+                <a:latin typeface="Arial" pitchFamily="34" charset="0"/>
+                <a:ea typeface="Arial" pitchFamily="34" charset="-122"/>
+                <a:cs typeface="Arial" pitchFamily="34" charset="-120"/>
+              </a:rPr>
+              <a:t>Level-up system based on total engagement score</a:t>
+            </a:r>
+            <a:endParaRPr lang="en-US" sz="1400" dirty="0"/>
+          </a:p>
+          <a:p>
+            <a:pPr>
+              <a:lnSpc>
+                <a:spcPct val="120000"/>
+              </a:lnSpc>
+              <a:spcAft>
+                <a:spcPts val="500"/>
+              </a:spcAft>
+            </a:pPr>
+            <a:r>
+              <a:rPr lang="en-US" sz="1400" dirty="0">
+                <a:solidFill>
+                  <a:srgbClr val="A1A1AA"/>
+                </a:solidFill>
+                <a:latin typeface="Arial" pitchFamily="34" charset="0"/>
+                <a:ea typeface="Arial" pitchFamily="34" charset="-122"/>
+                <a:cs typeface="Arial" pitchFamily="34" charset="-120"/>
+              </a:rPr>
+              <a:t>Seasonal events and limited-edition badges</a:t>
+            </a:r>
+            <a:endParaRPr lang="en-US" sz="1400" dirty="0"/>
+          </a:p>
+          <a:p>
+            <a:pPr>
+              <a:lnSpc>
+                <a:spcPct val="120000"/>
+              </a:lnSpc>
+              <a:spcAft>
+                <a:spcPts val="500"/>
+              </a:spcAft>
+            </a:pPr>
+            <a:r>
+              <a:rPr lang="en-US" sz="1400" dirty="0">
+                <a:solidFill>
+                  <a:srgbClr val="A1A1AA"/>
+                </a:solidFill>
+                <a:latin typeface="Arial" pitchFamily="34" charset="0"/>
+                <a:ea typeface="Arial" pitchFamily="34" charset="-122"/>
+                <a:cs typeface="Arial" pitchFamily="34" charset="-120"/>
+              </a:rPr>
+              <a:t>Referral program with bonus loyalty points</a:t>
+            </a:r>
+            <a:endParaRPr lang="en-US" sz="1400" dirty="0"/>
+          </a:p>
+          <a:p>
+            <a:pPr>
+              <a:lnSpc>
+                <a:spcPct val="120000"/>
+              </a:lnSpc>
+              <a:spcAft>
+                <a:spcPts val="500"/>
+              </a:spcAft>
+            </a:pPr>
+            <a:r>
+              <a:rPr lang="en-US" sz="1400" dirty="0">
+                <a:solidFill>
+                  <a:srgbClr val="A1A1AA"/>
+                </a:solidFill>
+                <a:latin typeface="Arial" pitchFamily="34" charset="0"/>
+                <a:ea typeface="Arial" pitchFamily="34" charset="-122"/>
+                <a:cs typeface="Arial" pitchFamily="34" charset="-120"/>
+              </a:rPr>
+              <a:t>Daily login rewards and activity milestones</a:t>
+            </a:r>
+            <a:endParaRPr lang="en-US" sz="1400" dirty="0"/>
+          </a:p>
+          <a:p>
+            <a:pPr>
+              <a:lnSpc>
+                <a:spcPct val="120000"/>
+              </a:lnSpc>
+              <a:spcAft>
+                <a:spcPts val="500"/>
+              </a:spcAft>
+            </a:pPr>
+            <a:r>
+              <a:rPr lang="en-US" sz="1400" dirty="0">
+                <a:solidFill>
+                  <a:srgbClr val="A1A1AA"/>
+                </a:solidFill>
+                <a:latin typeface="Arial" pitchFamily="34" charset="0"/>
+                <a:ea typeface="Arial" pitchFamily="34" charset="-122"/>
+                <a:cs typeface="Arial" pitchFamily="34" charset="-120"/>
+              </a:rPr>
+              <a:t>Social challenges: identify battles, taste comparisons</a:t>
+            </a:r>
+            <a:endParaRPr lang="en-US" sz="1400" dirty="0"/>
+          </a:p>
+        </p:txBody>
       </p:sp>
     </p:spTree>
   </p:cSld>
@@ -17535,7 +19704,7 @@
                 <a:ea typeface="Arial" pitchFamily="34" charset="-122"/>
                 <a:cs typeface="Arial" pitchFamily="34" charset="-120"/>
               </a:rPr>
-              <a:t>275+ APIs</a:t>
+              <a:t>290+ APIs</a:t>
             </a:r>
             <a:endParaRPr lang="en-US" sz="3600" dirty="0"/>
           </a:p>
@@ -17579,6 +19748,677 @@
             <a:endParaRPr lang="en-US" sz="1600" dirty="0"/>
           </a:p>
         </p:txBody>
+      </p:sp>
+    </p:spTree>
+  </p:cSld>
+  <p:clrMapOvr>
+    <a:masterClrMapping/>
+  </p:clrMapOvr>
+</p:sld>
+</file>
+
+<file path=ppt/slides/slide40.xml><?xml version="1.0" encoding="utf-8"?>
+<p:sld xmlns:a="http://schemas.openxmlformats.org/drawingml/2006/main" xmlns:r="http://schemas.openxmlformats.org/officeDocument/2006/relationships" xmlns:p="http://schemas.openxmlformats.org/presentationml/2006/main">
+  <p:cSld name="Slide 40">
+    <p:bg>
+      <p:bgPr>
+        <a:solidFill>
+          <a:srgbClr val="0F1117"/>
+        </a:solidFill>
+      </p:bgPr>
+    </p:bg>
+    <p:spTree>
+      <p:nvGrpSpPr>
+        <p:cNvPr id="1" name=""/>
+        <p:cNvGrpSpPr/>
+        <p:nvPr/>
+      </p:nvGrpSpPr>
+      <p:grpSpPr>
+        <a:xfrm>
+          <a:off x="0" y="0"/>
+          <a:ext cx="0" cy="0"/>
+          <a:chOff x="0" y="0"/>
+          <a:chExt cx="0" cy="0"/>
+        </a:xfrm>
+      </p:grpSpPr>
+      <p:sp>
+        <p:nvSpPr>
+          <p:cNvPr id="2" name="Shape 0"/>
+          <p:cNvSpPr/>
+          <p:nvPr/>
+        </p:nvSpPr>
+        <p:spPr>
+          <a:xfrm>
+            <a:off x="0" y="0"/>
+            <a:ext cx="12188952" cy="54864"/>
+          </a:xfrm>
+          <a:prstGeom prst="rect">
+            <a:avLst/>
+          </a:prstGeom>
+          <a:solidFill>
+            <a:srgbClr val="0EA5E9"/>
+          </a:solidFill>
+          <a:ln/>
+        </p:spPr>
+      </p:sp>
+      <p:sp>
+        <p:nvSpPr>
+          <p:cNvPr id="3" name="Text 1"/>
+          <p:cNvSpPr/>
+          <p:nvPr/>
+        </p:nvSpPr>
+        <p:spPr>
+          <a:xfrm>
+            <a:off x="731520" y="365760"/>
+            <a:ext cx="10515600" cy="731520"/>
+          </a:xfrm>
+          <a:prstGeom prst="rect">
+            <a:avLst/>
+          </a:prstGeom>
+          <a:noFill/>
+          <a:ln/>
+        </p:spPr>
+        <p:txBody>
+          <a:bodyPr wrap="square" rtlCol="0" anchor="ctr"/>
+          <a:lstStyle/>
+          <a:p>
+            <a:pPr indent="0" marL="0">
+              <a:buNone/>
+            </a:pPr>
+            <a:r>
+              <a:rPr lang="en-US" sz="3200" b="1" dirty="0">
+                <a:solidFill>
+                  <a:srgbClr val="FFFFFF"/>
+                </a:solidFill>
+                <a:latin typeface="Arial" pitchFamily="34" charset="0"/>
+                <a:ea typeface="Arial" pitchFamily="34" charset="-122"/>
+                <a:cs typeface="Arial" pitchFamily="34" charset="-120"/>
+              </a:rPr>
+              <a:t>Roadmap — Future Plans</a:t>
+            </a:r>
+            <a:endParaRPr lang="en-US" sz="3200" dirty="0"/>
+          </a:p>
+        </p:txBody>
+      </p:sp>
+      <p:sp>
+        <p:nvSpPr>
+          <p:cNvPr id="4" name="Shape 2"/>
+          <p:cNvSpPr/>
+          <p:nvPr/>
+        </p:nvSpPr>
+        <p:spPr>
+          <a:xfrm>
+            <a:off x="731520" y="1143000"/>
+            <a:ext cx="2286000" cy="36576"/>
+          </a:xfrm>
+          <a:prstGeom prst="rect">
+            <a:avLst/>
+          </a:prstGeom>
+          <a:solidFill>
+            <a:srgbClr val="0EA5E9"/>
+          </a:solidFill>
+          <a:ln/>
+        </p:spPr>
+      </p:sp>
+      <p:sp>
+        <p:nvSpPr>
+          <p:cNvPr id="5" name="Text 3"/>
+          <p:cNvSpPr/>
+          <p:nvPr/>
+        </p:nvSpPr>
+        <p:spPr>
+          <a:xfrm>
+            <a:off x="731520" y="1463040"/>
+            <a:ext cx="10515600" cy="5029200"/>
+          </a:xfrm>
+          <a:prstGeom prst="rect">
+            <a:avLst/>
+          </a:prstGeom>
+          <a:noFill/>
+          <a:ln/>
+        </p:spPr>
+        <p:txBody>
+          <a:bodyPr wrap="square" rtlCol="0" anchor="t"/>
+          <a:lstStyle/>
+          <a:p>
+            <a:pPr>
+              <a:lnSpc>
+                <a:spcPct val="120000"/>
+              </a:lnSpc>
+              <a:spcAft>
+                <a:spcPts val="500"/>
+              </a:spcAft>
+            </a:pPr>
+            <a:r>
+              <a:rPr lang="en-US" sz="1400" dirty="0">
+                <a:solidFill>
+                  <a:srgbClr val="A1A1AA"/>
+                </a:solidFill>
+                <a:latin typeface="Arial" pitchFamily="34" charset="0"/>
+                <a:ea typeface="Arial" pitchFamily="34" charset="-122"/>
+                <a:cs typeface="Arial" pitchFamily="34" charset="-120"/>
+              </a:rPr>
+              <a:t>Mobile app (React Native) for iOS and Android</a:t>
+            </a:r>
+            <a:endParaRPr lang="en-US" sz="1400" dirty="0"/>
+          </a:p>
+          <a:p>
+            <a:pPr>
+              <a:lnSpc>
+                <a:spcPct val="120000"/>
+              </a:lnSpc>
+              <a:spcAft>
+                <a:spcPts val="500"/>
+              </a:spcAft>
+            </a:pPr>
+            <a:r>
+              <a:rPr lang="en-US" sz="1400" dirty="0">
+                <a:solidFill>
+                  <a:srgbClr val="A1A1AA"/>
+                </a:solidFill>
+                <a:latin typeface="Arial" pitchFamily="34" charset="0"/>
+                <a:ea typeface="Arial" pitchFamily="34" charset="-122"/>
+                <a:cs typeface="Arial" pitchFamily="34" charset="-120"/>
+              </a:rPr>
+              <a:t>Real-time notifications and chat via WebSockets</a:t>
+            </a:r>
+            <a:endParaRPr lang="en-US" sz="1400" dirty="0"/>
+          </a:p>
+          <a:p>
+            <a:pPr>
+              <a:lnSpc>
+                <a:spcPct val="120000"/>
+              </a:lnSpc>
+              <a:spcAft>
+                <a:spcPts val="500"/>
+              </a:spcAft>
+            </a:pPr>
+            <a:r>
+              <a:rPr lang="en-US" sz="1400" dirty="0">
+                <a:solidFill>
+                  <a:srgbClr val="A1A1AA"/>
+                </a:solidFill>
+                <a:latin typeface="Arial" pitchFamily="34" charset="0"/>
+                <a:ea typeface="Arial" pitchFamily="34" charset="-122"/>
+                <a:cs typeface="Arial" pitchFamily="34" charset="-120"/>
+              </a:rPr>
+              <a:t>Vinyl Buddy v2: improved form factor and enclosure design</a:t>
+            </a:r>
+            <a:endParaRPr lang="en-US" sz="1400" dirty="0"/>
+          </a:p>
+          <a:p>
+            <a:pPr>
+              <a:lnSpc>
+                <a:spcPct val="120000"/>
+              </a:lnSpc>
+              <a:spcAft>
+                <a:spcPts val="500"/>
+              </a:spcAft>
+            </a:pPr>
+            <a:r>
+              <a:rPr lang="en-US" sz="1400" dirty="0">
+                <a:solidFill>
+                  <a:srgbClr val="A1A1AA"/>
+                </a:solidFill>
+                <a:latin typeface="Arial" pitchFamily="34" charset="0"/>
+                <a:ea typeface="Arial" pitchFamily="34" charset="-122"/>
+                <a:cs typeface="Arial" pitchFamily="34" charset="-120"/>
+              </a:rPr>
+              <a:t>Live listening sessions — listen along with friends in real time</a:t>
+            </a:r>
+            <a:endParaRPr lang="en-US" sz="1400" dirty="0"/>
+          </a:p>
+          <a:p>
+            <a:pPr>
+              <a:lnSpc>
+                <a:spcPct val="120000"/>
+              </a:lnSpc>
+              <a:spcAft>
+                <a:spcPts val="500"/>
+              </a:spcAft>
+            </a:pPr>
+            <a:r>
+              <a:rPr lang="en-US" sz="1400" dirty="0">
+                <a:solidFill>
+                  <a:srgbClr val="A1A1AA"/>
+                </a:solidFill>
+                <a:latin typeface="Arial" pitchFamily="34" charset="0"/>
+                <a:ea typeface="Arial" pitchFamily="34" charset="-122"/>
+                <a:cs typeface="Arial" pitchFamily="34" charset="-120"/>
+              </a:rPr>
+              <a:t>International shipping and multi-currency support</a:t>
+            </a:r>
+            <a:endParaRPr lang="en-US" sz="1400" dirty="0"/>
+          </a:p>
+          <a:p>
+            <a:pPr>
+              <a:lnSpc>
+                <a:spcPct val="120000"/>
+              </a:lnSpc>
+              <a:spcAft>
+                <a:spcPts val="500"/>
+              </a:spcAft>
+            </a:pPr>
+            <a:r>
+              <a:rPr lang="en-US" sz="1400" dirty="0">
+                <a:solidFill>
+                  <a:srgbClr val="A1A1AA"/>
+                </a:solidFill>
+                <a:latin typeface="Arial" pitchFamily="34" charset="0"/>
+                <a:ea typeface="Arial" pitchFamily="34" charset="-122"/>
+                <a:cs typeface="Arial" pitchFamily="34" charset="-120"/>
+              </a:rPr>
+              <a:t>Premium subscription tiers for power collectors</a:t>
+            </a:r>
+            <a:endParaRPr lang="en-US" sz="1400" dirty="0"/>
+          </a:p>
+          <a:p>
+            <a:pPr>
+              <a:lnSpc>
+                <a:spcPct val="120000"/>
+              </a:lnSpc>
+              <a:spcAft>
+                <a:spcPts val="500"/>
+              </a:spcAft>
+            </a:pPr>
+            <a:r>
+              <a:rPr lang="en-US" sz="1400" dirty="0">
+                <a:solidFill>
+                  <a:srgbClr val="A1A1AA"/>
+                </a:solidFill>
+                <a:latin typeface="Arial" pitchFamily="34" charset="0"/>
+                <a:ea typeface="Arial" pitchFamily="34" charset="-122"/>
+                <a:cs typeface="Arial" pitchFamily="34" charset="-120"/>
+              </a:rPr>
+              <a:t>Marketplace search ads and promoted listings</a:t>
+            </a:r>
+            <a:endParaRPr lang="en-US" sz="1400" dirty="0"/>
+          </a:p>
+          <a:p>
+            <a:pPr>
+              <a:lnSpc>
+                <a:spcPct val="120000"/>
+              </a:lnSpc>
+              <a:spcAft>
+                <a:spcPts val="500"/>
+              </a:spcAft>
+            </a:pPr>
+            <a:r>
+              <a:rPr lang="en-US" sz="1400" dirty="0">
+                <a:solidFill>
+                  <a:srgbClr val="A1A1AA"/>
+                </a:solidFill>
+                <a:latin typeface="Arial" pitchFamily="34" charset="0"/>
+                <a:ea typeface="Arial" pitchFamily="34" charset="-122"/>
+                <a:cs typeface="Arial" pitchFamily="34" charset="-120"/>
+              </a:rPr>
+              <a:t>Record label partnerships and exclusive drops</a:t>
+            </a:r>
+            <a:endParaRPr lang="en-US" sz="1400" dirty="0"/>
+          </a:p>
+          <a:p>
+            <a:pPr>
+              <a:lnSpc>
+                <a:spcPct val="120000"/>
+              </a:lnSpc>
+              <a:spcAft>
+                <a:spcPts val="500"/>
+              </a:spcAft>
+            </a:pPr>
+            <a:r>
+              <a:rPr lang="en-US" sz="1400" dirty="0">
+                <a:solidFill>
+                  <a:srgbClr val="A1A1AA"/>
+                </a:solidFill>
+                <a:latin typeface="Arial" pitchFamily="34" charset="0"/>
+                <a:ea typeface="Arial" pitchFamily="34" charset="-122"/>
+                <a:cs typeface="Arial" pitchFamily="34" charset="-120"/>
+              </a:rPr>
+              <a:t>Vinyl Buddy retail sales and distribution</a:t>
+            </a:r>
+            <a:endParaRPr lang="en-US" sz="1400" dirty="0"/>
+          </a:p>
+        </p:txBody>
+      </p:sp>
+    </p:spTree>
+  </p:cSld>
+  <p:clrMapOvr>
+    <a:masterClrMapping/>
+  </p:clrMapOvr>
+</p:sld>
+</file>
+
+<file path=ppt/slides/slide41.xml><?xml version="1.0" encoding="utf-8"?>
+<p:sld xmlns:a="http://schemas.openxmlformats.org/drawingml/2006/main" xmlns:r="http://schemas.openxmlformats.org/officeDocument/2006/relationships" xmlns:p="http://schemas.openxmlformats.org/presentationml/2006/main">
+  <p:cSld name="Slide 41">
+    <p:bg>
+      <p:bgPr>
+        <a:solidFill>
+          <a:srgbClr val="0F1117"/>
+        </a:solidFill>
+      </p:bgPr>
+    </p:bg>
+    <p:spTree>
+      <p:nvGrpSpPr>
+        <p:cNvPr id="1" name=""/>
+        <p:cNvGrpSpPr/>
+        <p:nvPr/>
+      </p:nvGrpSpPr>
+      <p:grpSpPr>
+        <a:xfrm>
+          <a:off x="0" y="0"/>
+          <a:ext cx="0" cy="0"/>
+          <a:chOff x="0" y="0"/>
+          <a:chExt cx="0" cy="0"/>
+        </a:xfrm>
+      </p:grpSpPr>
+      <p:sp>
+        <p:nvSpPr>
+          <p:cNvPr id="2" name="Shape 0"/>
+          <p:cNvSpPr/>
+          <p:nvPr/>
+        </p:nvSpPr>
+        <p:spPr>
+          <a:xfrm>
+            <a:off x="0" y="0"/>
+            <a:ext cx="12188952" cy="54864"/>
+          </a:xfrm>
+          <a:prstGeom prst="rect">
+            <a:avLst/>
+          </a:prstGeom>
+          <a:solidFill>
+            <a:srgbClr val="0EA5E9"/>
+          </a:solidFill>
+          <a:ln/>
+        </p:spPr>
+      </p:sp>
+      <p:sp>
+        <p:nvSpPr>
+          <p:cNvPr id="3" name="Text 1"/>
+          <p:cNvSpPr/>
+          <p:nvPr/>
+        </p:nvSpPr>
+        <p:spPr>
+          <a:xfrm>
+            <a:off x="731520" y="1097280"/>
+            <a:ext cx="10515600" cy="1097280"/>
+          </a:xfrm>
+          <a:prstGeom prst="rect">
+            <a:avLst/>
+          </a:prstGeom>
+          <a:noFill/>
+          <a:ln/>
+        </p:spPr>
+        <p:txBody>
+          <a:bodyPr wrap="square" rtlCol="0" anchor="ctr"/>
+          <a:lstStyle/>
+          <a:p>
+            <a:pPr algn="ctr" indent="0" marL="0">
+              <a:buNone/>
+            </a:pPr>
+            <a:r>
+              <a:rPr lang="en-US" sz="5600" b="1" dirty="0">
+                <a:solidFill>
+                  <a:srgbClr val="FFFFFF"/>
+                </a:solidFill>
+                <a:latin typeface="Arial" pitchFamily="34" charset="0"/>
+                <a:ea typeface="Arial" pitchFamily="34" charset="-122"/>
+                <a:cs typeface="Arial" pitchFamily="34" charset="-120"/>
+              </a:rPr>
+              <a:t>GrooveStack</a:t>
+            </a:r>
+            <a:endParaRPr lang="en-US" sz="5600" dirty="0"/>
+          </a:p>
+        </p:txBody>
+      </p:sp>
+      <p:sp>
+        <p:nvSpPr>
+          <p:cNvPr id="4" name="Text 2"/>
+          <p:cNvSpPr/>
+          <p:nvPr/>
+        </p:nvSpPr>
+        <p:spPr>
+          <a:xfrm>
+            <a:off x="731520" y="2103120"/>
+            <a:ext cx="10515600" cy="640080"/>
+          </a:xfrm>
+          <a:prstGeom prst="rect">
+            <a:avLst/>
+          </a:prstGeom>
+          <a:noFill/>
+          <a:ln/>
+        </p:spPr>
+        <p:txBody>
+          <a:bodyPr wrap="square" rtlCol="0" anchor="ctr"/>
+          <a:lstStyle/>
+          <a:p>
+            <a:pPr algn="ctr" indent="0" marL="0">
+              <a:buNone/>
+            </a:pPr>
+            <a:r>
+              <a:rPr lang="en-US" sz="2800" dirty="0">
+                <a:solidFill>
+                  <a:srgbClr val="0EA5E9"/>
+                </a:solidFill>
+                <a:latin typeface="Arial" pitchFamily="34" charset="0"/>
+                <a:ea typeface="Arial" pitchFamily="34" charset="-122"/>
+                <a:cs typeface="Arial" pitchFamily="34" charset="-120"/>
+              </a:rPr>
+              <a:t>+ Vinyl Buddy</a:t>
+            </a:r>
+            <a:endParaRPr lang="en-US" sz="2800" dirty="0"/>
+          </a:p>
+        </p:txBody>
+      </p:sp>
+      <p:sp>
+        <p:nvSpPr>
+          <p:cNvPr id="5" name="Text 3"/>
+          <p:cNvSpPr/>
+          <p:nvPr/>
+        </p:nvSpPr>
+        <p:spPr>
+          <a:xfrm>
+            <a:off x="731520" y="3017520"/>
+            <a:ext cx="10515600" cy="640080"/>
+          </a:xfrm>
+          <a:prstGeom prst="rect">
+            <a:avLst/>
+          </a:prstGeom>
+          <a:noFill/>
+          <a:ln/>
+        </p:spPr>
+        <p:txBody>
+          <a:bodyPr wrap="square" rtlCol="0" anchor="ctr"/>
+          <a:lstStyle/>
+          <a:p>
+            <a:pPr algn="ctr" indent="0" marL="0">
+              <a:buNone/>
+            </a:pPr>
+            <a:r>
+              <a:rPr lang="en-US" sz="2200" dirty="0">
+                <a:solidFill>
+                  <a:srgbClr val="D4D4D8"/>
+                </a:solidFill>
+                <a:latin typeface="Arial" pitchFamily="34" charset="0"/>
+                <a:ea typeface="Arial" pitchFamily="34" charset="-122"/>
+                <a:cs typeface="Arial" pitchFamily="34" charset="-120"/>
+              </a:rPr>
+              <a:t>Where Vinyl Lives</a:t>
+            </a:r>
+            <a:endParaRPr lang="en-US" sz="2200" dirty="0"/>
+          </a:p>
+        </p:txBody>
+      </p:sp>
+      <p:sp>
+        <p:nvSpPr>
+          <p:cNvPr id="6" name="Text 4"/>
+          <p:cNvSpPr/>
+          <p:nvPr/>
+        </p:nvSpPr>
+        <p:spPr>
+          <a:xfrm>
+            <a:off x="731520" y="3931920"/>
+            <a:ext cx="10515600" cy="1371600"/>
+          </a:xfrm>
+          <a:prstGeom prst="rect">
+            <a:avLst/>
+          </a:prstGeom>
+          <a:noFill/>
+          <a:ln/>
+        </p:spPr>
+        <p:txBody>
+          <a:bodyPr wrap="square" rtlCol="0" anchor="ctr"/>
+          <a:lstStyle/>
+          <a:p>
+            <a:pPr algn="ctr" indent="0" marL="0">
+              <a:lnSpc>
+                <a:spcPct val="150000"/>
+              </a:lnSpc>
+              <a:buNone/>
+            </a:pPr>
+            <a:r>
+              <a:rPr lang="en-US" sz="1600" dirty="0">
+                <a:solidFill>
+                  <a:srgbClr val="22C55E"/>
+                </a:solidFill>
+                <a:latin typeface="Arial" pitchFamily="34" charset="0"/>
+                <a:ea typeface="Arial" pitchFamily="34" charset="-122"/>
+                <a:cs typeface="Arial" pitchFamily="34" charset="-120"/>
+              </a:rPr>
+              <a:t>2,000+ improvements  •  290+ API endpoints  •  29 waves</a:t>
+            </a:r>
+            <a:pPr algn="ctr" indent="0" marL="0">
+              <a:lnSpc>
+                <a:spcPct val="150000"/>
+              </a:lnSpc>
+              <a:buNone/>
+            </a:pPr>
+            <a:r>
+              <a:rPr lang="en-US" sz="1600" dirty="0">
+                <a:solidFill>
+                  <a:srgbClr val="000000"/>
+                </a:solidFill>
+                <a:latin typeface="Arial" pitchFamily="34" charset="0"/>
+                <a:ea typeface="Arial" pitchFamily="34" charset="-122"/>
+                <a:cs typeface="Arial" pitchFamily="34" charset="-120"/>
+              </a:rPr>
+              <a:t>
+</a:t>
+            </a:r>
+            <a:pPr algn="ctr" indent="0" marL="0">
+              <a:lnSpc>
+                <a:spcPct val="150000"/>
+              </a:lnSpc>
+              <a:buNone/>
+            </a:pPr>
+            <a:r>
+              <a:rPr lang="en-US" sz="1800" dirty="0">
+                <a:solidFill>
+                  <a:srgbClr val="FFFFFF"/>
+                </a:solidFill>
+                <a:latin typeface="Arial" pitchFamily="34" charset="0"/>
+                <a:ea typeface="Arial" pitchFamily="34" charset="-122"/>
+                <a:cs typeface="Arial" pitchFamily="34" charset="-120"/>
+              </a:rPr>
+              <a:t>groovestack.vercel.app</a:t>
+            </a:r>
+            <a:pPr algn="ctr" indent="0" marL="0">
+              <a:lnSpc>
+                <a:spcPct val="150000"/>
+              </a:lnSpc>
+              <a:buNone/>
+            </a:pPr>
+            <a:r>
+              <a:rPr lang="en-US" sz="1600" dirty="0">
+                <a:solidFill>
+                  <a:srgbClr val="000000"/>
+                </a:solidFill>
+                <a:latin typeface="Arial" pitchFamily="34" charset="0"/>
+                <a:ea typeface="Arial" pitchFamily="34" charset="-122"/>
+                <a:cs typeface="Arial" pitchFamily="34" charset="-120"/>
+              </a:rPr>
+              <a:t>
+</a:t>
+            </a:r>
+            <a:pPr algn="ctr" indent="0" marL="0">
+              <a:lnSpc>
+                <a:spcPct val="150000"/>
+              </a:lnSpc>
+              <a:buNone/>
+            </a:pPr>
+            <a:r>
+              <a:rPr lang="en-US" sz="1600" dirty="0">
+                <a:solidFill>
+                  <a:srgbClr val="A1A1AA"/>
+                </a:solidFill>
+                <a:latin typeface="Arial" pitchFamily="34" charset="0"/>
+                <a:ea typeface="Arial" pitchFamily="34" charset="-122"/>
+                <a:cs typeface="Arial" pitchFamily="34" charset="-120"/>
+              </a:rPr>
+              <a:t>github.com/colelevy08/groovestack</a:t>
+            </a:r>
+            <a:endParaRPr lang="en-US" sz="1600" dirty="0"/>
+          </a:p>
+        </p:txBody>
+      </p:sp>
+      <p:sp>
+        <p:nvSpPr>
+          <p:cNvPr id="7" name="Text 5"/>
+          <p:cNvSpPr/>
+          <p:nvPr/>
+        </p:nvSpPr>
+        <p:spPr>
+          <a:xfrm>
+            <a:off x="731520" y="5303520"/>
+            <a:ext cx="10515600" cy="548640"/>
+          </a:xfrm>
+          <a:prstGeom prst="rect">
+            <a:avLst/>
+          </a:prstGeom>
+          <a:noFill/>
+          <a:ln/>
+        </p:spPr>
+        <p:txBody>
+          <a:bodyPr wrap="square" rtlCol="0" anchor="ctr"/>
+          <a:lstStyle/>
+          <a:p>
+            <a:pPr algn="ctr" indent="0" marL="0">
+              <a:buNone/>
+            </a:pPr>
+            <a:r>
+              <a:rPr lang="en-US" sz="1800" dirty="0">
+                <a:solidFill>
+                  <a:srgbClr val="A1A1AA"/>
+                </a:solidFill>
+                <a:latin typeface="Arial" pitchFamily="34" charset="0"/>
+                <a:ea typeface="Arial" pitchFamily="34" charset="-122"/>
+                <a:cs typeface="Arial" pitchFamily="34" charset="-120"/>
+              </a:rPr>
+              <a:t>Thank you!</a:t>
+            </a:r>
+            <a:endParaRPr lang="en-US" sz="1800" dirty="0"/>
+          </a:p>
+        </p:txBody>
+      </p:sp>
+      <p:sp>
+        <p:nvSpPr>
+          <p:cNvPr id="8" name="Shape 6"/>
+          <p:cNvSpPr/>
+          <p:nvPr/>
+        </p:nvSpPr>
+        <p:spPr>
+          <a:xfrm>
+            <a:off x="0" y="6803136"/>
+            <a:ext cx="12188952" cy="54864"/>
+          </a:xfrm>
+          <a:prstGeom prst="rect">
+            <a:avLst/>
+          </a:prstGeom>
+          <a:solidFill>
+            <a:srgbClr val="0EA5E9"/>
+          </a:solidFill>
+          <a:ln/>
+        </p:spPr>
       </p:sp>
     </p:spTree>
   </p:cSld>

</xml_diff>